<commit_message>
Update model with GSL and other basin's data
</commit_message>
<xml_diff>
--- a/Session Guide/IntroPresentation.pptx
+++ b/Session Guide/IntroPresentation.pptx
@@ -119,22 +119,12 @@
 </p:presentation>
 </file>
 
-<file path=ppt/revisionInfo.xml><?xml version="1.0" encoding="utf-8"?>
-<p1510:revInfo xmlns:a="http://schemas.openxmlformats.org/drawingml/2006/main" xmlns:r="http://schemas.openxmlformats.org/officeDocument/2006/relationships" xmlns:p1510="http://schemas.microsoft.com/office/powerpoint/2015/10/main">
-  <p1510:revLst>
-    <p1510:client id="{690B3A7B-E81C-46E7-8BEC-E514E51C2AA8}" v="1" dt="2026-08-05T22:58:10.210"/>
-    <p1510:client id="{C41AC06A-C952-4FC7-B486-A623EFA36300}" v="6" dt="2026-08-06T17:28:34.917"/>
-    <p1510:client id="{D389C471-0F27-4572-8BC2-E02D89424FF3}" v="21" dt="2026-08-06T18:03:34.597"/>
-  </p1510:revLst>
-</p1510:revInfo>
-</file>
-
 <file path=ppt/changesInfos/changesInfo1.xml><?xml version="1.0" encoding="utf-8"?>
 <pc:chgInfo xmlns:a="http://schemas.openxmlformats.org/drawingml/2006/main" xmlns:r="http://schemas.openxmlformats.org/officeDocument/2006/relationships" xmlns:ac="http://schemas.microsoft.com/office/drawing/2013/main/command" xmlns:pc="http://schemas.microsoft.com/office/powerpoint/2013/main/command">
   <pc:docChgLst>
     <pc:chgData name="Hadia Akbar" userId="19362115565_tp_box_2" providerId="OAuth2" clId="{FF77DECD-7ECC-48F4-BF82-9D4D4E0BE774}"/>
     <pc:docChg chg="undo redo custSel addSld delSld modSld sldOrd delMainMaster">
-      <pc:chgData name="Hadia Akbar" userId="19362115565_tp_box_2" providerId="OAuth2" clId="{FF77DECD-7ECC-48F4-BF82-9D4D4E0BE774}" dt="2026-08-06T18:04:11.900" v="2191" actId="1076"/>
+      <pc:chgData name="Hadia Akbar" userId="19362115565_tp_box_2" providerId="OAuth2" clId="{FF77DECD-7ECC-48F4-BF82-9D4D4E0BE774}" dt="2026-08-14T20:36:10.797" v="2217" actId="1076"/>
       <pc:docMkLst>
         <pc:docMk/>
       </pc:docMkLst>
@@ -158,126 +148,6 @@
             <pc:docMk/>
             <pc:sldMk cId="4246612416" sldId="256"/>
             <ac:spMk id="3" creationId="{AAFA9286-92DA-528E-C4BD-BD456C809191}"/>
-          </ac:spMkLst>
-        </pc:spChg>
-        <pc:spChg chg="add del">
-          <ac:chgData name="Hadia Akbar" userId="19362115565_tp_box_2" providerId="OAuth2" clId="{FF77DECD-7ECC-48F4-BF82-9D4D4E0BE774}" dt="2026-08-06T17:25:35.069" v="1878" actId="26606"/>
-          <ac:spMkLst>
-            <pc:docMk/>
-            <pc:sldMk cId="4246612416" sldId="256"/>
-            <ac:spMk id="7" creationId="{55666830-9A19-4E01-8505-D6C7F9AC5665}"/>
-          </ac:spMkLst>
-        </pc:spChg>
-        <pc:spChg chg="add del">
-          <ac:chgData name="Hadia Akbar" userId="19362115565_tp_box_2" providerId="OAuth2" clId="{FF77DECD-7ECC-48F4-BF82-9D4D4E0BE774}" dt="2026-08-06T17:25:35.069" v="1878" actId="26606"/>
-          <ac:spMkLst>
-            <pc:docMk/>
-            <pc:sldMk cId="4246612416" sldId="256"/>
-            <ac:spMk id="9" creationId="{AE9FC877-7FB6-4D22-9988-35420644E202}"/>
-          </ac:spMkLst>
-        </pc:spChg>
-        <pc:spChg chg="add del">
-          <ac:chgData name="Hadia Akbar" userId="19362115565_tp_box_2" providerId="OAuth2" clId="{FF77DECD-7ECC-48F4-BF82-9D4D4E0BE774}" dt="2026-08-06T17:25:35.069" v="1878" actId="26606"/>
-          <ac:spMkLst>
-            <pc:docMk/>
-            <pc:sldMk cId="4246612416" sldId="256"/>
-            <ac:spMk id="11" creationId="{E41809D1-F12E-46BB-B804-5F209D325E8B}"/>
-          </ac:spMkLst>
-        </pc:spChg>
-        <pc:spChg chg="add del">
-          <ac:chgData name="Hadia Akbar" userId="19362115565_tp_box_2" providerId="OAuth2" clId="{FF77DECD-7ECC-48F4-BF82-9D4D4E0BE774}" dt="2026-08-06T17:25:35.069" v="1878" actId="26606"/>
-          <ac:spMkLst>
-            <pc:docMk/>
-            <pc:sldMk cId="4246612416" sldId="256"/>
-            <ac:spMk id="16" creationId="{AF2F604E-43BE-4DC3-B983-E071523364F8}"/>
-          </ac:spMkLst>
-        </pc:spChg>
-        <pc:spChg chg="add del">
-          <ac:chgData name="Hadia Akbar" userId="19362115565_tp_box_2" providerId="OAuth2" clId="{FF77DECD-7ECC-48F4-BF82-9D4D4E0BE774}" dt="2026-08-06T17:25:52.923" v="1887" actId="26606"/>
-          <ac:spMkLst>
-            <pc:docMk/>
-            <pc:sldMk cId="4246612416" sldId="256"/>
-            <ac:spMk id="23" creationId="{A8384FB5-9ADC-4DDC-881B-597D56F5B15D}"/>
-          </ac:spMkLst>
-        </pc:spChg>
-        <pc:spChg chg="add del">
-          <ac:chgData name="Hadia Akbar" userId="19362115565_tp_box_2" providerId="OAuth2" clId="{FF77DECD-7ECC-48F4-BF82-9D4D4E0BE774}" dt="2026-08-06T17:25:52.923" v="1887" actId="26606"/>
-          <ac:spMkLst>
-            <pc:docMk/>
-            <pc:sldMk cId="4246612416" sldId="256"/>
-            <ac:spMk id="25" creationId="{BC05CA36-AD6A-4ABF-9A05-52E5A143D2BB}"/>
-          </ac:spMkLst>
-        </pc:spChg>
-        <pc:spChg chg="add del">
-          <ac:chgData name="Hadia Akbar" userId="19362115565_tp_box_2" providerId="OAuth2" clId="{FF77DECD-7ECC-48F4-BF82-9D4D4E0BE774}" dt="2026-08-06T17:25:52.923" v="1887" actId="26606"/>
-          <ac:spMkLst>
-            <pc:docMk/>
-            <pc:sldMk cId="4246612416" sldId="256"/>
-            <ac:spMk id="27" creationId="{D4331EE8-85A4-4588-8D9E-70E534D477DB}"/>
-          </ac:spMkLst>
-        </pc:spChg>
-        <pc:spChg chg="add del">
-          <ac:chgData name="Hadia Akbar" userId="19362115565_tp_box_2" providerId="OAuth2" clId="{FF77DECD-7ECC-48F4-BF82-9D4D4E0BE774}" dt="2026-08-06T17:25:52.923" v="1887" actId="26606"/>
-          <ac:spMkLst>
-            <pc:docMk/>
-            <pc:sldMk cId="4246612416" sldId="256"/>
-            <ac:spMk id="29" creationId="{49D6C862-61CC-4B46-8080-96583D653BAB}"/>
-          </ac:spMkLst>
-        </pc:spChg>
-        <pc:spChg chg="add del">
-          <ac:chgData name="Hadia Akbar" userId="19362115565_tp_box_2" providerId="OAuth2" clId="{FF77DECD-7ECC-48F4-BF82-9D4D4E0BE774}" dt="2026-08-06T17:25:52.923" v="1886" actId="26606"/>
-          <ac:spMkLst>
-            <pc:docMk/>
-            <pc:sldMk cId="4246612416" sldId="256"/>
-            <ac:spMk id="31" creationId="{E37EECFC-A684-4391-AE85-4CDAF5565F61}"/>
-          </ac:spMkLst>
-        </pc:spChg>
-        <pc:spChg chg="add del">
-          <ac:chgData name="Hadia Akbar" userId="19362115565_tp_box_2" providerId="OAuth2" clId="{FF77DECD-7ECC-48F4-BF82-9D4D4E0BE774}" dt="2026-08-06T17:25:52.569" v="1884" actId="26606"/>
-          <ac:spMkLst>
-            <pc:docMk/>
-            <pc:sldMk cId="4246612416" sldId="256"/>
-            <ac:spMk id="38" creationId="{C3D487F7-9050-4871-B351-34A72ADB296C}"/>
-          </ac:spMkLst>
-        </pc:spChg>
-        <pc:spChg chg="add del">
-          <ac:chgData name="Hadia Akbar" userId="19362115565_tp_box_2" providerId="OAuth2" clId="{FF77DECD-7ECC-48F4-BF82-9D4D4E0BE774}" dt="2026-08-06T17:25:52.569" v="1884" actId="26606"/>
-          <ac:spMkLst>
-            <pc:docMk/>
-            <pc:sldMk cId="4246612416" sldId="256"/>
-            <ac:spMk id="40" creationId="{F43C27DD-EF6A-4C48-9669-C2970E71A814}"/>
-          </ac:spMkLst>
-        </pc:spChg>
-        <pc:spChg chg="add del">
-          <ac:chgData name="Hadia Akbar" userId="19362115565_tp_box_2" providerId="OAuth2" clId="{FF77DECD-7ECC-48F4-BF82-9D4D4E0BE774}" dt="2026-08-06T17:25:52.569" v="1884" actId="26606"/>
-          <ac:spMkLst>
-            <pc:docMk/>
-            <pc:sldMk cId="4246612416" sldId="256"/>
-            <ac:spMk id="42" creationId="{C84384FE-1C88-4CAA-8FB8-2313A3AE734D}"/>
-          </ac:spMkLst>
-        </pc:spChg>
-        <pc:spChg chg="add del">
-          <ac:chgData name="Hadia Akbar" userId="19362115565_tp_box_2" providerId="OAuth2" clId="{FF77DECD-7ECC-48F4-BF82-9D4D4E0BE774}" dt="2026-08-06T17:25:52.569" v="1884" actId="26606"/>
-          <ac:spMkLst>
-            <pc:docMk/>
-            <pc:sldMk cId="4246612416" sldId="256"/>
-            <ac:spMk id="44" creationId="{87B6A113-58CD-406C-BCE4-6E1F1F2BE696}"/>
-          </ac:spMkLst>
-        </pc:spChg>
-        <pc:spChg chg="add del">
-          <ac:chgData name="Hadia Akbar" userId="19362115565_tp_box_2" providerId="OAuth2" clId="{FF77DECD-7ECC-48F4-BF82-9D4D4E0BE774}" dt="2026-08-06T17:25:52.569" v="1884" actId="26606"/>
-          <ac:spMkLst>
-            <pc:docMk/>
-            <pc:sldMk cId="4246612416" sldId="256"/>
-            <ac:spMk id="46" creationId="{05A1AA86-B7E6-4C02-AA34-F1A25CD4CCBD}"/>
-          </ac:spMkLst>
-        </pc:spChg>
-        <pc:spChg chg="add del">
-          <ac:chgData name="Hadia Akbar" userId="19362115565_tp_box_2" providerId="OAuth2" clId="{FF77DECD-7ECC-48F4-BF82-9D4D4E0BE774}" dt="2026-08-06T17:25:52.923" v="1886" actId="26606"/>
-          <ac:spMkLst>
-            <pc:docMk/>
-            <pc:sldMk cId="4246612416" sldId="256"/>
-            <ac:spMk id="48" creationId="{06DA9DF9-31F7-4056-B42E-878CC92417B8}"/>
           </ac:spMkLst>
         </pc:spChg>
         <pc:spChg chg="add">
@@ -320,66 +190,12 @@
             <ac:spMk id="54" creationId="{E37EECFC-A684-4391-AE85-4CDAF5565F61}"/>
           </ac:spMkLst>
         </pc:spChg>
-        <pc:picChg chg="add del mod ord">
-          <ac:chgData name="Hadia Akbar" userId="19362115565_tp_box_2" providerId="OAuth2" clId="{FF77DECD-7ECC-48F4-BF82-9D4D4E0BE774}" dt="2026-08-06T17:24:46.665" v="1743" actId="478"/>
-          <ac:picMkLst>
-            <pc:docMk/>
-            <pc:sldMk cId="4246612416" sldId="256"/>
-            <ac:picMk id="5" creationId="{04C88557-323E-8174-ED33-F9A1E595A5E0}"/>
-          </ac:picMkLst>
-        </pc:picChg>
         <pc:picChg chg="add mod">
           <ac:chgData name="Hadia Akbar" userId="19362115565_tp_box_2" providerId="OAuth2" clId="{FF77DECD-7ECC-48F4-BF82-9D4D4E0BE774}" dt="2026-08-06T17:25:52.923" v="1886" actId="26606"/>
           <ac:picMkLst>
             <pc:docMk/>
             <pc:sldMk cId="4246612416" sldId="256"/>
             <ac:picMk id="6" creationId="{DB227495-A140-F9B9-9EB3-2A6E168FED00}"/>
-          </ac:picMkLst>
-        </pc:picChg>
-      </pc:sldChg>
-      <pc:sldChg chg="addSp delSp modSp add del mod">
-        <pc:chgData name="Hadia Akbar" userId="19362115565_tp_box_2" providerId="OAuth2" clId="{FF77DECD-7ECC-48F4-BF82-9D4D4E0BE774}" dt="2026-08-06T18:03:26.490" v="2170" actId="47"/>
-        <pc:sldMkLst>
-          <pc:docMk/>
-          <pc:sldMk cId="235461169" sldId="257"/>
-        </pc:sldMkLst>
-        <pc:graphicFrameChg chg="mod">
-          <ac:chgData name="Hadia Akbar" userId="19362115565_tp_box_2" providerId="OAuth2" clId="{FF77DECD-7ECC-48F4-BF82-9D4D4E0BE774}" dt="2026-08-06T17:53:47.053" v="2062"/>
-          <ac:graphicFrameMkLst>
-            <pc:docMk/>
-            <pc:sldMk cId="235461169" sldId="257"/>
-            <ac:graphicFrameMk id="6" creationId="{C011B49A-A7CA-8A64-8EE8-705D843C87C8}"/>
-          </ac:graphicFrameMkLst>
-        </pc:graphicFrameChg>
-        <pc:picChg chg="add del">
-          <ac:chgData name="Hadia Akbar" userId="19362115565_tp_box_2" providerId="OAuth2" clId="{FF77DECD-7ECC-48F4-BF82-9D4D4E0BE774}" dt="2026-08-06T17:53:37.069" v="2061" actId="478"/>
-          <ac:picMkLst>
-            <pc:docMk/>
-            <pc:sldMk cId="235461169" sldId="257"/>
-            <ac:picMk id="4" creationId="{DE05265B-DD07-4A86-3EF2-01605D6C02D4}"/>
-          </ac:picMkLst>
-        </pc:picChg>
-        <pc:picChg chg="add del">
-          <ac:chgData name="Hadia Akbar" userId="19362115565_tp_box_2" providerId="OAuth2" clId="{FF77DECD-7ECC-48F4-BF82-9D4D4E0BE774}" dt="2026-08-06T17:53:36.846" v="2060" actId="478"/>
-          <ac:picMkLst>
-            <pc:docMk/>
-            <pc:sldMk cId="235461169" sldId="257"/>
-            <ac:picMk id="10" creationId="{66E918FE-E0FB-7551-5100-FF83D57E226D}"/>
-          </ac:picMkLst>
-        </pc:picChg>
-      </pc:sldChg>
-      <pc:sldChg chg="addSp delSp modSp new del mod ord setBg">
-        <pc:chgData name="Hadia Akbar" userId="19362115565_tp_box_2" providerId="OAuth2" clId="{FF77DECD-7ECC-48F4-BF82-9D4D4E0BE774}" dt="2026-08-06T17:52:28.573" v="2045" actId="47"/>
-        <pc:sldMkLst>
-          <pc:docMk/>
-          <pc:sldMk cId="890402765" sldId="257"/>
-        </pc:sldMkLst>
-        <pc:picChg chg="add mod">
-          <ac:chgData name="Hadia Akbar" userId="19362115565_tp_box_2" providerId="OAuth2" clId="{FF77DECD-7ECC-48F4-BF82-9D4D4E0BE774}" dt="2026-08-05T22:58:40.700" v="1715" actId="14100"/>
-          <ac:picMkLst>
-            <pc:docMk/>
-            <pc:sldMk cId="890402765" sldId="257"/>
-            <ac:picMk id="6" creationId="{5F862F3C-E790-A522-6942-17FB31B7AAC9}"/>
           </ac:picMkLst>
         </pc:picChg>
       </pc:sldChg>
@@ -413,14 +229,6 @@
             <ac:graphicFrameMk id="4" creationId="{D3FC7B2A-B870-FA58-8FAD-CE5871DD6A60}"/>
           </ac:graphicFrameMkLst>
         </pc:graphicFrameChg>
-        <pc:picChg chg="add del">
-          <ac:chgData name="Hadia Akbar" userId="19362115565_tp_box_2" providerId="OAuth2" clId="{FF77DECD-7ECC-48F4-BF82-9D4D4E0BE774}" dt="2026-08-06T17:53:03.779" v="2047" actId="22"/>
-          <ac:picMkLst>
-            <pc:docMk/>
-            <pc:sldMk cId="3397881947" sldId="258"/>
-            <ac:picMk id="6" creationId="{0BD05A0F-E136-6927-2665-F65D0A5FD35B}"/>
-          </ac:picMkLst>
-        </pc:picChg>
       </pc:sldChg>
       <pc:sldChg chg="addSp delSp modSp new mod ord setBg addAnim delAnim delDesignElem">
         <pc:chgData name="Hadia Akbar" userId="19362115565_tp_box_2" providerId="OAuth2" clId="{FF77DECD-7ECC-48F4-BF82-9D4D4E0BE774}" dt="2026-08-06T17:43:26.877" v="2042"/>
@@ -450,14 +258,6 @@
             <pc:docMk/>
             <pc:sldMk cId="1480586688" sldId="260"/>
             <ac:picMk id="18" creationId="{E9E2FD9A-CEC4-149A-7AA0-B9A9435CC662}"/>
-          </ac:picMkLst>
-        </pc:picChg>
-        <pc:picChg chg="add del mod">
-          <ac:chgData name="Hadia Akbar" userId="19362115565_tp_box_2" providerId="OAuth2" clId="{FF77DECD-7ECC-48F4-BF82-9D4D4E0BE774}" dt="2026-08-06T17:22:57.696" v="1725" actId="478"/>
-          <ac:picMkLst>
-            <pc:docMk/>
-            <pc:sldMk cId="1480586688" sldId="260"/>
-            <ac:picMk id="25" creationId="{AF508137-52D0-BAA5-C5E1-222AC5704542}"/>
           </ac:picMkLst>
         </pc:picChg>
       </pc:sldChg>
@@ -509,7 +309,7 @@
         </pc:graphicFrameChg>
       </pc:sldChg>
       <pc:sldChg chg="addSp delSp modSp new mod">
-        <pc:chgData name="Hadia Akbar" userId="19362115565_tp_box_2" providerId="OAuth2" clId="{FF77DECD-7ECC-48F4-BF82-9D4D4E0BE774}" dt="2026-08-06T18:04:11.900" v="2191" actId="1076"/>
+        <pc:chgData name="Hadia Akbar" userId="19362115565_tp_box_2" providerId="OAuth2" clId="{FF77DECD-7ECC-48F4-BF82-9D4D4E0BE774}" dt="2026-08-14T20:36:10.797" v="2217" actId="1076"/>
         <pc:sldMkLst>
           <pc:docMk/>
           <pc:sldMk cId="3049088380" sldId="263"/>
@@ -522,166 +322,31 @@
             <ac:spMk id="2" creationId="{677397B9-32DC-1DA8-48FB-77181BAFA5D8}"/>
           </ac:spMkLst>
         </pc:spChg>
-        <pc:spChg chg="del">
-          <ac:chgData name="Hadia Akbar" userId="19362115565_tp_box_2" providerId="OAuth2" clId="{FF77DECD-7ECC-48F4-BF82-9D4D4E0BE774}" dt="2026-08-06T17:59:03.295" v="2157" actId="22"/>
+        <pc:spChg chg="add mod">
+          <ac:chgData name="Hadia Akbar" userId="19362115565_tp_box_2" providerId="OAuth2" clId="{FF77DECD-7ECC-48F4-BF82-9D4D4E0BE774}" dt="2026-08-14T20:35:38.352" v="2204" actId="14100"/>
           <ac:spMkLst>
             <pc:docMk/>
             <pc:sldMk cId="3049088380" sldId="263"/>
-            <ac:spMk id="3" creationId="{FFE6C4C1-8FDB-0727-F9F3-1462F2116C93}"/>
+            <ac:spMk id="3" creationId="{64416FE0-0F99-AABE-B94A-DFB9232898A5}"/>
           </ac:spMkLst>
         </pc:spChg>
-        <pc:spChg chg="add del mod">
-          <ac:chgData name="Hadia Akbar" userId="19362115565_tp_box_2" providerId="OAuth2" clId="{FF77DECD-7ECC-48F4-BF82-9D4D4E0BE774}" dt="2026-08-06T18:00:19.214" v="2165" actId="478"/>
+        <pc:spChg chg="add mod">
+          <ac:chgData name="Hadia Akbar" userId="19362115565_tp_box_2" providerId="OAuth2" clId="{FF77DECD-7ECC-48F4-BF82-9D4D4E0BE774}" dt="2026-08-14T20:36:10.797" v="2217" actId="1076"/>
           <ac:spMkLst>
             <pc:docMk/>
             <pc:sldMk cId="3049088380" sldId="263"/>
-            <ac:spMk id="7" creationId="{BA761D6F-50C2-58CD-4665-5B1AC974E50C}"/>
+            <ac:spMk id="5" creationId="{058C039E-4B72-D823-6332-3B3D9121B1D9}"/>
           </ac:spMkLst>
         </pc:spChg>
-        <pc:picChg chg="add del mod">
-          <ac:chgData name="Hadia Akbar" userId="19362115565_tp_box_2" providerId="OAuth2" clId="{FF77DECD-7ECC-48F4-BF82-9D4D4E0BE774}" dt="2026-08-05T01:52:09.334" v="1489" actId="478"/>
-          <ac:picMkLst>
-            <pc:docMk/>
-            <pc:sldMk cId="3049088380" sldId="263"/>
-            <ac:picMk id="5" creationId="{2DCF294D-696E-B3E7-B4DB-73824B2BC177}"/>
-          </ac:picMkLst>
-        </pc:picChg>
-        <pc:picChg chg="add del mod ord">
-          <ac:chgData name="Hadia Akbar" userId="19362115565_tp_box_2" providerId="OAuth2" clId="{FF77DECD-7ECC-48F4-BF82-9D4D4E0BE774}" dt="2026-08-06T17:59:58.011" v="2161" actId="478"/>
-          <ac:picMkLst>
-            <pc:docMk/>
-            <pc:sldMk cId="3049088380" sldId="263"/>
-            <ac:picMk id="5" creationId="{B07AB3D5-5574-B36A-BB19-BD3B5431A5C2}"/>
-          </ac:picMkLst>
-        </pc:picChg>
-        <pc:picChg chg="add del mod">
-          <ac:chgData name="Hadia Akbar" userId="19362115565_tp_box_2" providerId="OAuth2" clId="{FF77DECD-7ECC-48F4-BF82-9D4D4E0BE774}" dt="2026-08-05T01:56:48.616" v="1504" actId="478"/>
-          <ac:picMkLst>
-            <pc:docMk/>
-            <pc:sldMk cId="3049088380" sldId="263"/>
-            <ac:picMk id="7" creationId="{966DD079-845D-F6BA-0776-163B243F519A}"/>
-          </ac:picMkLst>
-        </pc:picChg>
         <pc:picChg chg="add mod">
-          <ac:chgData name="Hadia Akbar" userId="19362115565_tp_box_2" providerId="OAuth2" clId="{FF77DECD-7ECC-48F4-BF82-9D4D4E0BE774}" dt="2026-08-06T18:04:11.900" v="2191" actId="1076"/>
+          <ac:chgData name="Hadia Akbar" userId="19362115565_tp_box_2" providerId="OAuth2" clId="{FF77DECD-7ECC-48F4-BF82-9D4D4E0BE774}" dt="2026-08-14T20:35:55.355" v="2212" actId="1076"/>
           <ac:picMkLst>
             <pc:docMk/>
             <pc:sldMk cId="3049088380" sldId="263"/>
             <ac:picMk id="9" creationId="{504CD099-FD1D-A9E1-17F7-A5EC85BB4181}"/>
           </ac:picMkLst>
         </pc:picChg>
-        <pc:picChg chg="add del">
-          <ac:chgData name="Hadia Akbar" userId="19362115565_tp_box_2" providerId="OAuth2" clId="{FF77DECD-7ECC-48F4-BF82-9D4D4E0BE774}" dt="2026-08-05T01:56:46.597" v="1503" actId="478"/>
-          <ac:picMkLst>
-            <pc:docMk/>
-            <pc:sldMk cId="3049088380" sldId="263"/>
-            <ac:picMk id="9" creationId="{65C44170-AD83-CE40-01F4-39C7DBBA4A43}"/>
-          </ac:picMkLst>
-        </pc:picChg>
-        <pc:picChg chg="add del mod">
-          <ac:chgData name="Hadia Akbar" userId="19362115565_tp_box_2" providerId="OAuth2" clId="{FF77DECD-7ECC-48F4-BF82-9D4D4E0BE774}" dt="2026-08-06T18:00:23.512" v="2166" actId="478"/>
-          <ac:picMkLst>
-            <pc:docMk/>
-            <pc:sldMk cId="3049088380" sldId="263"/>
-            <ac:picMk id="11" creationId="{C917D0C1-D200-6845-C03F-81BCEF6EA8D6}"/>
-          </ac:picMkLst>
-        </pc:picChg>
       </pc:sldChg>
-      <pc:sldMasterChg chg="del delSldLayout">
-        <pc:chgData name="Hadia Akbar" userId="19362115565_tp_box_2" providerId="OAuth2" clId="{FF77DECD-7ECC-48F4-BF82-9D4D4E0BE774}" dt="2026-08-06T18:03:26.490" v="2170" actId="47"/>
-        <pc:sldMasterMkLst>
-          <pc:docMk/>
-          <pc:sldMasterMk cId="1811082288" sldId="2147483660"/>
-        </pc:sldMasterMkLst>
-        <pc:sldLayoutChg chg="del">
-          <pc:chgData name="Hadia Akbar" userId="19362115565_tp_box_2" providerId="OAuth2" clId="{FF77DECD-7ECC-48F4-BF82-9D4D4E0BE774}" dt="2026-08-06T18:03:26.490" v="2170" actId="47"/>
-          <pc:sldLayoutMkLst>
-            <pc:docMk/>
-            <pc:sldMasterMk cId="1811082288" sldId="2147483660"/>
-            <pc:sldLayoutMk cId="858527832" sldId="2147483661"/>
-          </pc:sldLayoutMkLst>
-        </pc:sldLayoutChg>
-        <pc:sldLayoutChg chg="del">
-          <pc:chgData name="Hadia Akbar" userId="19362115565_tp_box_2" providerId="OAuth2" clId="{FF77DECD-7ECC-48F4-BF82-9D4D4E0BE774}" dt="2026-08-06T18:03:26.490" v="2170" actId="47"/>
-          <pc:sldLayoutMkLst>
-            <pc:docMk/>
-            <pc:sldMasterMk cId="1811082288" sldId="2147483660"/>
-            <pc:sldLayoutMk cId="3388879508" sldId="2147483662"/>
-          </pc:sldLayoutMkLst>
-        </pc:sldLayoutChg>
-        <pc:sldLayoutChg chg="del">
-          <pc:chgData name="Hadia Akbar" userId="19362115565_tp_box_2" providerId="OAuth2" clId="{FF77DECD-7ECC-48F4-BF82-9D4D4E0BE774}" dt="2026-08-06T18:03:26.490" v="2170" actId="47"/>
-          <pc:sldLayoutMkLst>
-            <pc:docMk/>
-            <pc:sldMasterMk cId="1811082288" sldId="2147483660"/>
-            <pc:sldLayoutMk cId="592097471" sldId="2147483663"/>
-          </pc:sldLayoutMkLst>
-        </pc:sldLayoutChg>
-        <pc:sldLayoutChg chg="del">
-          <pc:chgData name="Hadia Akbar" userId="19362115565_tp_box_2" providerId="OAuth2" clId="{FF77DECD-7ECC-48F4-BF82-9D4D4E0BE774}" dt="2026-08-06T18:03:26.490" v="2170" actId="47"/>
-          <pc:sldLayoutMkLst>
-            <pc:docMk/>
-            <pc:sldMasterMk cId="1811082288" sldId="2147483660"/>
-            <pc:sldLayoutMk cId="2487724214" sldId="2147483664"/>
-          </pc:sldLayoutMkLst>
-        </pc:sldLayoutChg>
-        <pc:sldLayoutChg chg="del">
-          <pc:chgData name="Hadia Akbar" userId="19362115565_tp_box_2" providerId="OAuth2" clId="{FF77DECD-7ECC-48F4-BF82-9D4D4E0BE774}" dt="2026-08-06T18:03:26.490" v="2170" actId="47"/>
-          <pc:sldLayoutMkLst>
-            <pc:docMk/>
-            <pc:sldMasterMk cId="1811082288" sldId="2147483660"/>
-            <pc:sldLayoutMk cId="3101536712" sldId="2147483665"/>
-          </pc:sldLayoutMkLst>
-        </pc:sldLayoutChg>
-        <pc:sldLayoutChg chg="del">
-          <pc:chgData name="Hadia Akbar" userId="19362115565_tp_box_2" providerId="OAuth2" clId="{FF77DECD-7ECC-48F4-BF82-9D4D4E0BE774}" dt="2026-08-06T18:03:26.490" v="2170" actId="47"/>
-          <pc:sldLayoutMkLst>
-            <pc:docMk/>
-            <pc:sldMasterMk cId="1811082288" sldId="2147483660"/>
-            <pc:sldLayoutMk cId="83738167" sldId="2147483666"/>
-          </pc:sldLayoutMkLst>
-        </pc:sldLayoutChg>
-        <pc:sldLayoutChg chg="del">
-          <pc:chgData name="Hadia Akbar" userId="19362115565_tp_box_2" providerId="OAuth2" clId="{FF77DECD-7ECC-48F4-BF82-9D4D4E0BE774}" dt="2026-08-06T18:03:26.490" v="2170" actId="47"/>
-          <pc:sldLayoutMkLst>
-            <pc:docMk/>
-            <pc:sldMasterMk cId="1811082288" sldId="2147483660"/>
-            <pc:sldLayoutMk cId="3714056911" sldId="2147483667"/>
-          </pc:sldLayoutMkLst>
-        </pc:sldLayoutChg>
-        <pc:sldLayoutChg chg="del">
-          <pc:chgData name="Hadia Akbar" userId="19362115565_tp_box_2" providerId="OAuth2" clId="{FF77DECD-7ECC-48F4-BF82-9D4D4E0BE774}" dt="2026-08-06T18:03:26.490" v="2170" actId="47"/>
-          <pc:sldLayoutMkLst>
-            <pc:docMk/>
-            <pc:sldMasterMk cId="1811082288" sldId="2147483660"/>
-            <pc:sldLayoutMk cId="4157770685" sldId="2147483668"/>
-          </pc:sldLayoutMkLst>
-        </pc:sldLayoutChg>
-        <pc:sldLayoutChg chg="del">
-          <pc:chgData name="Hadia Akbar" userId="19362115565_tp_box_2" providerId="OAuth2" clId="{FF77DECD-7ECC-48F4-BF82-9D4D4E0BE774}" dt="2026-08-06T18:03:26.490" v="2170" actId="47"/>
-          <pc:sldLayoutMkLst>
-            <pc:docMk/>
-            <pc:sldMasterMk cId="1811082288" sldId="2147483660"/>
-            <pc:sldLayoutMk cId="468236508" sldId="2147483669"/>
-          </pc:sldLayoutMkLst>
-        </pc:sldLayoutChg>
-        <pc:sldLayoutChg chg="del">
-          <pc:chgData name="Hadia Akbar" userId="19362115565_tp_box_2" providerId="OAuth2" clId="{FF77DECD-7ECC-48F4-BF82-9D4D4E0BE774}" dt="2026-08-06T18:03:26.490" v="2170" actId="47"/>
-          <pc:sldLayoutMkLst>
-            <pc:docMk/>
-            <pc:sldMasterMk cId="1811082288" sldId="2147483660"/>
-            <pc:sldLayoutMk cId="3331122569" sldId="2147483670"/>
-          </pc:sldLayoutMkLst>
-        </pc:sldLayoutChg>
-        <pc:sldLayoutChg chg="del">
-          <pc:chgData name="Hadia Akbar" userId="19362115565_tp_box_2" providerId="OAuth2" clId="{FF77DECD-7ECC-48F4-BF82-9D4D4E0BE774}" dt="2026-08-06T18:03:26.490" v="2170" actId="47"/>
-          <pc:sldLayoutMkLst>
-            <pc:docMk/>
-            <pc:sldMasterMk cId="1811082288" sldId="2147483660"/>
-            <pc:sldLayoutMk cId="3414839042" sldId="2147483671"/>
-          </pc:sldLayoutMkLst>
-        </pc:sldLayoutChg>
-      </pc:sldMasterChg>
     </pc:docChg>
   </pc:docChgLst>
 </pc:chgInfo>
@@ -8291,7 +7956,7 @@
           <a:p>
             <a:fld id="{23F5F05C-4C32-48D7-B5AA-52291E739591}" type="datetimeFigureOut">
               <a:rPr lang="en-US" smtClean="0"/>
-              <a:t>8/6/2026</a:t>
+              <a:t>8/14/2026</a:t>
             </a:fld>
             <a:endParaRPr lang="en-US"/>
           </a:p>
@@ -8933,7 +8598,7 @@
           <a:p>
             <a:fld id="{5518E2ED-ACDD-48AE-BEAE-F9B835E4D922}" type="datetimeFigureOut">
               <a:rPr lang="en-US" smtClean="0"/>
-              <a:t>8/6/2026</a:t>
+              <a:t>8/14/2026</a:t>
             </a:fld>
             <a:endParaRPr lang="en-US"/>
           </a:p>
@@ -9131,7 +8796,7 @@
           <a:p>
             <a:fld id="{5518E2ED-ACDD-48AE-BEAE-F9B835E4D922}" type="datetimeFigureOut">
               <a:rPr lang="en-US" smtClean="0"/>
-              <a:t>8/6/2026</a:t>
+              <a:t>8/14/2026</a:t>
             </a:fld>
             <a:endParaRPr lang="en-US"/>
           </a:p>
@@ -9339,7 +9004,7 @@
           <a:p>
             <a:fld id="{5518E2ED-ACDD-48AE-BEAE-F9B835E4D922}" type="datetimeFigureOut">
               <a:rPr lang="en-US" smtClean="0"/>
-              <a:t>8/6/2026</a:t>
+              <a:t>8/14/2026</a:t>
             </a:fld>
             <a:endParaRPr lang="en-US"/>
           </a:p>
@@ -9537,7 +9202,7 @@
           <a:p>
             <a:fld id="{5518E2ED-ACDD-48AE-BEAE-F9B835E4D922}" type="datetimeFigureOut">
               <a:rPr lang="en-US" smtClean="0"/>
-              <a:t>8/6/2026</a:t>
+              <a:t>8/14/2026</a:t>
             </a:fld>
             <a:endParaRPr lang="en-US"/>
           </a:p>
@@ -9812,7 +9477,7 @@
           <a:p>
             <a:fld id="{5518E2ED-ACDD-48AE-BEAE-F9B835E4D922}" type="datetimeFigureOut">
               <a:rPr lang="en-US" smtClean="0"/>
-              <a:t>8/6/2026</a:t>
+              <a:t>8/14/2026</a:t>
             </a:fld>
             <a:endParaRPr lang="en-US"/>
           </a:p>
@@ -10077,7 +9742,7 @@
           <a:p>
             <a:fld id="{5518E2ED-ACDD-48AE-BEAE-F9B835E4D922}" type="datetimeFigureOut">
               <a:rPr lang="en-US" smtClean="0"/>
-              <a:t>8/6/2026</a:t>
+              <a:t>8/14/2026</a:t>
             </a:fld>
             <a:endParaRPr lang="en-US"/>
           </a:p>
@@ -10489,7 +10154,7 @@
           <a:p>
             <a:fld id="{5518E2ED-ACDD-48AE-BEAE-F9B835E4D922}" type="datetimeFigureOut">
               <a:rPr lang="en-US" smtClean="0"/>
-              <a:t>8/6/2026</a:t>
+              <a:t>8/14/2026</a:t>
             </a:fld>
             <a:endParaRPr lang="en-US"/>
           </a:p>
@@ -10630,7 +10295,7 @@
           <a:p>
             <a:fld id="{5518E2ED-ACDD-48AE-BEAE-F9B835E4D922}" type="datetimeFigureOut">
               <a:rPr lang="en-US" smtClean="0"/>
-              <a:t>8/6/2026</a:t>
+              <a:t>8/14/2026</a:t>
             </a:fld>
             <a:endParaRPr lang="en-US"/>
           </a:p>
@@ -10743,7 +10408,7 @@
           <a:p>
             <a:fld id="{5518E2ED-ACDD-48AE-BEAE-F9B835E4D922}" type="datetimeFigureOut">
               <a:rPr lang="en-US" smtClean="0"/>
-              <a:t>8/6/2026</a:t>
+              <a:t>8/14/2026</a:t>
             </a:fld>
             <a:endParaRPr lang="en-US"/>
           </a:p>
@@ -11054,7 +10719,7 @@
           <a:p>
             <a:fld id="{5518E2ED-ACDD-48AE-BEAE-F9B835E4D922}" type="datetimeFigureOut">
               <a:rPr lang="en-US" smtClean="0"/>
-              <a:t>8/6/2026</a:t>
+              <a:t>8/14/2026</a:t>
             </a:fld>
             <a:endParaRPr lang="en-US"/>
           </a:p>
@@ -11342,7 +11007,7 @@
           <a:p>
             <a:fld id="{5518E2ED-ACDD-48AE-BEAE-F9B835E4D922}" type="datetimeFigureOut">
               <a:rPr lang="en-US" smtClean="0"/>
-              <a:t>8/6/2026</a:t>
+              <a:t>8/14/2026</a:t>
             </a:fld>
             <a:endParaRPr lang="en-US"/>
           </a:p>
@@ -11583,7 +11248,7 @@
           <a:p>
             <a:fld id="{5518E2ED-ACDD-48AE-BEAE-F9B835E4D922}" type="datetimeFigureOut">
               <a:rPr lang="en-US" smtClean="0"/>
-              <a:t>8/6/2026</a:t>
+              <a:t>8/14/2026</a:t>
             </a:fld>
             <a:endParaRPr lang="en-US"/>
           </a:p>
@@ -13499,7 +13164,7 @@
         </p:blipFill>
         <p:spPr>
           <a:xfrm>
-            <a:off x="1609164" y="1690688"/>
+            <a:off x="3007658" y="2183747"/>
             <a:ext cx="5627184" cy="2853220"/>
           </a:xfrm>
           <a:prstGeom prst="rect">
@@ -13507,6 +13172,110 @@
           </a:prstGeom>
         </p:spPr>
       </p:pic>
+      <p:sp>
+        <p:nvSpPr>
+          <p:cNvPr id="3" name="Rectangle 2">
+            <a:extLst>
+              <a:ext uri="{FF2B5EF4-FFF2-40B4-BE49-F238E27FC236}">
+                <a16:creationId xmlns:a16="http://schemas.microsoft.com/office/drawing/2014/main" id="{64416FE0-0F99-AABE-B94A-DFB9232898A5}"/>
+              </a:ext>
+            </a:extLst>
+          </p:cNvPr>
+          <p:cNvSpPr/>
+          <p:nvPr/>
+        </p:nvSpPr>
+        <p:spPr>
+          <a:xfrm>
+            <a:off x="5593976" y="2581837"/>
+            <a:ext cx="2922495" cy="430304"/>
+          </a:xfrm>
+          <a:prstGeom prst="rect">
+            <a:avLst/>
+          </a:prstGeom>
+          <a:noFill/>
+          <a:ln w="57150">
+            <a:solidFill>
+              <a:srgbClr val="FF0000"/>
+            </a:solidFill>
+          </a:ln>
+        </p:spPr>
+        <p:style>
+          <a:lnRef idx="2">
+            <a:schemeClr val="accent1">
+              <a:shade val="15000"/>
+            </a:schemeClr>
+          </a:lnRef>
+          <a:fillRef idx="1">
+            <a:schemeClr val="accent1"/>
+          </a:fillRef>
+          <a:effectRef idx="0">
+            <a:schemeClr val="accent1"/>
+          </a:effectRef>
+          <a:fontRef idx="minor">
+            <a:schemeClr val="lt1"/>
+          </a:fontRef>
+        </p:style>
+        <p:txBody>
+          <a:bodyPr rtlCol="0" anchor="ctr"/>
+          <a:lstStyle/>
+          <a:p>
+            <a:pPr algn="ctr"/>
+            <a:endParaRPr lang="en-US"/>
+          </a:p>
+        </p:txBody>
+      </p:sp>
+      <p:sp>
+        <p:nvSpPr>
+          <p:cNvPr id="5" name="Rectangle 4">
+            <a:extLst>
+              <a:ext uri="{FF2B5EF4-FFF2-40B4-BE49-F238E27FC236}">
+                <a16:creationId xmlns:a16="http://schemas.microsoft.com/office/drawing/2014/main" id="{058C039E-4B72-D823-6332-3B3D9121B1D9}"/>
+              </a:ext>
+            </a:extLst>
+          </p:cNvPr>
+          <p:cNvSpPr/>
+          <p:nvPr/>
+        </p:nvSpPr>
+        <p:spPr>
+          <a:xfrm>
+            <a:off x="5746376" y="2734237"/>
+            <a:ext cx="2922495" cy="430304"/>
+          </a:xfrm>
+          <a:prstGeom prst="rect">
+            <a:avLst/>
+          </a:prstGeom>
+          <a:noFill/>
+          <a:ln w="57150">
+            <a:solidFill>
+              <a:srgbClr val="FF0000"/>
+            </a:solidFill>
+          </a:ln>
+        </p:spPr>
+        <p:style>
+          <a:lnRef idx="2">
+            <a:schemeClr val="accent1">
+              <a:shade val="15000"/>
+            </a:schemeClr>
+          </a:lnRef>
+          <a:fillRef idx="1">
+            <a:schemeClr val="accent1"/>
+          </a:fillRef>
+          <a:effectRef idx="0">
+            <a:schemeClr val="accent1"/>
+          </a:effectRef>
+          <a:fontRef idx="minor">
+            <a:schemeClr val="lt1"/>
+          </a:fontRef>
+        </p:style>
+        <p:txBody>
+          <a:bodyPr rtlCol="0" anchor="ctr"/>
+          <a:lstStyle/>
+          <a:p>
+            <a:pPr algn="ctr"/>
+            <a:endParaRPr lang="en-US"/>
+          </a:p>
+        </p:txBody>
+      </p:sp>
     </p:spTree>
     <p:extLst>
       <p:ext uri="{BB962C8B-B14F-4D97-AF65-F5344CB8AC3E}">

</xml_diff>

<commit_message>
Update the GSL related data in the files
</commit_message>
<xml_diff>
--- a/Session Guide/IntroPresentation.pptx
+++ b/Session Guide/IntroPresentation.pptx
@@ -119,12 +119,20 @@
 </p:presentation>
 </file>
 
+<file path=ppt/revisionInfo.xml><?xml version="1.0" encoding="utf-8"?>
+<p1510:revInfo xmlns:a="http://schemas.openxmlformats.org/drawingml/2006/main" xmlns:r="http://schemas.openxmlformats.org/officeDocument/2006/relationships" xmlns:p1510="http://schemas.microsoft.com/office/powerpoint/2015/10/main">
+  <p1510:revLst>
+    <p1510:client id="{E9465A14-C3E6-48BF-871C-4371200A0961}" v="1" dt="2026-08-20T17:58:03.596"/>
+  </p1510:revLst>
+</p1510:revInfo>
+</file>
+
 <file path=ppt/changesInfos/changesInfo1.xml><?xml version="1.0" encoding="utf-8"?>
 <pc:chgInfo xmlns:a="http://schemas.openxmlformats.org/drawingml/2006/main" xmlns:r="http://schemas.openxmlformats.org/officeDocument/2006/relationships" xmlns:ac="http://schemas.microsoft.com/office/drawing/2013/main/command" xmlns:pc="http://schemas.microsoft.com/office/powerpoint/2013/main/command">
   <pc:docChgLst>
     <pc:chgData name="Hadia Akbar" userId="19362115565_tp_box_2" providerId="OAuth2" clId="{FF77DECD-7ECC-48F4-BF82-9D4D4E0BE774}"/>
     <pc:docChg chg="undo redo custSel addSld delSld modSld sldOrd delMainMaster">
-      <pc:chgData name="Hadia Akbar" userId="19362115565_tp_box_2" providerId="OAuth2" clId="{FF77DECD-7ECC-48F4-BF82-9D4D4E0BE774}" dt="2026-08-18T17:59:39.214" v="2218" actId="1076"/>
+      <pc:chgData name="Hadia Akbar" userId="19362115565_tp_box_2" providerId="OAuth2" clId="{FF77DECD-7ECC-48F4-BF82-9D4D4E0BE774}" dt="2026-08-20T17:58:03.596" v="2221" actId="113"/>
       <pc:docMkLst>
         <pc:docMk/>
       </pc:docMkLst>
@@ -231,7 +239,7 @@
         </pc:graphicFrameChg>
       </pc:sldChg>
       <pc:sldChg chg="addSp delSp modSp new mod ord setBg addAnim delAnim delDesignElem">
-        <pc:chgData name="Hadia Akbar" userId="19362115565_tp_box_2" providerId="OAuth2" clId="{FF77DECD-7ECC-48F4-BF82-9D4D4E0BE774}" dt="2026-08-06T17:43:26.877" v="2042"/>
+        <pc:chgData name="Hadia Akbar" userId="19362115565_tp_box_2" providerId="OAuth2" clId="{FF77DECD-7ECC-48F4-BF82-9D4D4E0BE774}" dt="2026-08-20T17:57:45.780" v="2220" actId="1076"/>
         <pc:sldMkLst>
           <pc:docMk/>
           <pc:sldMk cId="1480586688" sldId="260"/>
@@ -245,7 +253,7 @@
           </ac:spMkLst>
         </pc:spChg>
         <pc:picChg chg="add mod">
-          <ac:chgData name="Hadia Akbar" userId="19362115565_tp_box_2" providerId="OAuth2" clId="{FF77DECD-7ECC-48F4-BF82-9D4D4E0BE774}" dt="2026-08-06T17:23:43.157" v="1739" actId="1076"/>
+          <ac:chgData name="Hadia Akbar" userId="19362115565_tp_box_2" providerId="OAuth2" clId="{FF77DECD-7ECC-48F4-BF82-9D4D4E0BE774}" dt="2026-08-20T17:57:45.780" v="2220" actId="1076"/>
           <ac:picMkLst>
             <pc:docMk/>
             <pc:sldMk cId="1480586688" sldId="260"/>
@@ -262,7 +270,7 @@
         </pc:picChg>
       </pc:sldChg>
       <pc:sldChg chg="addSp delSp modSp new mod ord setBg">
-        <pc:chgData name="Hadia Akbar" userId="19362115565_tp_box_2" providerId="OAuth2" clId="{FF77DECD-7ECC-48F4-BF82-9D4D4E0BE774}" dt="2026-08-06T17:41:03.925" v="2039" actId="20577"/>
+        <pc:chgData name="Hadia Akbar" userId="19362115565_tp_box_2" providerId="OAuth2" clId="{FF77DECD-7ECC-48F4-BF82-9D4D4E0BE774}" dt="2026-08-20T17:58:03.596" v="2221" actId="113"/>
         <pc:sldMkLst>
           <pc:docMk/>
           <pc:sldMk cId="1860897597" sldId="262"/>
@@ -300,7 +308,7 @@
           </ac:spMkLst>
         </pc:spChg>
         <pc:graphicFrameChg chg="add mod modGraphic">
-          <ac:chgData name="Hadia Akbar" userId="19362115565_tp_box_2" providerId="OAuth2" clId="{FF77DECD-7ECC-48F4-BF82-9D4D4E0BE774}" dt="2026-08-06T17:41:03.925" v="2039" actId="20577"/>
+          <ac:chgData name="Hadia Akbar" userId="19362115565_tp_box_2" providerId="OAuth2" clId="{FF77DECD-7ECC-48F4-BF82-9D4D4E0BE774}" dt="2026-08-20T17:58:03.596" v="2221" actId="113"/>
           <ac:graphicFrameMkLst>
             <pc:docMk/>
             <pc:sldMk cId="1860897597" sldId="262"/>
@@ -353,7 +361,7 @@
 </file>
 
 <file path=ppt/diagrams/colors1.xml><?xml version="1.0" encoding="utf-8"?>
-<dgm:colorsDef xmlns:dgm="http://schemas.openxmlformats.org/drawingml/2006/diagram" xmlns:a="http://schemas.openxmlformats.org/drawingml/2006/main" uniqueId="urn:microsoft.com/office/officeart/2005/8/colors/accent1_2">
+<dgm:colorsDef xmlns:dgm="http://schemas.openxmlformats.org/drawingml/2006/diagram" xmlns:a="http://schemas.openxmlformats.org/drawingml/2006/main" uniqueId="urn:microsoft.com/office/officeart/2005/8/colors/accent1_2#1">
   <dgm:title val=""/>
   <dgm:desc val=""/>
   <dgm:catLst>
@@ -1100,7 +1108,7 @@
 </file>
 
 <file path=ppt/diagrams/colors2.xml><?xml version="1.0" encoding="utf-8"?>
-<dgm:colorsDef xmlns:dgm="http://schemas.openxmlformats.org/drawingml/2006/diagram" xmlns:a="http://schemas.openxmlformats.org/drawingml/2006/main" uniqueId="urn:microsoft.com/office/officeart/2005/8/colors/accent1_2">
+<dgm:colorsDef xmlns:dgm="http://schemas.openxmlformats.org/drawingml/2006/diagram" xmlns:a="http://schemas.openxmlformats.org/drawingml/2006/main" uniqueId="urn:microsoft.com/office/officeart/2005/8/colors/accent1_2#2">
   <dgm:title val=""/>
   <dgm:desc val=""/>
   <dgm:catLst>
@@ -1850,7 +1858,7 @@
 <dgm:dataModel xmlns:dgm="http://schemas.openxmlformats.org/drawingml/2006/diagram" xmlns:a="http://schemas.openxmlformats.org/drawingml/2006/main">
   <dgm:ptLst>
     <dgm:pt modelId="{332819EA-3386-42B9-9077-01AD17EAD6CF}" type="doc">
-      <dgm:prSet loTypeId="urn:microsoft.com/office/officeart/2008/layout/LinedList" loCatId="list" qsTypeId="urn:microsoft.com/office/officeart/2005/8/quickstyle/simple1" qsCatId="simple" csTypeId="urn:microsoft.com/office/officeart/2005/8/colors/accent1_2" csCatId="accent1" phldr="1"/>
+      <dgm:prSet loTypeId="urn:microsoft.com/office/officeart/2008/layout/LinedList" loCatId="list" qsTypeId="urn:microsoft.com/office/officeart/2005/8/quickstyle/simple1#1" qsCatId="simple" csTypeId="urn:microsoft.com/office/officeart/2005/8/colors/accent1_2#1" csCatId="accent1" phldr="1"/>
       <dgm:spPr/>
       <dgm:t>
         <a:bodyPr/>
@@ -1977,7 +1985,15 @@
         <a:p>
           <a:r>
             <a:rPr lang="en-US" dirty="0"/>
-            <a:t>Users can consume, conserve or sell water.</a:t>
+            <a:t>Users can </a:t>
+          </a:r>
+          <a:r>
+            <a:rPr lang="en-US" b="1" dirty="0"/>
+            <a:t>consume, conserve or sell </a:t>
+          </a:r>
+          <a:r>
+            <a:rPr lang="en-US" dirty="0"/>
+            <a:t>water.</a:t>
           </a:r>
         </a:p>
       </dgm:t>
@@ -2236,7 +2252,7 @@
 <dgm:dataModel xmlns:dgm="http://schemas.openxmlformats.org/drawingml/2006/diagram" xmlns:a="http://schemas.openxmlformats.org/drawingml/2006/main">
   <dgm:ptLst>
     <dgm:pt modelId="{99D1A08B-05C7-4294-99DD-7BE56AF469A8}" type="doc">
-      <dgm:prSet loTypeId="urn:microsoft.com/office/officeart/2005/8/layout/hProcess4" loCatId="process" qsTypeId="urn:microsoft.com/office/officeart/2005/8/quickstyle/simple1" qsCatId="simple" csTypeId="urn:microsoft.com/office/officeart/2005/8/colors/accent1_2" csCatId="accent1" phldr="1"/>
+      <dgm:prSet loTypeId="urn:microsoft.com/office/officeart/2005/8/layout/hProcess4" loCatId="process" qsTypeId="urn:microsoft.com/office/officeart/2005/8/quickstyle/simple1#2" qsCatId="simple" csTypeId="urn:microsoft.com/office/officeart/2005/8/colors/accent1_2#2" csCatId="accent1" phldr="1"/>
       <dgm:spPr/>
       <dgm:t>
         <a:bodyPr/>
@@ -3570,7 +3586,15 @@
           </a:pPr>
           <a:r>
             <a:rPr lang="en-US" sz="3100" kern="1200" dirty="0"/>
-            <a:t>Users can consume, conserve or sell water.</a:t>
+            <a:t>Users can </a:t>
+          </a:r>
+          <a:r>
+            <a:rPr lang="en-US" sz="3100" b="1" kern="1200" dirty="0"/>
+            <a:t>consume, conserve or sell </a:t>
+          </a:r>
+          <a:r>
+            <a:rPr lang="en-US" sz="3100" kern="1200" dirty="0"/>
+            <a:t>water.</a:t>
           </a:r>
         </a:p>
       </dsp:txBody>
@@ -5807,7 +5831,7 @@
 </file>
 
 <file path=ppt/diagrams/quickStyle1.xml><?xml version="1.0" encoding="utf-8"?>
-<dgm:styleDef xmlns:dgm="http://schemas.openxmlformats.org/drawingml/2006/diagram" xmlns:a="http://schemas.openxmlformats.org/drawingml/2006/main" uniqueId="urn:microsoft.com/office/officeart/2005/8/quickstyle/simple1">
+<dgm:styleDef xmlns:dgm="http://schemas.openxmlformats.org/drawingml/2006/diagram" xmlns:a="http://schemas.openxmlformats.org/drawingml/2006/main" uniqueId="urn:microsoft.com/office/officeart/2005/8/quickstyle/simple1#1">
   <dgm:title val=""/>
   <dgm:desc val=""/>
   <dgm:catLst>
@@ -6841,7 +6865,7 @@
 </file>
 
 <file path=ppt/diagrams/quickStyle2.xml><?xml version="1.0" encoding="utf-8"?>
-<dgm:styleDef xmlns:dgm="http://schemas.openxmlformats.org/drawingml/2006/diagram" xmlns:a="http://schemas.openxmlformats.org/drawingml/2006/main" uniqueId="urn:microsoft.com/office/officeart/2005/8/quickstyle/simple1">
+<dgm:styleDef xmlns:dgm="http://schemas.openxmlformats.org/drawingml/2006/diagram" xmlns:a="http://schemas.openxmlformats.org/drawingml/2006/main" uniqueId="urn:microsoft.com/office/officeart/2005/8/quickstyle/simple1#2">
   <dgm:title val=""/>
   <dgm:desc val=""/>
   <dgm:catLst>
@@ -7956,7 +7980,7 @@
           <a:p>
             <a:fld id="{23F5F05C-4C32-48D7-B5AA-52291E739591}" type="datetimeFigureOut">
               <a:rPr lang="en-US" smtClean="0"/>
-              <a:t>8/18/2026</a:t>
+              <a:t>8/20/2026</a:t>
             </a:fld>
             <a:endParaRPr lang="en-US"/>
           </a:p>
@@ -8598,7 +8622,7 @@
           <a:p>
             <a:fld id="{5518E2ED-ACDD-48AE-BEAE-F9B835E4D922}" type="datetimeFigureOut">
               <a:rPr lang="en-US" smtClean="0"/>
-              <a:t>8/18/2026</a:t>
+              <a:t>8/20/2026</a:t>
             </a:fld>
             <a:endParaRPr lang="en-US"/>
           </a:p>
@@ -8796,7 +8820,7 @@
           <a:p>
             <a:fld id="{5518E2ED-ACDD-48AE-BEAE-F9B835E4D922}" type="datetimeFigureOut">
               <a:rPr lang="en-US" smtClean="0"/>
-              <a:t>8/18/2026</a:t>
+              <a:t>8/20/2026</a:t>
             </a:fld>
             <a:endParaRPr lang="en-US"/>
           </a:p>
@@ -9004,7 +9028,7 @@
           <a:p>
             <a:fld id="{5518E2ED-ACDD-48AE-BEAE-F9B835E4D922}" type="datetimeFigureOut">
               <a:rPr lang="en-US" smtClean="0"/>
-              <a:t>8/18/2026</a:t>
+              <a:t>8/20/2026</a:t>
             </a:fld>
             <a:endParaRPr lang="en-US"/>
           </a:p>
@@ -9202,7 +9226,7 @@
           <a:p>
             <a:fld id="{5518E2ED-ACDD-48AE-BEAE-F9B835E4D922}" type="datetimeFigureOut">
               <a:rPr lang="en-US" smtClean="0"/>
-              <a:t>8/18/2026</a:t>
+              <a:t>8/20/2026</a:t>
             </a:fld>
             <a:endParaRPr lang="en-US"/>
           </a:p>
@@ -9477,7 +9501,7 @@
           <a:p>
             <a:fld id="{5518E2ED-ACDD-48AE-BEAE-F9B835E4D922}" type="datetimeFigureOut">
               <a:rPr lang="en-US" smtClean="0"/>
-              <a:t>8/18/2026</a:t>
+              <a:t>8/20/2026</a:t>
             </a:fld>
             <a:endParaRPr lang="en-US"/>
           </a:p>
@@ -9742,7 +9766,7 @@
           <a:p>
             <a:fld id="{5518E2ED-ACDD-48AE-BEAE-F9B835E4D922}" type="datetimeFigureOut">
               <a:rPr lang="en-US" smtClean="0"/>
-              <a:t>8/18/2026</a:t>
+              <a:t>8/20/2026</a:t>
             </a:fld>
             <a:endParaRPr lang="en-US"/>
           </a:p>
@@ -10154,7 +10178,7 @@
           <a:p>
             <a:fld id="{5518E2ED-ACDD-48AE-BEAE-F9B835E4D922}" type="datetimeFigureOut">
               <a:rPr lang="en-US" smtClean="0"/>
-              <a:t>8/18/2026</a:t>
+              <a:t>8/20/2026</a:t>
             </a:fld>
             <a:endParaRPr lang="en-US"/>
           </a:p>
@@ -10295,7 +10319,7 @@
           <a:p>
             <a:fld id="{5518E2ED-ACDD-48AE-BEAE-F9B835E4D922}" type="datetimeFigureOut">
               <a:rPr lang="en-US" smtClean="0"/>
-              <a:t>8/18/2026</a:t>
+              <a:t>8/20/2026</a:t>
             </a:fld>
             <a:endParaRPr lang="en-US"/>
           </a:p>
@@ -10408,7 +10432,7 @@
           <a:p>
             <a:fld id="{5518E2ED-ACDD-48AE-BEAE-F9B835E4D922}" type="datetimeFigureOut">
               <a:rPr lang="en-US" smtClean="0"/>
-              <a:t>8/18/2026</a:t>
+              <a:t>8/20/2026</a:t>
             </a:fld>
             <a:endParaRPr lang="en-US"/>
           </a:p>
@@ -10719,7 +10743,7 @@
           <a:p>
             <a:fld id="{5518E2ED-ACDD-48AE-BEAE-F9B835E4D922}" type="datetimeFigureOut">
               <a:rPr lang="en-US" smtClean="0"/>
-              <a:t>8/18/2026</a:t>
+              <a:t>8/20/2026</a:t>
             </a:fld>
             <a:endParaRPr lang="en-US"/>
           </a:p>
@@ -11007,7 +11031,7 @@
           <a:p>
             <a:fld id="{5518E2ED-ACDD-48AE-BEAE-F9B835E4D922}" type="datetimeFigureOut">
               <a:rPr lang="en-US" smtClean="0"/>
-              <a:t>8/18/2026</a:t>
+              <a:t>8/20/2026</a:t>
             </a:fld>
             <a:endParaRPr lang="en-US"/>
           </a:p>
@@ -11248,7 +11272,7 @@
           <a:p>
             <a:fld id="{5518E2ED-ACDD-48AE-BEAE-F9B835E4D922}" type="datetimeFigureOut">
               <a:rPr lang="en-US" smtClean="0"/>
-              <a:t>8/18/2026</a:t>
+              <a:t>8/20/2026</a:t>
             </a:fld>
             <a:endParaRPr lang="en-US"/>
           </a:p>
@@ -12397,8 +12421,8 @@
         </p:blipFill>
         <p:spPr>
           <a:xfrm>
-            <a:off x="1628773" y="2581835"/>
-            <a:ext cx="3145591" cy="3745496"/>
+            <a:off x="1873623" y="2791492"/>
+            <a:ext cx="2775235" cy="3304508"/>
           </a:xfrm>
           <a:prstGeom prst="rect">
             <a:avLst/>
@@ -12726,7 +12750,7 @@
             <p:ph idx="1"/>
             <p:extLst>
               <p:ext uri="{D42A27DB-BD31-4B8C-83A1-F6EECF244321}">
-                <p14:modId xmlns:p14="http://schemas.microsoft.com/office/powerpoint/2010/main" val="2612573471"/>
+                <p14:modId xmlns:p14="http://schemas.microsoft.com/office/powerpoint/2010/main" val="398504165"/>
               </p:ext>
             </p:extLst>
           </p:nvPr>

</xml_diff>

<commit_message>
Add GSL related slides
</commit_message>
<xml_diff>
--- a/Session Guide/IntroPresentation.pptx
+++ b/Session Guide/IntroPresentation.pptx
@@ -9,8 +9,8 @@
   </p:notesMasterIdLst>
   <p:sldIdLst>
     <p:sldId id="256" r:id="rId2"/>
-    <p:sldId id="260" r:id="rId3"/>
-    <p:sldId id="262" r:id="rId4"/>
+    <p:sldId id="264" r:id="rId3"/>
+    <p:sldId id="265" r:id="rId4"/>
     <p:sldId id="258" r:id="rId5"/>
     <p:sldId id="263" r:id="rId6"/>
   </p:sldIdLst>
@@ -122,7 +122,7 @@
 <file path=ppt/revisionInfo.xml><?xml version="1.0" encoding="utf-8"?>
 <p1510:revInfo xmlns:a="http://schemas.openxmlformats.org/drawingml/2006/main" xmlns:r="http://schemas.openxmlformats.org/officeDocument/2006/relationships" xmlns:p1510="http://schemas.microsoft.com/office/powerpoint/2015/10/main">
   <p1510:revLst>
-    <p1510:client id="{E9465A14-C3E6-48BF-871C-4371200A0961}" v="1" dt="2026-08-20T17:58:03.596"/>
+    <p1510:client id="{0FA96045-9951-4B0B-BD62-76A4AB30A5F9}" v="10" dt="2026-08-24T23:19:05.277"/>
   </p1510:revLst>
 </p1510:revInfo>
 </file>
@@ -132,18 +132,18 @@
   <pc:docChgLst>
     <pc:chgData name="Hadia Akbar" userId="19362115565_tp_box_2" providerId="OAuth2" clId="{FF77DECD-7ECC-48F4-BF82-9D4D4E0BE774}"/>
     <pc:docChg chg="undo redo custSel addSld delSld modSld sldOrd delMainMaster">
-      <pc:chgData name="Hadia Akbar" userId="19362115565_tp_box_2" providerId="OAuth2" clId="{FF77DECD-7ECC-48F4-BF82-9D4D4E0BE774}" dt="2026-08-20T17:58:03.596" v="2221" actId="113"/>
+      <pc:chgData name="Hadia Akbar" userId="19362115565_tp_box_2" providerId="OAuth2" clId="{FF77DECD-7ECC-48F4-BF82-9D4D4E0BE774}" dt="2026-08-24T23:19:05.277" v="2465" actId="12090"/>
       <pc:docMkLst>
         <pc:docMk/>
       </pc:docMkLst>
       <pc:sldChg chg="addSp delSp modSp new mod setBg addAnim modAnim delDesignElem">
-        <pc:chgData name="Hadia Akbar" userId="19362115565_tp_box_2" providerId="OAuth2" clId="{FF77DECD-7ECC-48F4-BF82-9D4D4E0BE774}" dt="2026-08-06T17:26:02.707" v="1889" actId="1076"/>
+        <pc:chgData name="Hadia Akbar" userId="19362115565_tp_box_2" providerId="OAuth2" clId="{FF77DECD-7ECC-48F4-BF82-9D4D4E0BE774}" dt="2026-08-24T23:07:31.014" v="2247" actId="1076"/>
         <pc:sldMkLst>
           <pc:docMk/>
           <pc:sldMk cId="4246612416" sldId="256"/>
         </pc:sldMkLst>
         <pc:spChg chg="mod">
-          <ac:chgData name="Hadia Akbar" userId="19362115565_tp_box_2" providerId="OAuth2" clId="{FF77DECD-7ECC-48F4-BF82-9D4D4E0BE774}" dt="2026-08-06T17:26:02.707" v="1889" actId="1076"/>
+          <ac:chgData name="Hadia Akbar" userId="19362115565_tp_box_2" providerId="OAuth2" clId="{FF77DECD-7ECC-48F4-BF82-9D4D4E0BE774}" dt="2026-08-24T23:06:46.212" v="2225" actId="1076"/>
           <ac:spMkLst>
             <pc:docMk/>
             <pc:sldMk cId="4246612416" sldId="256"/>
@@ -151,7 +151,7 @@
           </ac:spMkLst>
         </pc:spChg>
         <pc:spChg chg="mod">
-          <ac:chgData name="Hadia Akbar" userId="19362115565_tp_box_2" providerId="OAuth2" clId="{FF77DECD-7ECC-48F4-BF82-9D4D4E0BE774}" dt="2026-08-06T17:25:52.923" v="1887" actId="26606"/>
+          <ac:chgData name="Hadia Akbar" userId="19362115565_tp_box_2" providerId="OAuth2" clId="{FF77DECD-7ECC-48F4-BF82-9D4D4E0BE774}" dt="2026-08-24T23:07:31.014" v="2247" actId="1076"/>
           <ac:spMkLst>
             <pc:docMk/>
             <pc:sldMk cId="4246612416" sldId="256"/>
@@ -199,7 +199,15 @@
           </ac:spMkLst>
         </pc:spChg>
         <pc:picChg chg="add mod">
-          <ac:chgData name="Hadia Akbar" userId="19362115565_tp_box_2" providerId="OAuth2" clId="{FF77DECD-7ECC-48F4-BF82-9D4D4E0BE774}" dt="2026-08-06T17:25:52.923" v="1886" actId="26606"/>
+          <ac:chgData name="Hadia Akbar" userId="19362115565_tp_box_2" providerId="OAuth2" clId="{FF77DECD-7ECC-48F4-BF82-9D4D4E0BE774}" dt="2026-08-24T23:07:15.259" v="2240" actId="1076"/>
+          <ac:picMkLst>
+            <pc:docMk/>
+            <pc:sldMk cId="4246612416" sldId="256"/>
+            <ac:picMk id="5" creationId="{013E8E12-46D6-55E9-31F9-2CCFEDCB82BF}"/>
+          </ac:picMkLst>
+        </pc:picChg>
+        <pc:picChg chg="add mod">
+          <ac:chgData name="Hadia Akbar" userId="19362115565_tp_box_2" providerId="OAuth2" clId="{FF77DECD-7ECC-48F4-BF82-9D4D4E0BE774}" dt="2026-08-24T23:07:28.480" v="2246" actId="14100"/>
           <ac:picMkLst>
             <pc:docMk/>
             <pc:sldMk cId="4246612416" sldId="256"/>
@@ -208,7 +216,7 @@
         </pc:picChg>
       </pc:sldChg>
       <pc:sldChg chg="addSp delSp modSp add mod">
-        <pc:chgData name="Hadia Akbar" userId="19362115565_tp_box_2" providerId="OAuth2" clId="{FF77DECD-7ECC-48F4-BF82-9D4D4E0BE774}" dt="2026-08-06T18:03:40.726" v="2190" actId="20577"/>
+        <pc:chgData name="Hadia Akbar" userId="19362115565_tp_box_2" providerId="OAuth2" clId="{FF77DECD-7ECC-48F4-BF82-9D4D4E0BE774}" dt="2026-08-24T23:19:05.277" v="2465" actId="12090"/>
         <pc:sldMkLst>
           <pc:docMk/>
           <pc:sldMk cId="3397881947" sldId="258"/>
@@ -222,7 +230,7 @@
           </ac:spMkLst>
         </pc:spChg>
         <pc:graphicFrameChg chg="mod modGraphic">
-          <ac:chgData name="Hadia Akbar" userId="19362115565_tp_box_2" providerId="OAuth2" clId="{FF77DECD-7ECC-48F4-BF82-9D4D4E0BE774}" dt="2026-08-06T18:03:40.726" v="2190" actId="20577"/>
+          <ac:chgData name="Hadia Akbar" userId="19362115565_tp_box_2" providerId="OAuth2" clId="{FF77DECD-7ECC-48F4-BF82-9D4D4E0BE774}" dt="2026-08-24T23:19:05.277" v="2465" actId="12090"/>
           <ac:graphicFrameMkLst>
             <pc:docMk/>
             <pc:sldMk cId="3397881947" sldId="258"/>
@@ -238,22 +246,14 @@
           </ac:graphicFrameMkLst>
         </pc:graphicFrameChg>
       </pc:sldChg>
-      <pc:sldChg chg="addSp delSp modSp new mod ord setBg addAnim delAnim delDesignElem">
-        <pc:chgData name="Hadia Akbar" userId="19362115565_tp_box_2" providerId="OAuth2" clId="{FF77DECD-7ECC-48F4-BF82-9D4D4E0BE774}" dt="2026-08-20T17:57:45.780" v="2220" actId="1076"/>
+      <pc:sldChg chg="addSp delSp modSp new del mod ord setBg addAnim delAnim delDesignElem">
+        <pc:chgData name="Hadia Akbar" userId="19362115565_tp_box_2" providerId="OAuth2" clId="{FF77DECD-7ECC-48F4-BF82-9D4D4E0BE774}" dt="2026-08-24T23:07:33.993" v="2248" actId="47"/>
         <pc:sldMkLst>
           <pc:docMk/>
           <pc:sldMk cId="1480586688" sldId="260"/>
         </pc:sldMkLst>
-        <pc:spChg chg="mod ord">
-          <ac:chgData name="Hadia Akbar" userId="19362115565_tp_box_2" providerId="OAuth2" clId="{FF77DECD-7ECC-48F4-BF82-9D4D4E0BE774}" dt="2026-08-06T17:23:17.051" v="1732" actId="1076"/>
-          <ac:spMkLst>
-            <pc:docMk/>
-            <pc:sldMk cId="1480586688" sldId="260"/>
-            <ac:spMk id="2" creationId="{81F1C4B3-9A9B-ACA7-FD33-EA866B5A34CE}"/>
-          </ac:spMkLst>
-        </pc:spChg>
         <pc:picChg chg="add mod">
-          <ac:chgData name="Hadia Akbar" userId="19362115565_tp_box_2" providerId="OAuth2" clId="{FF77DECD-7ECC-48F4-BF82-9D4D4E0BE774}" dt="2026-08-20T17:57:45.780" v="2220" actId="1076"/>
+          <ac:chgData name="Hadia Akbar" userId="19362115565_tp_box_2" providerId="OAuth2" clId="{FF77DECD-7ECC-48F4-BF82-9D4D4E0BE774}" dt="2026-08-24T23:06:30.886" v="2222" actId="1076"/>
           <ac:picMkLst>
             <pc:docMk/>
             <pc:sldMk cId="1480586688" sldId="260"/>
@@ -261,7 +261,7 @@
           </ac:picMkLst>
         </pc:picChg>
         <pc:picChg chg="add del mod">
-          <ac:chgData name="Hadia Akbar" userId="19362115565_tp_box_2" providerId="OAuth2" clId="{FF77DECD-7ECC-48F4-BF82-9D4D4E0BE774}" dt="2026-08-06T17:23:56.705" v="1742" actId="1076"/>
+          <ac:chgData name="Hadia Akbar" userId="19362115565_tp_box_2" providerId="OAuth2" clId="{FF77DECD-7ECC-48F4-BF82-9D4D4E0BE774}" dt="2026-08-24T23:06:40.223" v="2223" actId="21"/>
           <ac:picMkLst>
             <pc:docMk/>
             <pc:sldMk cId="1480586688" sldId="260"/>
@@ -269,46 +269,22 @@
           </ac:picMkLst>
         </pc:picChg>
       </pc:sldChg>
-      <pc:sldChg chg="addSp delSp modSp new mod ord setBg">
-        <pc:chgData name="Hadia Akbar" userId="19362115565_tp_box_2" providerId="OAuth2" clId="{FF77DECD-7ECC-48F4-BF82-9D4D4E0BE774}" dt="2026-08-20T17:58:03.596" v="2221" actId="113"/>
+      <pc:sldChg chg="addSp delSp modSp new add del mod ord setBg">
+        <pc:chgData name="Hadia Akbar" userId="19362115565_tp_box_2" providerId="OAuth2" clId="{FF77DECD-7ECC-48F4-BF82-9D4D4E0BE774}" dt="2026-08-24T23:18:46.875" v="2461" actId="47"/>
         <pc:sldMkLst>
           <pc:docMk/>
           <pc:sldMk cId="1860897597" sldId="262"/>
         </pc:sldMkLst>
-        <pc:spChg chg="mod">
-          <ac:chgData name="Hadia Akbar" userId="19362115565_tp_box_2" providerId="OAuth2" clId="{FF77DECD-7ECC-48F4-BF82-9D4D4E0BE774}" dt="2026-08-04T18:03:23.726" v="1483" actId="14100"/>
+        <pc:spChg chg="add mod">
+          <ac:chgData name="Hadia Akbar" userId="19362115565_tp_box_2" providerId="OAuth2" clId="{FF77DECD-7ECC-48F4-BF82-9D4D4E0BE774}" dt="2026-08-24T23:16:46.312" v="2443" actId="21"/>
           <ac:spMkLst>
             <pc:docMk/>
             <pc:sldMk cId="1860897597" sldId="262"/>
-            <ac:spMk id="2" creationId="{82135AE4-D2DF-F18B-908D-5801E8171ADD}"/>
+            <ac:spMk id="4" creationId="{4A9A44C1-D39F-B823-D8E3-FD6C1DF75D70}"/>
           </ac:spMkLst>
         </pc:spChg>
-        <pc:spChg chg="add">
-          <ac:chgData name="Hadia Akbar" userId="19362115565_tp_box_2" providerId="OAuth2" clId="{FF77DECD-7ECC-48F4-BF82-9D4D4E0BE774}" dt="2026-08-04T05:58:01.491" v="1464" actId="26606"/>
-          <ac:spMkLst>
-            <pc:docMk/>
-            <pc:sldMk cId="1860897597" sldId="262"/>
-            <ac:spMk id="21" creationId="{44AD29B6-BF3B-4407-9E75-52DF8E3B29F1}"/>
-          </ac:spMkLst>
-        </pc:spChg>
-        <pc:spChg chg="add">
-          <ac:chgData name="Hadia Akbar" userId="19362115565_tp_box_2" providerId="OAuth2" clId="{FF77DECD-7ECC-48F4-BF82-9D4D4E0BE774}" dt="2026-08-04T05:58:01.491" v="1464" actId="26606"/>
-          <ac:spMkLst>
-            <pc:docMk/>
-            <pc:sldMk cId="1860897597" sldId="262"/>
-            <ac:spMk id="23" creationId="{55F8BA08-3E38-4B70-B93A-74F08E092206}"/>
-          </ac:spMkLst>
-        </pc:spChg>
-        <pc:spChg chg="add">
-          <ac:chgData name="Hadia Akbar" userId="19362115565_tp_box_2" providerId="OAuth2" clId="{FF77DECD-7ECC-48F4-BF82-9D4D4E0BE774}" dt="2026-08-04T05:58:01.491" v="1464" actId="26606"/>
-          <ac:spMkLst>
-            <pc:docMk/>
-            <pc:sldMk cId="1860897597" sldId="262"/>
-            <ac:spMk id="25" creationId="{357F1B33-79AB-4A71-8CEC-4546D709B8C8}"/>
-          </ac:spMkLst>
-        </pc:spChg>
-        <pc:graphicFrameChg chg="add mod modGraphic">
-          <ac:chgData name="Hadia Akbar" userId="19362115565_tp_box_2" providerId="OAuth2" clId="{FF77DECD-7ECC-48F4-BF82-9D4D4E0BE774}" dt="2026-08-20T17:58:03.596" v="2221" actId="113"/>
+        <pc:graphicFrameChg chg="add del mod modGraphic">
+          <ac:chgData name="Hadia Akbar" userId="19362115565_tp_box_2" providerId="OAuth2" clId="{FF77DECD-7ECC-48F4-BF82-9D4D4E0BE774}" dt="2026-08-24T23:16:46.312" v="2443" actId="21"/>
           <ac:graphicFrameMkLst>
             <pc:docMk/>
             <pc:sldMk cId="1860897597" sldId="262"/>
@@ -317,7 +293,7 @@
         </pc:graphicFrameChg>
       </pc:sldChg>
       <pc:sldChg chg="addSp delSp modSp new mod">
-        <pc:chgData name="Hadia Akbar" userId="19362115565_tp_box_2" providerId="OAuth2" clId="{FF77DECD-7ECC-48F4-BF82-9D4D4E0BE774}" dt="2026-08-18T17:59:39.214" v="2218" actId="1076"/>
+        <pc:chgData name="Hadia Akbar" userId="19362115565_tp_box_2" providerId="OAuth2" clId="{FF77DECD-7ECC-48F4-BF82-9D4D4E0BE774}" dt="2026-08-24T23:18:45.216" v="2459" actId="1076"/>
         <pc:sldMkLst>
           <pc:docMk/>
           <pc:sldMk cId="3049088380" sldId="263"/>
@@ -346,12 +322,98 @@
             <ac:spMk id="5" creationId="{058C039E-4B72-D823-6332-3B3D9121B1D9}"/>
           </ac:spMkLst>
         </pc:spChg>
-        <pc:picChg chg="add mod">
-          <ac:chgData name="Hadia Akbar" userId="19362115565_tp_box_2" providerId="OAuth2" clId="{FF77DECD-7ECC-48F4-BF82-9D4D4E0BE774}" dt="2026-08-14T20:35:55.355" v="2212" actId="1076"/>
+        <pc:picChg chg="add del mod">
+          <ac:chgData name="Hadia Akbar" userId="19362115565_tp_box_2" providerId="OAuth2" clId="{FF77DECD-7ECC-48F4-BF82-9D4D4E0BE774}" dt="2026-08-24T23:18:45.216" v="2459" actId="1076"/>
           <ac:picMkLst>
             <pc:docMk/>
             <pc:sldMk cId="3049088380" sldId="263"/>
             <ac:picMk id="9" creationId="{504CD099-FD1D-A9E1-17F7-A5EC85BB4181}"/>
+          </ac:picMkLst>
+        </pc:picChg>
+      </pc:sldChg>
+      <pc:sldChg chg="addSp modSp new mod ord">
+        <pc:chgData name="Hadia Akbar" userId="19362115565_tp_box_2" providerId="OAuth2" clId="{FF77DECD-7ECC-48F4-BF82-9D4D4E0BE774}" dt="2026-08-24T23:16:18.208" v="2438" actId="1076"/>
+        <pc:sldMkLst>
+          <pc:docMk/>
+          <pc:sldMk cId="1233494780" sldId="264"/>
+        </pc:sldMkLst>
+        <pc:spChg chg="add mod">
+          <ac:chgData name="Hadia Akbar" userId="19362115565_tp_box_2" providerId="OAuth2" clId="{FF77DECD-7ECC-48F4-BF82-9D4D4E0BE774}" dt="2026-08-24T23:14:29.194" v="2364"/>
+          <ac:spMkLst>
+            <pc:docMk/>
+            <pc:sldMk cId="1233494780" sldId="264"/>
+            <ac:spMk id="5" creationId="{ACFF18CE-2302-6EB6-7F2D-E27034F4B1D9}"/>
+          </ac:spMkLst>
+        </pc:spChg>
+        <pc:spChg chg="add mod">
+          <ac:chgData name="Hadia Akbar" userId="19362115565_tp_box_2" providerId="OAuth2" clId="{FF77DECD-7ECC-48F4-BF82-9D4D4E0BE774}" dt="2026-08-24T23:15:27.979" v="2401" actId="1076"/>
+          <ac:spMkLst>
+            <pc:docMk/>
+            <pc:sldMk cId="1233494780" sldId="264"/>
+            <ac:spMk id="7" creationId="{613250A1-4841-7097-A001-67EE207071D7}"/>
+          </ac:spMkLst>
+        </pc:spChg>
+        <pc:spChg chg="add mod">
+          <ac:chgData name="Hadia Akbar" userId="19362115565_tp_box_2" providerId="OAuth2" clId="{FF77DECD-7ECC-48F4-BF82-9D4D4E0BE774}" dt="2026-08-24T23:15:41.830" v="2404"/>
+          <ac:spMkLst>
+            <pc:docMk/>
+            <pc:sldMk cId="1233494780" sldId="264"/>
+            <ac:spMk id="9" creationId="{57E19324-00E0-2CF6-0634-64D5B5FDB4E1}"/>
+          </ac:spMkLst>
+        </pc:spChg>
+        <pc:spChg chg="add mod">
+          <ac:chgData name="Hadia Akbar" userId="19362115565_tp_box_2" providerId="OAuth2" clId="{FF77DECD-7ECC-48F4-BF82-9D4D4E0BE774}" dt="2026-08-24T23:16:18.208" v="2438" actId="1076"/>
+          <ac:spMkLst>
+            <pc:docMk/>
+            <pc:sldMk cId="1233494780" sldId="264"/>
+            <ac:spMk id="11" creationId="{DBF63553-0BB4-3734-E060-DE33145904CA}"/>
+          </ac:spMkLst>
+        </pc:spChg>
+        <pc:picChg chg="add mod modCrop">
+          <ac:chgData name="Hadia Akbar" userId="19362115565_tp_box_2" providerId="OAuth2" clId="{FF77DECD-7ECC-48F4-BF82-9D4D4E0BE774}" dt="2026-08-24T23:15:17.685" v="2398" actId="1035"/>
+          <ac:picMkLst>
+            <pc:docMk/>
+            <pc:sldMk cId="1233494780" sldId="264"/>
+            <ac:picMk id="3" creationId="{557EFDC3-1226-0938-F65C-AC0A4CB70C29}"/>
+          </ac:picMkLst>
+        </pc:picChg>
+      </pc:sldChg>
+      <pc:sldChg chg="addSp delSp modSp new mod ord">
+        <pc:chgData name="Hadia Akbar" userId="19362115565_tp_box_2" providerId="OAuth2" clId="{FF77DECD-7ECC-48F4-BF82-9D4D4E0BE774}" dt="2026-08-24T23:17:15.773" v="2454" actId="14100"/>
+        <pc:sldMkLst>
+          <pc:docMk/>
+          <pc:sldMk cId="1077105498" sldId="265"/>
+        </pc:sldMkLst>
+        <pc:spChg chg="del">
+          <ac:chgData name="Hadia Akbar" userId="19362115565_tp_box_2" providerId="OAuth2" clId="{FF77DECD-7ECC-48F4-BF82-9D4D4E0BE774}" dt="2026-08-24T23:17:09.879" v="2452" actId="478"/>
+          <ac:spMkLst>
+            <pc:docMk/>
+            <pc:sldMk cId="1077105498" sldId="265"/>
+            <ac:spMk id="2" creationId="{6812BC6F-D077-4E05-C130-3F2CC3DDECA7}"/>
+          </ac:spMkLst>
+        </pc:spChg>
+        <pc:spChg chg="del">
+          <ac:chgData name="Hadia Akbar" userId="19362115565_tp_box_2" providerId="OAuth2" clId="{FF77DECD-7ECC-48F4-BF82-9D4D4E0BE774}" dt="2026-08-24T23:17:11.632" v="2453" actId="478"/>
+          <ac:spMkLst>
+            <pc:docMk/>
+            <pc:sldMk cId="1077105498" sldId="265"/>
+            <ac:spMk id="3" creationId="{FF8C3D16-A4DC-80A1-9DB8-7698B9BEFF8A}"/>
+          </ac:spMkLst>
+        </pc:spChg>
+        <pc:graphicFrameChg chg="add mod">
+          <ac:chgData name="Hadia Akbar" userId="19362115565_tp_box_2" providerId="OAuth2" clId="{FF77DECD-7ECC-48F4-BF82-9D4D4E0BE774}" dt="2026-08-24T23:16:57.800" v="2447" actId="1076"/>
+          <ac:graphicFrameMkLst>
+            <pc:docMk/>
+            <pc:sldMk cId="1077105498" sldId="265"/>
+            <ac:graphicFrameMk id="6" creationId="{7990CB0E-8803-D419-DBC6-4068A222A4E0}"/>
+          </ac:graphicFrameMkLst>
+        </pc:graphicFrameChg>
+        <pc:picChg chg="add mod">
+          <ac:chgData name="Hadia Akbar" userId="19362115565_tp_box_2" providerId="OAuth2" clId="{FF77DECD-7ECC-48F4-BF82-9D4D4E0BE774}" dt="2026-08-24T23:17:15.773" v="2454" actId="14100"/>
+          <ac:picMkLst>
+            <pc:docMk/>
+            <pc:sldMk cId="1077105498" sldId="265"/>
+            <ac:picMk id="5" creationId="{E444F844-AF34-AA7D-E2E0-6589D214A168}"/>
           </ac:picMkLst>
         </pc:picChg>
       </pc:sldChg>
@@ -2242,7 +2304,7 @@
   <dgm:whole/>
   <dgm:extLst>
     <a:ext uri="http://schemas.microsoft.com/office/drawing/2008/diagram">
-      <dsp:dataModelExt xmlns:dsp="http://schemas.microsoft.com/office/drawing/2008/diagram" relId="rId6" minVer="http://schemas.openxmlformats.org/drawingml/2006/diagram"/>
+      <dsp:dataModelExt xmlns:dsp="http://schemas.microsoft.com/office/drawing/2008/diagram" relId="rId7" minVer="http://schemas.openxmlformats.org/drawingml/2006/diagram"/>
     </a:ext>
   </dgm:extLst>
 </dgm:dataModel>
@@ -2634,18 +2696,13 @@
         <a:lstStyle/>
         <a:p>
           <a:r>
-            <a:rPr lang="en-US" sz="1600" b="1">
+            <a:rPr lang="en-US" sz="1600" b="1" dirty="0">
               <a:solidFill>
                 <a:srgbClr val="3333FF"/>
               </a:solidFill>
             </a:rPr>
             <a:t>Decide Consumption</a:t>
           </a:r>
-          <a:endParaRPr lang="en-US" sz="1600" b="1" dirty="0">
-            <a:solidFill>
-              <a:srgbClr val="3333FF"/>
-            </a:solidFill>
-          </a:endParaRPr>
         </a:p>
       </dgm:t>
     </dgm:pt>
@@ -2908,7 +2965,7 @@
       <dgm:spPr/>
     </dgm:pt>
     <dgm:pt modelId="{30DD4CDA-4812-46C7-BA95-FF21DAD772D9}" type="pres">
-      <dgm:prSet presAssocID="{5C407219-177A-43EE-B67E-B6E75271BA5B}" presName="childNode1" presStyleLbl="bgAcc1" presStyleIdx="0" presStyleCnt="4">
+      <dgm:prSet presAssocID="{5C407219-177A-43EE-B67E-B6E75271BA5B}" presName="childNode1" presStyleLbl="bgAcc1" presStyleIdx="0" presStyleCnt="4" custScaleX="110000" custScaleY="110000">
         <dgm:presLayoutVars>
           <dgm:bulletEnabled val="1"/>
         </dgm:presLayoutVars>
@@ -2949,7 +3006,7 @@
       <dgm:spPr/>
     </dgm:pt>
     <dgm:pt modelId="{D9BDC29B-7D63-4495-A3B2-7C07F9B8C330}" type="pres">
-      <dgm:prSet presAssocID="{5489487A-AE09-4C57-A8FE-3C88CD528A51}" presName="childNode2" presStyleLbl="bgAcc1" presStyleIdx="1" presStyleCnt="4">
+      <dgm:prSet presAssocID="{5489487A-AE09-4C57-A8FE-3C88CD528A51}" presName="childNode2" presStyleLbl="bgAcc1" presStyleIdx="1" presStyleCnt="4" custScaleX="110000" custScaleY="110000">
         <dgm:presLayoutVars>
           <dgm:bulletEnabled val="1"/>
         </dgm:presLayoutVars>
@@ -2990,7 +3047,7 @@
       <dgm:spPr/>
     </dgm:pt>
     <dgm:pt modelId="{686EF4F2-C186-45B2-85A0-F6687D978556}" type="pres">
-      <dgm:prSet presAssocID="{1BCB95D6-B1A4-439C-9AD1-CE00E32D68AA}" presName="childNode1" presStyleLbl="bgAcc1" presStyleIdx="2" presStyleCnt="4">
+      <dgm:prSet presAssocID="{1BCB95D6-B1A4-439C-9AD1-CE00E32D68AA}" presName="childNode1" presStyleLbl="bgAcc1" presStyleIdx="2" presStyleCnt="4" custScaleX="110000" custScaleY="110000">
         <dgm:presLayoutVars>
           <dgm:bulletEnabled val="1"/>
         </dgm:presLayoutVars>
@@ -3031,7 +3088,7 @@
       <dgm:spPr/>
     </dgm:pt>
     <dgm:pt modelId="{DE4AC59B-B8E8-4AE0-82DC-3BD6B4ADF27A}" type="pres">
-      <dgm:prSet presAssocID="{5DA50F34-C831-4850-8B63-CE799FF6C0D5}" presName="childNode2" presStyleLbl="bgAcc1" presStyleIdx="3" presStyleCnt="4">
+      <dgm:prSet presAssocID="{5DA50F34-C831-4850-8B63-CE799FF6C0D5}" presName="childNode2" presStyleLbl="bgAcc1" presStyleIdx="3" presStyleCnt="4" custScaleX="110000" custScaleY="110000">
         <dgm:presLayoutVars>
           <dgm:bulletEnabled val="1"/>
         </dgm:presLayoutVars>
@@ -3842,8 +3899,8 @@
       </dsp:nvSpPr>
       <dsp:spPr>
         <a:xfrm>
-          <a:off x="9648" y="2694975"/>
-          <a:ext cx="2450927" cy="2021502"/>
+          <a:off x="3417" y="2637506"/>
+          <a:ext cx="2591963" cy="2137827"/>
         </a:xfrm>
         <a:prstGeom prst="roundRect">
           <a:avLst>
@@ -3958,8 +4015,8 @@
         </a:p>
       </dsp:txBody>
       <dsp:txXfrm>
-        <a:off x="56168" y="2741495"/>
-        <a:ext cx="2357887" cy="1495283"/>
+        <a:off x="52614" y="2686703"/>
+        <a:ext cx="2493569" cy="1581327"/>
       </dsp:txXfrm>
     </dsp:sp>
     <dsp:sp modelId="{464DE029-02A1-4763-8666-F53A13C6FAAD}">
@@ -3969,16 +4026,16 @@
       </dsp:nvSpPr>
       <dsp:spPr>
         <a:xfrm>
-          <a:off x="1389830" y="3290574"/>
-          <a:ext cx="2584390" cy="2584390"/>
+          <a:off x="1439340" y="3206126"/>
+          <a:ext cx="2620065" cy="2620065"/>
         </a:xfrm>
         <a:prstGeom prst="leftCircularArrow">
           <a:avLst>
-            <a:gd name="adj1" fmla="val 2693"/>
-            <a:gd name="adj2" fmla="val 327803"/>
-            <a:gd name="adj3" fmla="val 1993841"/>
-            <a:gd name="adj4" fmla="val 8915017"/>
-            <a:gd name="adj5" fmla="val 3141"/>
+            <a:gd name="adj1" fmla="val 2554"/>
+            <a:gd name="adj2" fmla="val 309855"/>
+            <a:gd name="adj3" fmla="val 1981885"/>
+            <a:gd name="adj4" fmla="val 8921009"/>
+            <a:gd name="adj5" fmla="val 2979"/>
           </a:avLst>
         </a:prstGeom>
         <a:solidFill>
@@ -4017,8 +4074,8 @@
       </dsp:nvSpPr>
       <dsp:spPr>
         <a:xfrm>
-          <a:off x="554299" y="4350675"/>
-          <a:ext cx="2178602" cy="866358"/>
+          <a:off x="644862" y="4326476"/>
+          <a:ext cx="2094515" cy="832919"/>
         </a:xfrm>
         <a:prstGeom prst="roundRect">
           <a:avLst>
@@ -4094,8 +4151,8 @@
         </a:p>
       </dsp:txBody>
       <dsp:txXfrm>
-        <a:off x="579674" y="4376050"/>
-        <a:ext cx="2127852" cy="815608"/>
+        <a:off x="669257" y="4350871"/>
+        <a:ext cx="2045725" cy="784129"/>
       </dsp:txXfrm>
     </dsp:sp>
     <dsp:sp modelId="{D9BDC29B-7D63-4495-A3B2-7C07F9B8C330}">
@@ -4105,8 +4162,8 @@
       </dsp:nvSpPr>
       <dsp:spPr>
         <a:xfrm>
-          <a:off x="3064282" y="2694975"/>
-          <a:ext cx="2450927" cy="2021502"/>
+          <a:off x="3057969" y="2636118"/>
+          <a:ext cx="2591963" cy="2137827"/>
         </a:xfrm>
         <a:prstGeom prst="roundRect">
           <a:avLst>
@@ -4199,8 +4256,8 @@
         </a:p>
       </dsp:txBody>
       <dsp:txXfrm>
-        <a:off x="3110802" y="3174674"/>
-        <a:ext cx="2357887" cy="1495283"/>
+        <a:off x="3107166" y="3143421"/>
+        <a:ext cx="2493569" cy="1581327"/>
       </dsp:txXfrm>
     </dsp:sp>
     <dsp:sp modelId="{1C299799-9D54-457B-A3C7-0FB93A410866}">
@@ -4210,16 +4267,16 @@
       </dsp:nvSpPr>
       <dsp:spPr>
         <a:xfrm>
-          <a:off x="4443787" y="1491532"/>
-          <a:ext cx="2896330" cy="2896330"/>
+          <a:off x="4493210" y="1542007"/>
+          <a:ext cx="2920031" cy="2920031"/>
         </a:xfrm>
         <a:prstGeom prst="circularArrow">
           <a:avLst>
-            <a:gd name="adj1" fmla="val 2403"/>
-            <a:gd name="adj2" fmla="val 290535"/>
-            <a:gd name="adj3" fmla="val 19533954"/>
+            <a:gd name="adj1" fmla="val 2291"/>
+            <a:gd name="adj2" fmla="val 276342"/>
+            <a:gd name="adj3" fmla="val 19548147"/>
             <a:gd name="adj4" fmla="val 12575511"/>
-            <a:gd name="adj5" fmla="val 2803"/>
+            <a:gd name="adj5" fmla="val 2673"/>
           </a:avLst>
         </a:prstGeom>
         <a:solidFill>
@@ -4258,8 +4315,8 @@
       </dsp:nvSpPr>
       <dsp:spPr>
         <a:xfrm>
-          <a:off x="3608933" y="2261795"/>
-          <a:ext cx="2178602" cy="866358"/>
+          <a:off x="3699414" y="2316832"/>
+          <a:ext cx="2094515" cy="832919"/>
         </a:xfrm>
         <a:prstGeom prst="roundRect">
           <a:avLst>
@@ -4335,8 +4392,8 @@
         </a:p>
       </dsp:txBody>
       <dsp:txXfrm>
-        <a:off x="3634308" y="2287170"/>
-        <a:ext cx="2127852" cy="815608"/>
+        <a:off x="3723809" y="2341227"/>
+        <a:ext cx="2045725" cy="784129"/>
       </dsp:txXfrm>
     </dsp:sp>
     <dsp:sp modelId="{686EF4F2-C186-45B2-85A0-F6687D978556}">
@@ -4346,8 +4403,8 @@
       </dsp:nvSpPr>
       <dsp:spPr>
         <a:xfrm>
-          <a:off x="6118916" y="2694975"/>
-          <a:ext cx="2450927" cy="2021502"/>
+          <a:off x="6112521" y="2637506"/>
+          <a:ext cx="2591963" cy="2137827"/>
         </a:xfrm>
         <a:prstGeom prst="roundRect">
           <a:avLst>
@@ -4430,18 +4487,13 @@
             <a:buChar char="•"/>
           </a:pPr>
           <a:r>
-            <a:rPr lang="en-US" sz="1600" b="1" kern="1200">
+            <a:rPr lang="en-US" sz="1600" b="1" kern="1200" dirty="0">
               <a:solidFill>
                 <a:srgbClr val="3333FF"/>
               </a:solidFill>
             </a:rPr>
             <a:t>Decide Consumption</a:t>
           </a:r>
-          <a:endParaRPr lang="en-US" sz="1600" b="1" kern="1200" dirty="0">
-            <a:solidFill>
-              <a:srgbClr val="3333FF"/>
-            </a:solidFill>
-          </a:endParaRPr>
         </a:p>
         <a:p>
           <a:pPr marL="342900" lvl="2" indent="-171450" algn="l" defTabSz="711200">
@@ -4489,8 +4541,8 @@
         </a:p>
       </dsp:txBody>
       <dsp:txXfrm>
-        <a:off x="6165436" y="2741495"/>
-        <a:ext cx="2357887" cy="1495283"/>
+        <a:off x="6161718" y="2686703"/>
+        <a:ext cx="2493569" cy="1581327"/>
       </dsp:txXfrm>
     </dsp:sp>
     <dsp:sp modelId="{74F3F80A-8B0F-4F29-B321-AD28639C9105}">
@@ -4500,16 +4552,16 @@
       </dsp:nvSpPr>
       <dsp:spPr>
         <a:xfrm>
-          <a:off x="7518845" y="3257502"/>
-          <a:ext cx="2583156" cy="2583156"/>
+          <a:off x="7567398" y="3174298"/>
+          <a:ext cx="2618944" cy="2618944"/>
         </a:xfrm>
         <a:prstGeom prst="leftCircularArrow">
           <a:avLst>
-            <a:gd name="adj1" fmla="val 2694"/>
-            <a:gd name="adj2" fmla="val 327969"/>
-            <a:gd name="adj3" fmla="val 2103480"/>
+            <a:gd name="adj1" fmla="val 2555"/>
+            <a:gd name="adj2" fmla="val 309995"/>
+            <a:gd name="adj3" fmla="val 2085506"/>
             <a:gd name="adj4" fmla="val 9024489"/>
-            <a:gd name="adj5" fmla="val 3143"/>
+            <a:gd name="adj5" fmla="val 2980"/>
           </a:avLst>
         </a:prstGeom>
         <a:solidFill>
@@ -4548,8 +4600,8 @@
       </dsp:nvSpPr>
       <dsp:spPr>
         <a:xfrm>
-          <a:off x="6663566" y="4283298"/>
-          <a:ext cx="2178602" cy="866358"/>
+          <a:off x="6753966" y="4261700"/>
+          <a:ext cx="2094515" cy="832919"/>
         </a:xfrm>
         <a:prstGeom prst="roundRect">
           <a:avLst>
@@ -4617,8 +4669,8 @@
         </a:p>
       </dsp:txBody>
       <dsp:txXfrm>
-        <a:off x="6688941" y="4308673"/>
-        <a:ext cx="2127852" cy="815608"/>
+        <a:off x="6778361" y="4286095"/>
+        <a:ext cx="2045725" cy="784129"/>
       </dsp:txXfrm>
     </dsp:sp>
     <dsp:sp modelId="{DE4AC59B-B8E8-4AE0-82DC-3BD6B4ADF27A}">
@@ -4628,8 +4680,8 @@
       </dsp:nvSpPr>
       <dsp:spPr>
         <a:xfrm>
-          <a:off x="9173550" y="2694975"/>
-          <a:ext cx="2450927" cy="2021502"/>
+          <a:off x="9167073" y="2636118"/>
+          <a:ext cx="2591963" cy="2137827"/>
         </a:xfrm>
         <a:prstGeom prst="roundRect">
           <a:avLst>
@@ -4732,8 +4784,8 @@
         </a:p>
       </dsp:txBody>
       <dsp:txXfrm>
-        <a:off x="9220070" y="3174674"/>
-        <a:ext cx="2357887" cy="1495283"/>
+        <a:off x="9216270" y="3143421"/>
+        <a:ext cx="2493569" cy="1581327"/>
       </dsp:txXfrm>
     </dsp:sp>
     <dsp:sp modelId="{C4D9AE61-43FF-44EC-9E2D-7446ED243914}">
@@ -4743,8 +4795,8 @@
       </dsp:nvSpPr>
       <dsp:spPr>
         <a:xfrm>
-          <a:off x="9718200" y="2261795"/>
-          <a:ext cx="2178602" cy="866358"/>
+          <a:off x="9808518" y="2316832"/>
+          <a:ext cx="2094515" cy="832919"/>
         </a:xfrm>
         <a:prstGeom prst="roundRect">
           <a:avLst>
@@ -4812,8 +4864,8 @@
         </a:p>
       </dsp:txBody>
       <dsp:txXfrm>
-        <a:off x="9743575" y="2287170"/>
-        <a:ext cx="2127852" cy="815608"/>
+        <a:off x="9832913" y="2341227"/>
+        <a:ext cx="2045725" cy="784129"/>
       </dsp:txXfrm>
     </dsp:sp>
   </dsp:spTree>
@@ -7980,7 +8032,7 @@
           <a:p>
             <a:fld id="{23F5F05C-4C32-48D7-B5AA-52291E739591}" type="datetimeFigureOut">
               <a:rPr lang="en-US" smtClean="0"/>
-              <a:t>8/20/2026</a:t>
+              <a:t>8/24/2026</a:t>
             </a:fld>
             <a:endParaRPr lang="en-US"/>
           </a:p>
@@ -8622,7 +8674,7 @@
           <a:p>
             <a:fld id="{5518E2ED-ACDD-48AE-BEAE-F9B835E4D922}" type="datetimeFigureOut">
               <a:rPr lang="en-US" smtClean="0"/>
-              <a:t>8/20/2026</a:t>
+              <a:t>8/24/2026</a:t>
             </a:fld>
             <a:endParaRPr lang="en-US"/>
           </a:p>
@@ -8820,7 +8872,7 @@
           <a:p>
             <a:fld id="{5518E2ED-ACDD-48AE-BEAE-F9B835E4D922}" type="datetimeFigureOut">
               <a:rPr lang="en-US" smtClean="0"/>
-              <a:t>8/20/2026</a:t>
+              <a:t>8/24/2026</a:t>
             </a:fld>
             <a:endParaRPr lang="en-US"/>
           </a:p>
@@ -9028,7 +9080,7 @@
           <a:p>
             <a:fld id="{5518E2ED-ACDD-48AE-BEAE-F9B835E4D922}" type="datetimeFigureOut">
               <a:rPr lang="en-US" smtClean="0"/>
-              <a:t>8/20/2026</a:t>
+              <a:t>8/24/2026</a:t>
             </a:fld>
             <a:endParaRPr lang="en-US"/>
           </a:p>
@@ -9226,7 +9278,7 @@
           <a:p>
             <a:fld id="{5518E2ED-ACDD-48AE-BEAE-F9B835E4D922}" type="datetimeFigureOut">
               <a:rPr lang="en-US" smtClean="0"/>
-              <a:t>8/20/2026</a:t>
+              <a:t>8/24/2026</a:t>
             </a:fld>
             <a:endParaRPr lang="en-US"/>
           </a:p>
@@ -9501,7 +9553,7 @@
           <a:p>
             <a:fld id="{5518E2ED-ACDD-48AE-BEAE-F9B835E4D922}" type="datetimeFigureOut">
               <a:rPr lang="en-US" smtClean="0"/>
-              <a:t>8/20/2026</a:t>
+              <a:t>8/24/2026</a:t>
             </a:fld>
             <a:endParaRPr lang="en-US"/>
           </a:p>
@@ -9766,7 +9818,7 @@
           <a:p>
             <a:fld id="{5518E2ED-ACDD-48AE-BEAE-F9B835E4D922}" type="datetimeFigureOut">
               <a:rPr lang="en-US" smtClean="0"/>
-              <a:t>8/20/2026</a:t>
+              <a:t>8/24/2026</a:t>
             </a:fld>
             <a:endParaRPr lang="en-US"/>
           </a:p>
@@ -10178,7 +10230,7 @@
           <a:p>
             <a:fld id="{5518E2ED-ACDD-48AE-BEAE-F9B835E4D922}" type="datetimeFigureOut">
               <a:rPr lang="en-US" smtClean="0"/>
-              <a:t>8/20/2026</a:t>
+              <a:t>8/24/2026</a:t>
             </a:fld>
             <a:endParaRPr lang="en-US"/>
           </a:p>
@@ -10319,7 +10371,7 @@
           <a:p>
             <a:fld id="{5518E2ED-ACDD-48AE-BEAE-F9B835E4D922}" type="datetimeFigureOut">
               <a:rPr lang="en-US" smtClean="0"/>
-              <a:t>8/20/2026</a:t>
+              <a:t>8/24/2026</a:t>
             </a:fld>
             <a:endParaRPr lang="en-US"/>
           </a:p>
@@ -10432,7 +10484,7 @@
           <a:p>
             <a:fld id="{5518E2ED-ACDD-48AE-BEAE-F9B835E4D922}" type="datetimeFigureOut">
               <a:rPr lang="en-US" smtClean="0"/>
-              <a:t>8/20/2026</a:t>
+              <a:t>8/24/2026</a:t>
             </a:fld>
             <a:endParaRPr lang="en-US"/>
           </a:p>
@@ -10743,7 +10795,7 @@
           <a:p>
             <a:fld id="{5518E2ED-ACDD-48AE-BEAE-F9B835E4D922}" type="datetimeFigureOut">
               <a:rPr lang="en-US" smtClean="0"/>
-              <a:t>8/20/2026</a:t>
+              <a:t>8/24/2026</a:t>
             </a:fld>
             <a:endParaRPr lang="en-US"/>
           </a:p>
@@ -11031,7 +11083,7 @@
           <a:p>
             <a:fld id="{5518E2ED-ACDD-48AE-BEAE-F9B835E4D922}" type="datetimeFigureOut">
               <a:rPr lang="en-US" smtClean="0"/>
-              <a:t>8/20/2026</a:t>
+              <a:t>8/24/2026</a:t>
             </a:fld>
             <a:endParaRPr lang="en-US"/>
           </a:p>
@@ -11272,7 +11324,7 @@
           <a:p>
             <a:fld id="{5518E2ED-ACDD-48AE-BEAE-F9B835E4D922}" type="datetimeFigureOut">
               <a:rPr lang="en-US" smtClean="0"/>
-              <a:t>8/20/2026</a:t>
+              <a:t>8/24/2026</a:t>
             </a:fld>
             <a:endParaRPr lang="en-US"/>
           </a:p>
@@ -11791,8 +11843,8 @@
         </p:nvSpPr>
         <p:spPr>
           <a:xfrm>
-            <a:off x="628435" y="921715"/>
-            <a:ext cx="5566207" cy="2635993"/>
+            <a:off x="371816" y="779929"/>
+            <a:ext cx="5566207" cy="1908202"/>
           </a:xfrm>
         </p:spPr>
         <p:txBody>
@@ -12049,19 +12101,19 @@
         </p:nvSpPr>
         <p:spPr>
           <a:xfrm>
-            <a:off x="823442" y="4541263"/>
-            <a:ext cx="4662957" cy="1395022"/>
+            <a:off x="3365916" y="5295309"/>
+            <a:ext cx="1893644" cy="457203"/>
           </a:xfrm>
         </p:spPr>
         <p:txBody>
           <a:bodyPr anchor="t">
-            <a:normAutofit/>
+            <a:normAutofit fontScale="92500"/>
           </a:bodyPr>
           <a:lstStyle/>
           <a:p>
             <a:pPr algn="l"/>
             <a:r>
-              <a:rPr lang="en-US" dirty="0">
+              <a:rPr lang="en-US" b="1" dirty="0">
                 <a:solidFill>
                   <a:srgbClr val="FFFFFF"/>
                 </a:solidFill>
@@ -12099,8 +12151,8 @@
         </p:blipFill>
         <p:spPr>
           <a:xfrm>
-            <a:off x="6823077" y="463404"/>
-            <a:ext cx="4664682" cy="5553193"/>
+            <a:off x="334492" y="4146457"/>
+            <a:ext cx="2147370" cy="2556393"/>
           </a:xfrm>
           <a:prstGeom prst="rect">
             <a:avLst/>
@@ -12183,6 +12235,36 @@
           </a:p>
         </p:txBody>
       </p:sp>
+      <p:pic>
+        <p:nvPicPr>
+          <p:cNvPr id="5" name="Picture 4" descr="The image depicts a map illustrating various water bodies and regions within Utah, including rivers like the Bear River Basin, Salt Lake, and others, with several reservoirs and lakes marked.&#10;&#10;AI-generated content may be incorrect.">
+            <a:extLst>
+              <a:ext uri="{FF2B5EF4-FFF2-40B4-BE49-F238E27FC236}">
+                <a16:creationId xmlns:a16="http://schemas.microsoft.com/office/drawing/2014/main" id="{013E8E12-46D6-55E9-31F9-2CCFEDCB82BF}"/>
+              </a:ext>
+            </a:extLst>
+          </p:cNvPr>
+          <p:cNvPicPr>
+            <a:picLocks noChangeAspect="1"/>
+          </p:cNvPicPr>
+          <p:nvPr/>
+        </p:nvPicPr>
+        <p:blipFill>
+          <a:blip r:embed="rId4"/>
+          <a:stretch>
+            <a:fillRect/>
+          </a:stretch>
+        </p:blipFill>
+        <p:spPr>
+          <a:xfrm>
+            <a:off x="7152080" y="7495"/>
+            <a:ext cx="5039920" cy="6858001"/>
+          </a:xfrm>
+          <a:prstGeom prst="rect">
+            <a:avLst/>
+          </a:prstGeom>
+        </p:spPr>
+      </p:pic>
     </p:spTree>
     <p:extLst>
       <p:ext uri="{BB962C8B-B14F-4D97-AF65-F5344CB8AC3E}">
@@ -12299,14 +12381,6 @@
 <file path=ppt/slides/slide2.xml><?xml version="1.0" encoding="utf-8"?>
 <p:sld xmlns:a="http://schemas.openxmlformats.org/drawingml/2006/main" xmlns:r="http://schemas.openxmlformats.org/officeDocument/2006/relationships" xmlns:p="http://schemas.openxmlformats.org/presentationml/2006/main">
   <p:cSld>
-    <p:bg>
-      <p:bgPr>
-        <a:solidFill>
-          <a:schemeClr val="bg1"/>
-        </a:solidFill>
-        <a:effectLst/>
-      </p:bgPr>
-    </p:bg>
     <p:spTree>
       <p:nvGrpSpPr>
         <p:cNvPr id="1" name=""/>
@@ -12321,48 +12395,12 @@
           <a:chExt cx="0" cy="0"/>
         </a:xfrm>
       </p:grpSpPr>
-      <p:sp>
-        <p:nvSpPr>
-          <p:cNvPr id="2" name="Title 1">
+      <p:pic>
+        <p:nvPicPr>
+          <p:cNvPr id="3" name="Picture 2" descr="The graph depicts historical elevation data for the Great Salt Lake South Arm, showing a steady rise from 4,188 feet in 1905 to 4,212 feet in 2025.&#10;&#10;AI-generated content may be incorrect.">
             <a:extLst>
               <a:ext uri="{FF2B5EF4-FFF2-40B4-BE49-F238E27FC236}">
-                <a16:creationId xmlns:a16="http://schemas.microsoft.com/office/drawing/2014/main" id="{81F1C4B3-9A9B-ACA7-FD33-EA866B5A34CE}"/>
-              </a:ext>
-            </a:extLst>
-          </p:cNvPr>
-          <p:cNvSpPr>
-            <a:spLocks noGrp="1"/>
-          </p:cNvSpPr>
-          <p:nvPr>
-            <p:ph type="title"/>
-          </p:nvPr>
-        </p:nvSpPr>
-        <p:spPr>
-          <a:xfrm>
-            <a:off x="610782" y="762000"/>
-            <a:ext cx="5637618" cy="1401597"/>
-          </a:xfrm>
-        </p:spPr>
-        <p:txBody>
-          <a:bodyPr vert="horz" lIns="91440" tIns="45720" rIns="91440" bIns="45720" rtlCol="0" anchor="b">
-            <a:normAutofit fontScale="90000"/>
-          </a:bodyPr>
-          <a:lstStyle/>
-          <a:p>
-            <a:pPr algn="ctr"/>
-            <a:r>
-              <a:rPr lang="en-US" sz="4000" dirty="0"/>
-              <a:t>A Tri-State Water Bank to Get More Water to the GSL</a:t>
-            </a:r>
-          </a:p>
-        </p:txBody>
-      </p:sp>
-      <p:pic>
-        <p:nvPicPr>
-          <p:cNvPr id="18" name="Figure">
-            <a:extLst>
-              <a:ext uri="{FF2B5EF4-FFF2-40B4-BE49-F238E27FC236}">
-                <a16:creationId xmlns:a16="http://schemas.microsoft.com/office/drawing/2014/main" id="{E9E2FD9A-CEC4-149A-7AA0-B9A9435CC662}"/>
+                <a16:creationId xmlns:a16="http://schemas.microsoft.com/office/drawing/2014/main" id="{557EFDC3-1226-0938-F65C-AC0A4CB70C29}"/>
               </a:ext>
             </a:extLst>
           </p:cNvPr>
@@ -12373,71 +12411,224 @@
         </p:nvPicPr>
         <p:blipFill>
           <a:blip r:embed="rId2"/>
-          <a:srcRect/>
-          <a:stretch>
-            <a:fillRect/>
-          </a:stretch>
-        </p:blipFill>
-        <p:spPr bwMode="auto">
-          <a:xfrm>
-            <a:off x="7037563" y="73644"/>
-            <a:ext cx="4918846" cy="6710711"/>
-          </a:xfrm>
-          <a:prstGeom prst="rect">
-            <a:avLst/>
-          </a:prstGeom>
-          <a:ln w="19050">
-            <a:solidFill>
-              <a:schemeClr val="tx1"/>
-            </a:solidFill>
-          </a:ln>
-        </p:spPr>
-      </p:pic>
-      <p:pic>
-        <p:nvPicPr>
-          <p:cNvPr id="4" name="Picture 3" descr="The image depicts a map highlighting Idaho, Wyoming, Salt Lake City, Great, Denver, and Utah.&#10;&#10;AI-generated content may be incorrect.">
-            <a:extLst>
-              <a:ext uri="{FF2B5EF4-FFF2-40B4-BE49-F238E27FC236}">
-                <a16:creationId xmlns:a16="http://schemas.microsoft.com/office/drawing/2014/main" id="{24E79CC9-78C3-BC1B-D785-D9BBED37350E}"/>
-              </a:ext>
-            </a:extLst>
-          </p:cNvPr>
-          <p:cNvPicPr>
-            <a:picLocks noChangeAspect="1"/>
-          </p:cNvPicPr>
-          <p:nvPr/>
-        </p:nvPicPr>
-        <p:blipFill>
-          <a:blip r:embed="rId3">
-            <a:extLst>
-              <a:ext uri="{28A0092B-C50C-407E-A947-70E740481C1C}">
-                <a14:useLocalDpi xmlns:a14="http://schemas.microsoft.com/office/drawing/2010/main" val="0"/>
-              </a:ext>
-            </a:extLst>
-          </a:blip>
+          <a:srcRect t="9245" b="3418"/>
           <a:stretch>
             <a:fillRect/>
           </a:stretch>
         </p:blipFill>
         <p:spPr>
           <a:xfrm>
-            <a:off x="1873623" y="2791492"/>
-            <a:ext cx="2775235" cy="3304508"/>
+            <a:off x="228214" y="44819"/>
+            <a:ext cx="11735567" cy="4267199"/>
           </a:xfrm>
           <a:prstGeom prst="rect">
             <a:avLst/>
           </a:prstGeom>
-          <a:ln w="19050">
-            <a:solidFill>
-              <a:schemeClr val="tx1"/>
-            </a:solidFill>
-          </a:ln>
         </p:spPr>
       </p:pic>
+      <p:sp>
+        <p:nvSpPr>
+          <p:cNvPr id="5" name="TextBox 4">
+            <a:extLst>
+              <a:ext uri="{FF2B5EF4-FFF2-40B4-BE49-F238E27FC236}">
+                <a16:creationId xmlns:a16="http://schemas.microsoft.com/office/drawing/2014/main" id="{ACFF18CE-2302-6EB6-7F2D-E27034F4B1D9}"/>
+              </a:ext>
+            </a:extLst>
+          </p:cNvPr>
+          <p:cNvSpPr txBox="1"/>
+          <p:nvPr/>
+        </p:nvSpPr>
+        <p:spPr>
+          <a:xfrm>
+            <a:off x="1035422" y="5699320"/>
+            <a:ext cx="10121153" cy="954107"/>
+          </a:xfrm>
+          <a:prstGeom prst="rect">
+            <a:avLst/>
+          </a:prstGeom>
+          <a:noFill/>
+        </p:spPr>
+        <p:txBody>
+          <a:bodyPr wrap="square">
+            <a:spAutoFit/>
+          </a:bodyPr>
+          <a:lstStyle/>
+          <a:p>
+            <a:pPr algn="ctr"/>
+            <a:r>
+              <a:rPr lang="en-US" sz="2800" b="1" i="0" dirty="0">
+                <a:solidFill>
+                  <a:schemeClr val="tx1"/>
+                </a:solidFill>
+                <a:effectLst/>
+                <a:latin typeface="+mn-lt"/>
+              </a:rPr>
+              <a:t>800,000 acre-feet</a:t>
+            </a:r>
+            <a:r>
+              <a:rPr lang="en-US" sz="2800" b="0" i="0" dirty="0">
+                <a:solidFill>
+                  <a:schemeClr val="tx1"/>
+                </a:solidFill>
+                <a:effectLst/>
+                <a:latin typeface="+mn-lt"/>
+              </a:rPr>
+              <a:t> of sustained additional inflow per year needed to return the lake to healthy levels (4,198 feet) by 2025</a:t>
+            </a:r>
+            <a:endParaRPr lang="en-US" sz="2800" dirty="0"/>
+          </a:p>
+        </p:txBody>
+      </p:sp>
+      <p:sp>
+        <p:nvSpPr>
+          <p:cNvPr id="7" name="TextBox 6">
+            <a:extLst>
+              <a:ext uri="{FF2B5EF4-FFF2-40B4-BE49-F238E27FC236}">
+                <a16:creationId xmlns:a16="http://schemas.microsoft.com/office/drawing/2014/main" id="{613250A1-4841-7097-A001-67EE207071D7}"/>
+              </a:ext>
+            </a:extLst>
+          </p:cNvPr>
+          <p:cNvSpPr txBox="1"/>
+          <p:nvPr/>
+        </p:nvSpPr>
+        <p:spPr>
+          <a:xfrm>
+            <a:off x="179291" y="4312018"/>
+            <a:ext cx="5916706" cy="523220"/>
+          </a:xfrm>
+          <a:prstGeom prst="rect">
+            <a:avLst/>
+          </a:prstGeom>
+          <a:noFill/>
+        </p:spPr>
+        <p:txBody>
+          <a:bodyPr wrap="square">
+            <a:spAutoFit/>
+          </a:bodyPr>
+          <a:lstStyle/>
+          <a:p>
+            <a:r>
+              <a:rPr lang="en-US" sz="2800" i="0" dirty="0">
+                <a:solidFill>
+                  <a:srgbClr val="00B050"/>
+                </a:solidFill>
+                <a:effectLst/>
+                <a:latin typeface="+mn-lt"/>
+              </a:rPr>
+              <a:t>Healthy lake levels: 4,198-4,205 ft </a:t>
+            </a:r>
+            <a:endParaRPr lang="en-US" sz="2800" dirty="0">
+              <a:solidFill>
+                <a:srgbClr val="00B050"/>
+              </a:solidFill>
+            </a:endParaRPr>
+          </a:p>
+        </p:txBody>
+      </p:sp>
+      <p:sp>
+        <p:nvSpPr>
+          <p:cNvPr id="9" name="TextBox 8">
+            <a:extLst>
+              <a:ext uri="{FF2B5EF4-FFF2-40B4-BE49-F238E27FC236}">
+                <a16:creationId xmlns:a16="http://schemas.microsoft.com/office/drawing/2014/main" id="{57E19324-00E0-2CF6-0634-64D5B5FDB4E1}"/>
+              </a:ext>
+            </a:extLst>
+          </p:cNvPr>
+          <p:cNvSpPr txBox="1"/>
+          <p:nvPr/>
+        </p:nvSpPr>
+        <p:spPr>
+          <a:xfrm>
+            <a:off x="7328645" y="4312018"/>
+            <a:ext cx="4939556" cy="523220"/>
+          </a:xfrm>
+          <a:prstGeom prst="rect">
+            <a:avLst/>
+          </a:prstGeom>
+          <a:noFill/>
+        </p:spPr>
+        <p:txBody>
+          <a:bodyPr wrap="square">
+            <a:spAutoFit/>
+          </a:bodyPr>
+          <a:lstStyle/>
+          <a:p>
+            <a:r>
+              <a:rPr lang="en-US" sz="2800">
+                <a:solidFill>
+                  <a:srgbClr val="FF0000"/>
+                </a:solidFill>
+              </a:rPr>
+              <a:t>H</a:t>
+            </a:r>
+            <a:r>
+              <a:rPr lang="en-US" sz="2800" b="0" i="0">
+                <a:solidFill>
+                  <a:srgbClr val="FF0000"/>
+                </a:solidFill>
+                <a:effectLst/>
+                <a:latin typeface="+mn-lt"/>
+              </a:rPr>
+              <a:t>istoric low : 4,188.5 ft (2022)</a:t>
+            </a:r>
+            <a:endParaRPr lang="en-US" sz="2800" dirty="0">
+              <a:solidFill>
+                <a:srgbClr val="FF0000"/>
+              </a:solidFill>
+            </a:endParaRPr>
+          </a:p>
+        </p:txBody>
+      </p:sp>
+      <p:sp>
+        <p:nvSpPr>
+          <p:cNvPr id="11" name="TextBox 10">
+            <a:extLst>
+              <a:ext uri="{FF2B5EF4-FFF2-40B4-BE49-F238E27FC236}">
+                <a16:creationId xmlns:a16="http://schemas.microsoft.com/office/drawing/2014/main" id="{DBF63553-0BB4-3734-E060-DE33145904CA}"/>
+              </a:ext>
+            </a:extLst>
+          </p:cNvPr>
+          <p:cNvSpPr txBox="1"/>
+          <p:nvPr/>
+        </p:nvSpPr>
+        <p:spPr>
+          <a:xfrm>
+            <a:off x="4798358" y="5005669"/>
+            <a:ext cx="3314700" cy="523220"/>
+          </a:xfrm>
+          <a:prstGeom prst="rect">
+            <a:avLst/>
+          </a:prstGeom>
+          <a:noFill/>
+        </p:spPr>
+        <p:txBody>
+          <a:bodyPr wrap="square">
+            <a:spAutoFit/>
+          </a:bodyPr>
+          <a:lstStyle/>
+          <a:p>
+            <a:r>
+              <a:rPr lang="en-US" sz="2800" b="1" dirty="0"/>
+              <a:t>Mid 2026 ~ </a:t>
+            </a:r>
+            <a:r>
+              <a:rPr lang="en-US" sz="2800" b="1" i="0" dirty="0">
+                <a:solidFill>
+                  <a:schemeClr val="tx1"/>
+                </a:solidFill>
+                <a:effectLst/>
+                <a:latin typeface="+mn-lt"/>
+              </a:rPr>
+              <a:t>4,190 ft</a:t>
+            </a:r>
+            <a:endParaRPr lang="en-US" sz="2800" b="1" dirty="0"/>
+          </a:p>
+        </p:txBody>
+      </p:sp>
     </p:spTree>
     <p:extLst>
       <p:ext uri="{BB962C8B-B14F-4D97-AF65-F5344CB8AC3E}">
-        <p14:creationId xmlns:p14="http://schemas.microsoft.com/office/powerpoint/2010/main" val="1480586688"/>
+        <p14:creationId xmlns:p14="http://schemas.microsoft.com/office/powerpoint/2010/main" val="1233494780"/>
       </p:ext>
     </p:extLst>
   </p:cSld>
@@ -12450,14 +12641,6 @@
 <file path=ppt/slides/slide3.xml><?xml version="1.0" encoding="utf-8"?>
 <p:sld xmlns:a="http://schemas.openxmlformats.org/drawingml/2006/main" xmlns:r="http://schemas.openxmlformats.org/officeDocument/2006/relationships" xmlns:p="http://schemas.openxmlformats.org/presentationml/2006/main">
   <p:cSld>
-    <p:bg>
-      <p:bgPr>
-        <a:solidFill>
-          <a:schemeClr val="bg1"/>
-        </a:solidFill>
-        <a:effectLst/>
-      </p:bgPr>
-    </p:bg>
     <p:spTree>
       <p:nvGrpSpPr>
         <p:cNvPr id="1" name=""/>
@@ -12472,271 +12655,39 @@
           <a:chExt cx="0" cy="0"/>
         </a:xfrm>
       </p:grpSpPr>
-      <p:sp useBgFill="1">
-        <p:nvSpPr>
-          <p:cNvPr id="21" name="Rectangle 20">
+      <p:pic>
+        <p:nvPicPr>
+          <p:cNvPr id="5" name="Picture 4" descr="The image depicts a map illustrating various water bodies and regions within Utah, including rivers like the Bear River Basin, Salt Lake, and others, with several reservoirs and lakes marked.&#10;&#10;AI-generated content may be incorrect.">
             <a:extLst>
               <a:ext uri="{FF2B5EF4-FFF2-40B4-BE49-F238E27FC236}">
-                <a16:creationId xmlns:a16="http://schemas.microsoft.com/office/drawing/2014/main" id="{44AD29B6-BF3B-4407-9E75-52DF8E3B29F1}"/>
-              </a:ext>
-              <a:ext uri="{C183D7F6-B498-43B3-948B-1728B52AA6E4}">
-                <adec:decorative xmlns:adec="http://schemas.microsoft.com/office/drawing/2017/decorative" val="1"/>
+                <a16:creationId xmlns:a16="http://schemas.microsoft.com/office/drawing/2014/main" id="{E444F844-AF34-AA7D-E2E0-6589D214A168}"/>
               </a:ext>
             </a:extLst>
           </p:cNvPr>
-          <p:cNvSpPr>
-            <a:spLocks noGrp="1" noRot="1" noChangeAspect="1" noMove="1" noResize="1" noEditPoints="1" noAdjustHandles="1" noChangeArrowheads="1" noChangeShapeType="1" noTextEdit="1"/>
-          </p:cNvSpPr>
-          <p:nvPr>
-            <p:extLst>
-              <p:ext uri="{386F3935-93C4-4BCD-93E2-E3B085C9AB24}">
-                <p16:designElem xmlns:p16="http://schemas.microsoft.com/office/powerpoint/2015/main" val="1"/>
-              </p:ext>
-            </p:extLst>
-          </p:nvPr>
-        </p:nvSpPr>
+          <p:cNvPicPr>
+            <a:picLocks noChangeAspect="1"/>
+          </p:cNvPicPr>
+          <p:nvPr/>
+        </p:nvPicPr>
+        <p:blipFill>
+          <a:blip r:embed="rId2"/>
+          <a:stretch>
+            <a:fillRect/>
+          </a:stretch>
+        </p:blipFill>
         <p:spPr>
           <a:xfrm>
-            <a:off x="0" y="0"/>
-            <a:ext cx="12192000" cy="6858000"/>
+            <a:off x="171764" y="154391"/>
+            <a:ext cx="4641385" cy="6315699"/>
           </a:xfrm>
           <a:prstGeom prst="rect">
             <a:avLst/>
           </a:prstGeom>
-          <a:ln>
-            <a:noFill/>
-          </a:ln>
         </p:spPr>
-        <p:style>
-          <a:lnRef idx="2">
-            <a:schemeClr val="accent1">
-              <a:shade val="50000"/>
-            </a:schemeClr>
-          </a:lnRef>
-          <a:fillRef idx="1">
-            <a:schemeClr val="accent1"/>
-          </a:fillRef>
-          <a:effectRef idx="0">
-            <a:schemeClr val="accent1"/>
-          </a:effectRef>
-          <a:fontRef idx="minor">
-            <a:schemeClr val="lt1"/>
-          </a:fontRef>
-        </p:style>
-        <p:txBody>
-          <a:bodyPr rtlCol="0" anchor="ctr"/>
-          <a:lstStyle/>
-          <a:p>
-            <a:pPr algn="ctr"/>
-            <a:endParaRPr lang="en-US"/>
-          </a:p>
-        </p:txBody>
-      </p:sp>
-      <p:sp useBgFill="1">
-        <p:nvSpPr>
-          <p:cNvPr id="23" name="Rectangle 22">
-            <a:extLst>
-              <a:ext uri="{FF2B5EF4-FFF2-40B4-BE49-F238E27FC236}">
-                <a16:creationId xmlns:a16="http://schemas.microsoft.com/office/drawing/2014/main" id="{55F8BA08-3E38-4B70-B93A-74F08E092206}"/>
-              </a:ext>
-              <a:ext uri="{C183D7F6-B498-43B3-948B-1728B52AA6E4}">
-                <adec:decorative xmlns:adec="http://schemas.microsoft.com/office/drawing/2017/decorative" val="1"/>
-              </a:ext>
-            </a:extLst>
-          </p:cNvPr>
-          <p:cNvSpPr>
-            <a:spLocks noGrp="1" noRot="1" noChangeAspect="1" noMove="1" noResize="1" noEditPoints="1" noAdjustHandles="1" noChangeArrowheads="1" noChangeShapeType="1" noTextEdit="1"/>
-          </p:cNvSpPr>
-          <p:nvPr>
-            <p:extLst>
-              <p:ext uri="{386F3935-93C4-4BCD-93E2-E3B085C9AB24}">
-                <p16:designElem xmlns:p16="http://schemas.microsoft.com/office/powerpoint/2015/main" val="1"/>
-              </p:ext>
-            </p:extLst>
-          </p:nvPr>
-        </p:nvSpPr>
-        <p:spPr>
-          <a:xfrm>
-            <a:off x="558209" y="260019"/>
-            <a:ext cx="11167447" cy="5933012"/>
-          </a:xfrm>
-          <a:prstGeom prst="rect">
-            <a:avLst/>
-          </a:prstGeom>
-          <a:ln w="12700">
-            <a:solidFill>
-              <a:srgbClr val="DEDEDE"/>
-            </a:solidFill>
-          </a:ln>
-          <a:effectLst>
-            <a:outerShdw blurRad="50800" dist="38100" dir="2700000" algn="tl" rotWithShape="0">
-              <a:schemeClr val="bg2">
-                <a:lumMod val="85000"/>
-                <a:alpha val="50000"/>
-              </a:schemeClr>
-            </a:outerShdw>
-          </a:effectLst>
-        </p:spPr>
-        <p:style>
-          <a:lnRef idx="2">
-            <a:schemeClr val="accent1">
-              <a:shade val="50000"/>
-            </a:schemeClr>
-          </a:lnRef>
-          <a:fillRef idx="1">
-            <a:schemeClr val="accent1"/>
-          </a:fillRef>
-          <a:effectRef idx="0">
-            <a:schemeClr val="accent1"/>
-          </a:effectRef>
-          <a:fontRef idx="minor">
-            <a:schemeClr val="lt1"/>
-          </a:fontRef>
-        </p:style>
-        <p:txBody>
-          <a:bodyPr rtlCol="0" anchor="ctr"/>
-          <a:lstStyle/>
-          <a:p>
-            <a:pPr marL="0" marR="0" lvl="0" indent="0" algn="ctr" defTabSz="914400" rtl="0" eaLnBrk="1" fontAlgn="auto" latinLnBrk="0" hangingPunct="1">
-              <a:lnSpc>
-                <a:spcPct val="100000"/>
-              </a:lnSpc>
-              <a:spcBef>
-                <a:spcPts val="0"/>
-              </a:spcBef>
-              <a:spcAft>
-                <a:spcPts val="0"/>
-              </a:spcAft>
-              <a:buClrTx/>
-              <a:buSzTx/>
-              <a:buFontTx/>
-              <a:buNone/>
-              <a:tabLst/>
-              <a:defRPr/>
-            </a:pPr>
-            <a:endParaRPr kumimoji="0" lang="en-US" sz="1800" b="0" i="0" u="none" strike="noStrike" kern="1200" cap="none" spc="0" normalizeH="0" baseline="0" noProof="0">
-              <a:ln>
-                <a:noFill/>
-              </a:ln>
-              <a:solidFill>
-                <a:prstClr val="white"/>
-              </a:solidFill>
-              <a:effectLst/>
-              <a:uLnTx/>
-              <a:uFillTx/>
-              <a:latin typeface="Calibri" panose="020F0502020204030204"/>
-              <a:ea typeface="+mn-ea"/>
-              <a:cs typeface="+mn-cs"/>
-            </a:endParaRPr>
-          </a:p>
-        </p:txBody>
-      </p:sp>
-      <p:sp>
-        <p:nvSpPr>
-          <p:cNvPr id="2" name="Title 1">
-            <a:extLst>
-              <a:ext uri="{FF2B5EF4-FFF2-40B4-BE49-F238E27FC236}">
-                <a16:creationId xmlns:a16="http://schemas.microsoft.com/office/drawing/2014/main" id="{82135AE4-D2DF-F18B-908D-5801E8171ADD}"/>
-              </a:ext>
-            </a:extLst>
-          </p:cNvPr>
-          <p:cNvSpPr>
-            <a:spLocks noGrp="1"/>
-          </p:cNvSpPr>
-          <p:nvPr>
-            <p:ph type="title"/>
-          </p:nvPr>
-        </p:nvSpPr>
-        <p:spPr>
-          <a:xfrm>
-            <a:off x="1045029" y="507160"/>
-            <a:ext cx="3266995" cy="5438730"/>
-          </a:xfrm>
-        </p:spPr>
-        <p:txBody>
-          <a:bodyPr>
-            <a:normAutofit/>
-          </a:bodyPr>
-          <a:lstStyle/>
-          <a:p>
-            <a:r>
-              <a:rPr lang="en-US" dirty="0"/>
-              <a:t>Key Assumptions and Ideas</a:t>
-            </a:r>
-          </a:p>
-        </p:txBody>
-      </p:sp>
-      <p:sp>
-        <p:nvSpPr>
-          <p:cNvPr id="25" name="Rectangle 24">
-            <a:extLst>
-              <a:ext uri="{FF2B5EF4-FFF2-40B4-BE49-F238E27FC236}">
-                <a16:creationId xmlns:a16="http://schemas.microsoft.com/office/drawing/2014/main" id="{357F1B33-79AB-4A71-8CEC-4546D709B8C8}"/>
-              </a:ext>
-              <a:ext uri="{C183D7F6-B498-43B3-948B-1728B52AA6E4}">
-                <adec:decorative xmlns:adec="http://schemas.microsoft.com/office/drawing/2017/decorative" val="1"/>
-              </a:ext>
-            </a:extLst>
-          </p:cNvPr>
-          <p:cNvSpPr>
-            <a:spLocks noGrp="1" noRot="1" noChangeAspect="1" noMove="1" noResize="1" noEditPoints="1" noAdjustHandles="1" noChangeArrowheads="1" noChangeShapeType="1" noTextEdit="1"/>
-          </p:cNvSpPr>
-          <p:nvPr>
-            <p:extLst>
-              <p:ext uri="{386F3935-93C4-4BCD-93E2-E3B085C9AB24}">
-                <p16:designElem xmlns:p16="http://schemas.microsoft.com/office/powerpoint/2015/main" val="1"/>
-              </p:ext>
-            </p:extLst>
-          </p:nvPr>
-        </p:nvSpPr>
-        <p:spPr>
-          <a:xfrm>
-            <a:off x="498834" y="2874481"/>
-            <a:ext cx="128016" cy="704088"/>
-          </a:xfrm>
-          <a:prstGeom prst="rect">
-            <a:avLst/>
-          </a:prstGeom>
-          <a:solidFill>
-            <a:schemeClr val="accent2"/>
-          </a:solidFill>
-          <a:ln>
-            <a:noFill/>
-          </a:ln>
-        </p:spPr>
-        <p:style>
-          <a:lnRef idx="2">
-            <a:schemeClr val="accent1">
-              <a:shade val="50000"/>
-            </a:schemeClr>
-          </a:lnRef>
-          <a:fillRef idx="1">
-            <a:schemeClr val="accent1"/>
-          </a:fillRef>
-          <a:effectRef idx="0">
-            <a:schemeClr val="accent1"/>
-          </a:effectRef>
-          <a:fontRef idx="minor">
-            <a:schemeClr val="lt1"/>
-          </a:fontRef>
-        </p:style>
-        <p:txBody>
-          <a:bodyPr rtlCol="0" anchor="ctr"/>
-          <a:lstStyle/>
-          <a:p>
-            <a:pPr algn="ctr"/>
-            <a:endParaRPr lang="en-US">
-              <a:solidFill>
-                <a:prstClr val="white"/>
-              </a:solidFill>
-              <a:latin typeface="Calibri" panose="020F0502020204030204"/>
-            </a:endParaRPr>
-          </a:p>
-        </p:txBody>
-      </p:sp>
+      </p:pic>
       <p:graphicFrame>
         <p:nvGraphicFramePr>
-          <p:cNvPr id="5" name="Content Placeholder 2">
+          <p:cNvPr id="6" name="Content Placeholder 2">
             <a:extLst>
               <a:ext uri="{FF2B5EF4-FFF2-40B4-BE49-F238E27FC236}">
                 <a16:creationId xmlns:a16="http://schemas.microsoft.com/office/drawing/2014/main" id="{7990CB0E-8803-D419-DBC6-4068A222A4E0}"/>
@@ -12744,31 +12695,30 @@
             </a:extLst>
           </p:cNvPr>
           <p:cNvGraphicFramePr>
-            <a:graphicFrameLocks noGrp="1"/>
+            <a:graphicFrameLocks/>
           </p:cNvGraphicFramePr>
           <p:nvPr>
-            <p:ph idx="1"/>
             <p:extLst>
               <p:ext uri="{D42A27DB-BD31-4B8C-83A1-F6EECF244321}">
-                <p14:modId xmlns:p14="http://schemas.microsoft.com/office/powerpoint/2010/main" val="398504165"/>
+                <p14:modId xmlns:p14="http://schemas.microsoft.com/office/powerpoint/2010/main" val="889738938"/>
               </p:ext>
             </p:extLst>
           </p:nvPr>
         </p:nvGraphicFramePr>
         <p:xfrm>
-          <a:off x="4526280" y="74428"/>
+          <a:off x="5189668" y="217864"/>
           <a:ext cx="6830568" cy="6783572"/>
         </p:xfrm>
         <a:graphic>
           <a:graphicData uri="http://schemas.openxmlformats.org/drawingml/2006/diagram">
-            <dgm:relIds xmlns:dgm="http://schemas.openxmlformats.org/drawingml/2006/diagram" xmlns:r="http://schemas.openxmlformats.org/officeDocument/2006/relationships" r:dm="rId2" r:lo="rId3" r:qs="rId4" r:cs="rId5"/>
+            <dgm:relIds xmlns:dgm="http://schemas.openxmlformats.org/drawingml/2006/diagram" xmlns:r="http://schemas.openxmlformats.org/officeDocument/2006/relationships" r:dm="rId3" r:lo="rId4" r:qs="rId5" r:cs="rId6"/>
           </a:graphicData>
         </a:graphic>
       </p:graphicFrame>
     </p:spTree>
     <p:extLst>
       <p:ext uri="{BB962C8B-B14F-4D97-AF65-F5344CB8AC3E}">
-        <p14:creationId xmlns:p14="http://schemas.microsoft.com/office/powerpoint/2010/main" val="1860897597"/>
+        <p14:creationId xmlns:p14="http://schemas.microsoft.com/office/powerpoint/2010/main" val="1077105498"/>
       </p:ext>
     </p:extLst>
   </p:cSld>
@@ -12808,7 +12758,7 @@
           <p:nvPr>
             <p:extLst>
               <p:ext uri="{D42A27DB-BD31-4B8C-83A1-F6EECF244321}">
-                <p14:modId xmlns:p14="http://schemas.microsoft.com/office/powerpoint/2010/main" val="1027488444"/>
+                <p14:modId xmlns:p14="http://schemas.microsoft.com/office/powerpoint/2010/main" val="3276213830"/>
               </p:ext>
             </p:extLst>
           </p:nvPr>

</xml_diff>

<commit_message>
Add more sample strategies
</commit_message>
<xml_diff>
--- a/Session Guide/IntroPresentation.pptx
+++ b/Session Guide/IntroPresentation.pptx
@@ -123,6 +123,7 @@
 <p1510:revInfo xmlns:a="http://schemas.openxmlformats.org/drawingml/2006/main" xmlns:r="http://schemas.openxmlformats.org/officeDocument/2006/relationships" xmlns:p1510="http://schemas.microsoft.com/office/powerpoint/2015/10/main">
   <p1510:revLst>
     <p1510:client id="{0FA96045-9951-4B0B-BD62-76A4AB30A5F9}" v="10" dt="2026-08-24T23:19:05.277"/>
+    <p1510:client id="{BE72FB7B-DAE7-44E6-A59E-4031D98A4453}" v="1" dt="2026-08-25T17:57:17.673"/>
   </p1510:revLst>
 </p1510:revInfo>
 </file>
@@ -132,18 +133,18 @@
   <pc:docChgLst>
     <pc:chgData name="Hadia Akbar" userId="19362115565_tp_box_2" providerId="OAuth2" clId="{FF77DECD-7ECC-48F4-BF82-9D4D4E0BE774}"/>
     <pc:docChg chg="undo redo custSel addSld delSld modSld sldOrd delMainMaster">
-      <pc:chgData name="Hadia Akbar" userId="19362115565_tp_box_2" providerId="OAuth2" clId="{FF77DECD-7ECC-48F4-BF82-9D4D4E0BE774}" dt="2026-08-24T23:19:05.277" v="2465" actId="12090"/>
+      <pc:chgData name="Hadia Akbar" userId="19362115565_tp_box_2" providerId="OAuth2" clId="{FF77DECD-7ECC-48F4-BF82-9D4D4E0BE774}" dt="2026-08-25T18:40:44.123" v="2533" actId="1076"/>
       <pc:docMkLst>
         <pc:docMk/>
       </pc:docMkLst>
       <pc:sldChg chg="addSp delSp modSp new mod setBg addAnim modAnim delDesignElem">
-        <pc:chgData name="Hadia Akbar" userId="19362115565_tp_box_2" providerId="OAuth2" clId="{FF77DECD-7ECC-48F4-BF82-9D4D4E0BE774}" dt="2026-08-24T23:07:31.014" v="2247" actId="1076"/>
+        <pc:chgData name="Hadia Akbar" userId="19362115565_tp_box_2" providerId="OAuth2" clId="{FF77DECD-7ECC-48F4-BF82-9D4D4E0BE774}" dt="2026-08-25T17:55:47.286" v="2470" actId="1076"/>
         <pc:sldMkLst>
           <pc:docMk/>
           <pc:sldMk cId="4246612416" sldId="256"/>
         </pc:sldMkLst>
         <pc:spChg chg="mod">
-          <ac:chgData name="Hadia Akbar" userId="19362115565_tp_box_2" providerId="OAuth2" clId="{FF77DECD-7ECC-48F4-BF82-9D4D4E0BE774}" dt="2026-08-24T23:06:46.212" v="2225" actId="1076"/>
+          <ac:chgData name="Hadia Akbar" userId="19362115565_tp_box_2" providerId="OAuth2" clId="{FF77DECD-7ECC-48F4-BF82-9D4D4E0BE774}" dt="2026-08-25T17:55:47.286" v="2470" actId="1076"/>
           <ac:spMkLst>
             <pc:docMk/>
             <pc:sldMk cId="4246612416" sldId="256"/>
@@ -216,13 +217,13 @@
         </pc:picChg>
       </pc:sldChg>
       <pc:sldChg chg="addSp delSp modSp add mod">
-        <pc:chgData name="Hadia Akbar" userId="19362115565_tp_box_2" providerId="OAuth2" clId="{FF77DECD-7ECC-48F4-BF82-9D4D4E0BE774}" dt="2026-08-24T23:19:05.277" v="2465" actId="12090"/>
+        <pc:chgData name="Hadia Akbar" userId="19362115565_tp_box_2" providerId="OAuth2" clId="{FF77DECD-7ECC-48F4-BF82-9D4D4E0BE774}" dt="2026-08-25T17:57:38.535" v="2508" actId="20577"/>
         <pc:sldMkLst>
           <pc:docMk/>
           <pc:sldMk cId="3397881947" sldId="258"/>
         </pc:sldMkLst>
         <pc:spChg chg="add mod">
-          <ac:chgData name="Hadia Akbar" userId="19362115565_tp_box_2" providerId="OAuth2" clId="{FF77DECD-7ECC-48F4-BF82-9D4D4E0BE774}" dt="2026-08-06T17:56:02.933" v="2156" actId="20577"/>
+          <ac:chgData name="Hadia Akbar" userId="19362115565_tp_box_2" providerId="OAuth2" clId="{FF77DECD-7ECC-48F4-BF82-9D4D4E0BE774}" dt="2026-08-25T17:56:57.966" v="2477" actId="1076"/>
           <ac:spMkLst>
             <pc:docMk/>
             <pc:sldMk cId="3397881947" sldId="258"/>
@@ -230,7 +231,7 @@
           </ac:spMkLst>
         </pc:spChg>
         <pc:graphicFrameChg chg="mod modGraphic">
-          <ac:chgData name="Hadia Akbar" userId="19362115565_tp_box_2" providerId="OAuth2" clId="{FF77DECD-7ECC-48F4-BF82-9D4D4E0BE774}" dt="2026-08-24T23:19:05.277" v="2465" actId="12090"/>
+          <ac:chgData name="Hadia Akbar" userId="19362115565_tp_box_2" providerId="OAuth2" clId="{FF77DECD-7ECC-48F4-BF82-9D4D4E0BE774}" dt="2026-08-25T17:57:38.535" v="2508" actId="20577"/>
           <ac:graphicFrameMkLst>
             <pc:docMk/>
             <pc:sldMk cId="3397881947" sldId="258"/>
@@ -332,13 +333,13 @@
         </pc:picChg>
       </pc:sldChg>
       <pc:sldChg chg="addSp modSp new mod ord">
-        <pc:chgData name="Hadia Akbar" userId="19362115565_tp_box_2" providerId="OAuth2" clId="{FF77DECD-7ECC-48F4-BF82-9D4D4E0BE774}" dt="2026-08-24T23:16:18.208" v="2438" actId="1076"/>
+        <pc:chgData name="Hadia Akbar" userId="19362115565_tp_box_2" providerId="OAuth2" clId="{FF77DECD-7ECC-48F4-BF82-9D4D4E0BE774}" dt="2026-08-25T18:40:44.123" v="2533" actId="1076"/>
         <pc:sldMkLst>
           <pc:docMk/>
           <pc:sldMk cId="1233494780" sldId="264"/>
         </pc:sldMkLst>
         <pc:spChg chg="add mod">
-          <ac:chgData name="Hadia Akbar" userId="19362115565_tp_box_2" providerId="OAuth2" clId="{FF77DECD-7ECC-48F4-BF82-9D4D4E0BE774}" dt="2026-08-24T23:14:29.194" v="2364"/>
+          <ac:chgData name="Hadia Akbar" userId="19362115565_tp_box_2" providerId="OAuth2" clId="{FF77DECD-7ECC-48F4-BF82-9D4D4E0BE774}" dt="2026-08-25T18:40:44.123" v="2533" actId="1076"/>
           <ac:spMkLst>
             <pc:docMk/>
             <pc:sldMk cId="1233494780" sldId="264"/>
@@ -346,7 +347,7 @@
           </ac:spMkLst>
         </pc:spChg>
         <pc:spChg chg="add mod">
-          <ac:chgData name="Hadia Akbar" userId="19362115565_tp_box_2" providerId="OAuth2" clId="{FF77DECD-7ECC-48F4-BF82-9D4D4E0BE774}" dt="2026-08-24T23:15:27.979" v="2401" actId="1076"/>
+          <ac:chgData name="Hadia Akbar" userId="19362115565_tp_box_2" providerId="OAuth2" clId="{FF77DECD-7ECC-48F4-BF82-9D4D4E0BE774}" dt="2026-08-25T18:39:37.737" v="2516" actId="1076"/>
           <ac:spMkLst>
             <pc:docMk/>
             <pc:sldMk cId="1233494780" sldId="264"/>
@@ -354,7 +355,7 @@
           </ac:spMkLst>
         </pc:spChg>
         <pc:spChg chg="add mod">
-          <ac:chgData name="Hadia Akbar" userId="19362115565_tp_box_2" providerId="OAuth2" clId="{FF77DECD-7ECC-48F4-BF82-9D4D4E0BE774}" dt="2026-08-24T23:15:41.830" v="2404"/>
+          <ac:chgData name="Hadia Akbar" userId="19362115565_tp_box_2" providerId="OAuth2" clId="{FF77DECD-7ECC-48F4-BF82-9D4D4E0BE774}" dt="2026-08-25T18:40:33.218" v="2530" actId="1076"/>
           <ac:spMkLst>
             <pc:docMk/>
             <pc:sldMk cId="1233494780" sldId="264"/>
@@ -362,7 +363,7 @@
           </ac:spMkLst>
         </pc:spChg>
         <pc:spChg chg="add mod">
-          <ac:chgData name="Hadia Akbar" userId="19362115565_tp_box_2" providerId="OAuth2" clId="{FF77DECD-7ECC-48F4-BF82-9D4D4E0BE774}" dt="2026-08-24T23:16:18.208" v="2438" actId="1076"/>
+          <ac:chgData name="Hadia Akbar" userId="19362115565_tp_box_2" providerId="OAuth2" clId="{FF77DECD-7ECC-48F4-BF82-9D4D4E0BE774}" dt="2026-08-25T18:40:22.757" v="2529" actId="1076"/>
           <ac:spMkLst>
             <pc:docMk/>
             <pc:sldMk cId="1233494780" sldId="264"/>
@@ -370,7 +371,7 @@
           </ac:spMkLst>
         </pc:spChg>
         <pc:picChg chg="add mod modCrop">
-          <ac:chgData name="Hadia Akbar" userId="19362115565_tp_box_2" providerId="OAuth2" clId="{FF77DECD-7ECC-48F4-BF82-9D4D4E0BE774}" dt="2026-08-24T23:15:17.685" v="2398" actId="1035"/>
+          <ac:chgData name="Hadia Akbar" userId="19362115565_tp_box_2" providerId="OAuth2" clId="{FF77DECD-7ECC-48F4-BF82-9D4D4E0BE774}" dt="2026-08-25T18:40:19.720" v="2528" actId="1076"/>
           <ac:picMkLst>
             <pc:docMk/>
             <pc:sldMk cId="1233494780" sldId="264"/>
@@ -2650,7 +2651,14 @@
     </dgm:pt>
     <dgm:pt modelId="{FB1AC2EB-2A73-487E-BFFC-E85DCC33CF70}">
       <dgm:prSet phldrT="[Text]" phldr="0" custT="1"/>
-      <dgm:spPr/>
+      <dgm:spPr>
+        <a:solidFill>
+          <a:schemeClr val="accent2">
+            <a:lumMod val="20000"/>
+            <a:lumOff val="80000"/>
+          </a:schemeClr>
+        </a:solidFill>
+      </dgm:spPr>
       <dgm:t>
         <a:bodyPr/>
         <a:lstStyle/>
@@ -2690,7 +2698,14 @@
     </dgm:pt>
     <dgm:pt modelId="{EB9EEFA8-E354-4F52-BA0E-F1E23DACFF23}">
       <dgm:prSet phldrT="[Text]" phldr="0" custT="1"/>
-      <dgm:spPr/>
+      <dgm:spPr>
+        <a:solidFill>
+          <a:schemeClr val="accent2">
+            <a:lumMod val="20000"/>
+            <a:lumOff val="80000"/>
+          </a:schemeClr>
+        </a:solidFill>
+      </dgm:spPr>
       <dgm:t>
         <a:bodyPr/>
         <a:lstStyle/>
@@ -2854,49 +2869,16 @@
         </a:p>
       </dgm:t>
     </dgm:pt>
-    <dgm:pt modelId="{3679B97A-32D2-4172-BEF9-560A1496BE56}">
+    <dgm:pt modelId="{067E8FF9-061C-4CD3-A921-26E66C8903EA}">
       <dgm:prSet phldrT="[Text]" phldr="0" custT="1"/>
-      <dgm:spPr/>
-      <dgm:t>
-        <a:bodyPr/>
-        <a:lstStyle/>
-        <a:p>
-          <a:r>
-            <a:rPr lang="en-US" sz="1600" b="1" dirty="0">
-              <a:solidFill>
-                <a:srgbClr val="3333FF"/>
-              </a:solidFill>
-            </a:rPr>
-            <a:t>Negotiate Price</a:t>
-          </a:r>
-        </a:p>
-      </dgm:t>
-    </dgm:pt>
-    <dgm:pt modelId="{B180FB7C-C893-47CE-AC8C-F0A6527F33DC}" type="parTrans" cxnId="{A16A5AFB-4236-4673-9CB5-BE389EB3EF8C}">
-      <dgm:prSet/>
-      <dgm:spPr/>
-      <dgm:t>
-        <a:bodyPr/>
-        <a:lstStyle/>
-        <a:p>
-          <a:endParaRPr lang="en-US"/>
-        </a:p>
-      </dgm:t>
-    </dgm:pt>
-    <dgm:pt modelId="{0D2383D4-47E1-4D36-90BF-8D7B53F07E5B}" type="sibTrans" cxnId="{A16A5AFB-4236-4673-9CB5-BE389EB3EF8C}">
-      <dgm:prSet/>
-      <dgm:spPr/>
-      <dgm:t>
-        <a:bodyPr/>
-        <a:lstStyle/>
-        <a:p>
-          <a:endParaRPr lang="en-US"/>
-        </a:p>
-      </dgm:t>
-    </dgm:pt>
-    <dgm:pt modelId="{428AB112-F44A-4DBD-9A72-307227A48835}">
-      <dgm:prSet phldrT="[Text]" phldr="0" custT="1"/>
-      <dgm:spPr/>
+      <dgm:spPr>
+        <a:solidFill>
+          <a:schemeClr val="accent2">
+            <a:lumMod val="20000"/>
+            <a:lumOff val="80000"/>
+          </a:schemeClr>
+        </a:solidFill>
+      </dgm:spPr>
       <dgm:t>
         <a:bodyPr/>
         <a:lstStyle/>
@@ -2912,27 +2894,46 @@
         </a:p>
       </dgm:t>
     </dgm:pt>
-    <dgm:pt modelId="{DE48C9E4-0BEC-4D80-A91C-82920DE858EA}" type="parTrans" cxnId="{6B257843-4F5E-4AFE-A2EB-DCD7EC2836DE}">
+    <dgm:pt modelId="{4BDED4F2-CDF9-49DB-8ABB-3FB5C36045BA}" type="parTrans" cxnId="{FB0716F9-6BD9-4536-8DCF-134146E022B6}">
       <dgm:prSet/>
       <dgm:spPr/>
+    </dgm:pt>
+    <dgm:pt modelId="{94AFE86B-7BC3-489D-8D06-70F5EE494AE4}" type="sibTrans" cxnId="{FB0716F9-6BD9-4536-8DCF-134146E022B6}">
+      <dgm:prSet/>
+      <dgm:spPr/>
+    </dgm:pt>
+    <dgm:pt modelId="{463F1166-29D7-4D0E-BEAE-3FEA4539912F}">
+      <dgm:prSet phldrT="[Text]" phldr="0" custT="1"/>
+      <dgm:spPr>
+        <a:solidFill>
+          <a:schemeClr val="accent2">
+            <a:lumMod val="20000"/>
+            <a:lumOff val="80000"/>
+          </a:schemeClr>
+        </a:solidFill>
+      </dgm:spPr>
       <dgm:t>
         <a:bodyPr/>
         <a:lstStyle/>
         <a:p>
-          <a:endParaRPr lang="en-US"/>
+          <a:r>
+            <a:rPr lang="en-US" sz="1600" b="1" dirty="0">
+              <a:solidFill>
+                <a:srgbClr val="3333FF"/>
+              </a:solidFill>
+            </a:rPr>
+            <a:t>Negotiate Price with the bank</a:t>
+          </a:r>
         </a:p>
       </dgm:t>
     </dgm:pt>
-    <dgm:pt modelId="{364B18D5-CB61-44ED-85B8-E92D9EE279E9}" type="sibTrans" cxnId="{6B257843-4F5E-4AFE-A2EB-DCD7EC2836DE}">
+    <dgm:pt modelId="{4FCCC525-2284-43CB-B379-561F45AA5620}" type="parTrans" cxnId="{E9390139-F794-4D9D-8BD8-8206907484F4}">
       <dgm:prSet/>
       <dgm:spPr/>
-      <dgm:t>
-        <a:bodyPr/>
-        <a:lstStyle/>
-        <a:p>
-          <a:endParaRPr lang="en-US"/>
-        </a:p>
-      </dgm:t>
+    </dgm:pt>
+    <dgm:pt modelId="{D965F5A8-311F-48EC-8A78-501A3170B2FD}" type="sibTrans" cxnId="{E9390139-F794-4D9D-8BD8-8206907484F4}">
+      <dgm:prSet/>
+      <dgm:spPr/>
     </dgm:pt>
     <dgm:pt modelId="{1641139E-5806-4ED1-AA40-CDBBD9ABB873}" type="pres">
       <dgm:prSet presAssocID="{99D1A08B-05C7-4294-99DD-7BE56AF469A8}" presName="Name0" presStyleCnt="0">
@@ -3118,81 +3119,81 @@
     </dgm:pt>
   </dgm:ptLst>
   <dgm:cxnLst>
+    <dgm:cxn modelId="{3DC6A201-5771-43DA-B9D7-5C5BDCF46D32}" type="presOf" srcId="{067E8FF9-061C-4CD3-A921-26E66C8903EA}" destId="{686EF4F2-C186-45B2-85A0-F6687D978556}" srcOrd="0" destOrd="2" presId="urn:microsoft.com/office/officeart/2005/8/layout/hProcess4"/>
     <dgm:cxn modelId="{792D4403-5B5E-411A-82AE-D483DFE10AAB}" srcId="{99D1A08B-05C7-4294-99DD-7BE56AF469A8}" destId="{5DA50F34-C831-4850-8B63-CE799FF6C0D5}" srcOrd="3" destOrd="0" parTransId="{B7130E8A-5AA5-407D-9187-C73B81606744}" sibTransId="{27D0D650-91D1-4215-B213-38A33A97C818}"/>
     <dgm:cxn modelId="{22D14C08-B102-444F-8400-735B14327DF4}" srcId="{1BCB95D6-B1A4-439C-9AD1-CE00E32D68AA}" destId="{EB9EEFA8-E354-4F52-BA0E-F1E23DACFF23}" srcOrd="1" destOrd="0" parTransId="{FBDD0822-3C20-4EF0-B91D-23A882EE7DCF}" sibTransId="{81CF5625-CEBF-44C9-BA20-42ED0CDF8DE9}"/>
-    <dgm:cxn modelId="{3AA8EF0A-0856-4B67-8239-D4811C9B9A20}" type="presOf" srcId="{36A43055-FF1E-4000-92DC-E1996435069B}" destId="{3A5BFE43-F020-43A7-BFCC-87B32E6976A9}" srcOrd="1" destOrd="0" presId="urn:microsoft.com/office/officeart/2005/8/layout/hProcess4"/>
+    <dgm:cxn modelId="{B2114C0C-9AC9-41D6-8A6B-DA4291CE8593}" type="presOf" srcId="{5C407219-177A-43EE-B67E-B6E75271BA5B}" destId="{22CBB4AF-36EB-417C-B703-FAF0662ACF49}" srcOrd="0" destOrd="0" presId="urn:microsoft.com/office/officeart/2005/8/layout/hProcess4"/>
     <dgm:cxn modelId="{0695140D-8D64-47F6-820C-E3C788A10897}" srcId="{5C407219-177A-43EE-B67E-B6E75271BA5B}" destId="{269C76F2-6A3F-4463-A37D-34DF9557723A}" srcOrd="1" destOrd="0" parTransId="{6FBEEE41-A564-4BEC-881C-34C8762D68EC}" sibTransId="{45AFFE97-47BA-4DAA-829A-7C59AE051FBD}"/>
-    <dgm:cxn modelId="{E2C1BF0F-D514-4126-8BC4-A61CBF22795D}" type="presOf" srcId="{FB1AC2EB-2A73-487E-BFFC-E85DCC33CF70}" destId="{686EF4F2-C186-45B2-85A0-F6687D978556}" srcOrd="0" destOrd="0" presId="urn:microsoft.com/office/officeart/2005/8/layout/hProcess4"/>
-    <dgm:cxn modelId="{C28AC818-B414-421E-8463-AB316EB8EB6D}" type="presOf" srcId="{97225384-B3A3-4246-BB0C-554A34D4B7EE}" destId="{21C25EF7-5122-4CB4-922C-C536D59390E7}" srcOrd="1" destOrd="0" presId="urn:microsoft.com/office/officeart/2005/8/layout/hProcess4"/>
-    <dgm:cxn modelId="{64ECB721-0461-41EC-8F41-CB09C952C4FE}" type="presOf" srcId="{5C407219-177A-43EE-B67E-B6E75271BA5B}" destId="{22CBB4AF-36EB-417C-B703-FAF0662ACF49}" srcOrd="0" destOrd="0" presId="urn:microsoft.com/office/officeart/2005/8/layout/hProcess4"/>
+    <dgm:cxn modelId="{68DDD513-74E0-4FBC-A484-DA1F093513A4}" type="presOf" srcId="{463F1166-29D7-4D0E-BEAE-3FEA4539912F}" destId="{22FAA828-71BC-4F47-855C-19152EC671EC}" srcOrd="1" destOrd="3" presId="urn:microsoft.com/office/officeart/2005/8/layout/hProcess4"/>
+    <dgm:cxn modelId="{571D9C18-79A1-4301-8875-8859B57A90DF}" type="presOf" srcId="{0C420126-164A-4514-A51E-AB2C4502F253}" destId="{74F3F80A-8B0F-4F29-B321-AD28639C9105}" srcOrd="0" destOrd="0" presId="urn:microsoft.com/office/officeart/2005/8/layout/hProcess4"/>
+    <dgm:cxn modelId="{CF03821E-C648-4156-9BF5-EB8FEF4BE68F}" type="presOf" srcId="{8E1FD376-005E-46DD-AB7C-3AD5F0C68AF6}" destId="{464DE029-02A1-4763-8666-F53A13C6FAAD}" srcOrd="0" destOrd="0" presId="urn:microsoft.com/office/officeart/2005/8/layout/hProcess4"/>
+    <dgm:cxn modelId="{6B1BAF1E-47AC-4383-AA5B-E6E6B7165D83}" type="presOf" srcId="{18DC73F0-EDC3-4451-98EA-91C847F5E375}" destId="{D9BDC29B-7D63-4495-A3B2-7C07F9B8C330}" srcOrd="0" destOrd="1" presId="urn:microsoft.com/office/officeart/2005/8/layout/hProcess4"/>
     <dgm:cxn modelId="{440F9726-70B7-42A5-AB88-B53C3894826F}" srcId="{269C76F2-6A3F-4463-A37D-34DF9557723A}" destId="{DCFD0921-E245-4A02-B3A7-0E9B55127B04}" srcOrd="0" destOrd="0" parTransId="{70B824C9-F3CD-40A2-B5BA-784C85902FF3}" sibTransId="{69013C8D-2C94-4B00-9813-3B8C02617849}"/>
     <dgm:cxn modelId="{F305BA26-4492-4867-9F9B-5A8ACF3514B4}" srcId="{5DA50F34-C831-4850-8B63-CE799FF6C0D5}" destId="{F945E611-CD2E-4C69-9DAE-2D0D3822A0EA}" srcOrd="1" destOrd="0" parTransId="{E05F5CE7-8C2A-4ACE-81D4-21183E002FC5}" sibTransId="{25BB5900-0641-407C-8ED9-9C929C16D5E9}"/>
-    <dgm:cxn modelId="{5997E327-E8CC-401F-8736-7BC1AA7001BC}" type="presOf" srcId="{8111E655-AA73-4919-8D88-D2AFAC6203BA}" destId="{3C445FF9-93F1-4683-A6D2-EC9DB43AA93D}" srcOrd="1" destOrd="0" presId="urn:microsoft.com/office/officeart/2005/8/layout/hProcess4"/>
-    <dgm:cxn modelId="{E8CA3328-6D59-4724-88B8-D6684CCFD216}" type="presOf" srcId="{F945E611-CD2E-4C69-9DAE-2D0D3822A0EA}" destId="{3C445FF9-93F1-4683-A6D2-EC9DB43AA93D}" srcOrd="1" destOrd="1" presId="urn:microsoft.com/office/officeart/2005/8/layout/hProcess4"/>
+    <dgm:cxn modelId="{77073B2A-B0D1-4503-ADA9-FF4494A3E902}" type="presOf" srcId="{463F1166-29D7-4D0E-BEAE-3FEA4539912F}" destId="{686EF4F2-C186-45B2-85A0-F6687D978556}" srcOrd="0" destOrd="3" presId="urn:microsoft.com/office/officeart/2005/8/layout/hProcess4"/>
+    <dgm:cxn modelId="{3F01E32A-C783-4512-AA9F-A382056589FF}" type="presOf" srcId="{A5277286-5511-4E9A-9AF8-737B622E3223}" destId="{1C299799-9D54-457B-A3C7-0FB93A410866}" srcOrd="0" destOrd="0" presId="urn:microsoft.com/office/officeart/2005/8/layout/hProcess4"/>
     <dgm:cxn modelId="{1D8D772B-181D-4909-B145-E899F3EF30EF}" type="presOf" srcId="{99D1A08B-05C7-4294-99DD-7BE56AF469A8}" destId="{1641139E-5806-4ED1-AA40-CDBBD9ABB873}" srcOrd="0" destOrd="0" presId="urn:microsoft.com/office/officeart/2005/8/layout/hProcess4"/>
-    <dgm:cxn modelId="{F1D3D530-B984-418C-B652-57E1E301F4DE}" type="presOf" srcId="{0C420126-164A-4514-A51E-AB2C4502F253}" destId="{74F3F80A-8B0F-4F29-B321-AD28639C9105}" srcOrd="0" destOrd="0" presId="urn:microsoft.com/office/officeart/2005/8/layout/hProcess4"/>
-    <dgm:cxn modelId="{1629ED30-2BD7-424A-906E-0DAD0AA696C2}" type="presOf" srcId="{F945E611-CD2E-4C69-9DAE-2D0D3822A0EA}" destId="{DE4AC59B-B8E8-4AE0-82DC-3BD6B4ADF27A}" srcOrd="0" destOrd="1" presId="urn:microsoft.com/office/officeart/2005/8/layout/hProcess4"/>
+    <dgm:cxn modelId="{04320F2C-8EB7-4DC8-94C8-FB84A97372FE}" type="presOf" srcId="{269C76F2-6A3F-4463-A37D-34DF9557723A}" destId="{30DD4CDA-4812-46C7-BA95-FF21DAD772D9}" srcOrd="0" destOrd="1" presId="urn:microsoft.com/office/officeart/2005/8/layout/hProcess4"/>
+    <dgm:cxn modelId="{C64CED34-0BC3-41A2-81AE-DF9E04A7B236}" type="presOf" srcId="{EB9EEFA8-E354-4F52-BA0E-F1E23DACFF23}" destId="{686EF4F2-C186-45B2-85A0-F6687D978556}" srcOrd="0" destOrd="1" presId="urn:microsoft.com/office/officeart/2005/8/layout/hProcess4"/>
     <dgm:cxn modelId="{63DD5235-EEA8-4C62-812F-84E36FEF1592}" srcId="{1BCB95D6-B1A4-439C-9AD1-CE00E32D68AA}" destId="{FB1AC2EB-2A73-487E-BFFC-E85DCC33CF70}" srcOrd="0" destOrd="0" parTransId="{E19BCDDB-747D-419A-A20E-A9AAFEF8A011}" sibTransId="{86A587C2-A658-4B6E-9679-4F54844F90F0}"/>
-    <dgm:cxn modelId="{178C6A5B-5781-42D4-90C0-2603702C6FEC}" type="presOf" srcId="{3679B97A-32D2-4172-BEF9-560A1496BE56}" destId="{22FAA828-71BC-4F47-855C-19152EC671EC}" srcOrd="1" destOrd="3" presId="urn:microsoft.com/office/officeart/2005/8/layout/hProcess4"/>
-    <dgm:cxn modelId="{B640D65E-9BAB-40E1-9A90-1DF268BFCE38}" type="presOf" srcId="{8E1FD376-005E-46DD-AB7C-3AD5F0C68AF6}" destId="{464DE029-02A1-4763-8666-F53A13C6FAAD}" srcOrd="0" destOrd="0" presId="urn:microsoft.com/office/officeart/2005/8/layout/hProcess4"/>
-    <dgm:cxn modelId="{CA3F9942-3020-409B-85BB-456C14616609}" type="presOf" srcId="{18DC73F0-EDC3-4451-98EA-91C847F5E375}" destId="{3A5BFE43-F020-43A7-BFCC-87B32E6976A9}" srcOrd="1" destOrd="1" presId="urn:microsoft.com/office/officeart/2005/8/layout/hProcess4"/>
-    <dgm:cxn modelId="{6B257843-4F5E-4AFE-A2EB-DCD7EC2836DE}" srcId="{EB9EEFA8-E354-4F52-BA0E-F1E23DACFF23}" destId="{428AB112-F44A-4DBD-9A72-307227A48835}" srcOrd="0" destOrd="0" parTransId="{DE48C9E4-0BEC-4D80-A91C-82920DE858EA}" sibTransId="{364B18D5-CB61-44ED-85B8-E92D9EE279E9}"/>
+    <dgm:cxn modelId="{E9390139-F794-4D9D-8BD8-8206907484F4}" srcId="{1BCB95D6-B1A4-439C-9AD1-CE00E32D68AA}" destId="{463F1166-29D7-4D0E-BEAE-3FEA4539912F}" srcOrd="3" destOrd="0" parTransId="{4FCCC525-2284-43CB-B379-561F45AA5620}" sibTransId="{D965F5A8-311F-48EC-8A78-501A3170B2FD}"/>
+    <dgm:cxn modelId="{B7AB723B-6EC3-4C62-84FF-6E1D5EA1F9CB}" type="presOf" srcId="{97225384-B3A3-4246-BB0C-554A34D4B7EE}" destId="{30DD4CDA-4812-46C7-BA95-FF21DAD772D9}" srcOrd="0" destOrd="0" presId="urn:microsoft.com/office/officeart/2005/8/layout/hProcess4"/>
+    <dgm:cxn modelId="{E02FD53C-0E3C-4F7A-BB14-6DE44DDED801}" type="presOf" srcId="{18DC73F0-EDC3-4451-98EA-91C847F5E375}" destId="{3A5BFE43-F020-43A7-BFCC-87B32E6976A9}" srcOrd="1" destOrd="1" presId="urn:microsoft.com/office/officeart/2005/8/layout/hProcess4"/>
+    <dgm:cxn modelId="{C7202E40-7748-4972-8B42-9BA792EEF703}" type="presOf" srcId="{8111E655-AA73-4919-8D88-D2AFAC6203BA}" destId="{DE4AC59B-B8E8-4AE0-82DC-3BD6B4ADF27A}" srcOrd="0" destOrd="0" presId="urn:microsoft.com/office/officeart/2005/8/layout/hProcess4"/>
+    <dgm:cxn modelId="{8A4D0D43-928B-40DF-A566-5650AD89ADFD}" type="presOf" srcId="{F945E611-CD2E-4C69-9DAE-2D0D3822A0EA}" destId="{DE4AC59B-B8E8-4AE0-82DC-3BD6B4ADF27A}" srcOrd="0" destOrd="1" presId="urn:microsoft.com/office/officeart/2005/8/layout/hProcess4"/>
+    <dgm:cxn modelId="{D1412143-9041-4B79-A22D-37B6C3E0698C}" type="presOf" srcId="{067E8FF9-061C-4CD3-A921-26E66C8903EA}" destId="{22FAA828-71BC-4F47-855C-19152EC671EC}" srcOrd="1" destOrd="2" presId="urn:microsoft.com/office/officeart/2005/8/layout/hProcess4"/>
+    <dgm:cxn modelId="{F9416E63-D4B2-4C02-88EF-C514CF4E74D7}" type="presOf" srcId="{269C76F2-6A3F-4463-A37D-34DF9557723A}" destId="{21C25EF7-5122-4CB4-922C-C536D59390E7}" srcOrd="1" destOrd="1" presId="urn:microsoft.com/office/officeart/2005/8/layout/hProcess4"/>
+    <dgm:cxn modelId="{3FA23464-5E58-40BD-93DD-DB3C42BA7DAA}" type="presOf" srcId="{1BCB95D6-B1A4-439C-9AD1-CE00E32D68AA}" destId="{94FE265A-D377-4872-8AAD-6D9586E0C18A}" srcOrd="0" destOrd="0" presId="urn:microsoft.com/office/officeart/2005/8/layout/hProcess4"/>
     <dgm:cxn modelId="{BDFEF269-CF52-44E1-90F3-093DB5486581}" srcId="{5489487A-AE09-4C57-A8FE-3C88CD528A51}" destId="{36A43055-FF1E-4000-92DC-E1996435069B}" srcOrd="0" destOrd="0" parTransId="{F952DEC6-66D8-4998-8A9C-A930577EC2D2}" sibTransId="{86D954EB-E373-4698-A5D0-017BAF56FA0A}"/>
-    <dgm:cxn modelId="{9F09F24A-90A1-422B-B5DA-B38130F44CE8}" type="presOf" srcId="{36A43055-FF1E-4000-92DC-E1996435069B}" destId="{D9BDC29B-7D63-4495-A3B2-7C07F9B8C330}" srcOrd="0" destOrd="0" presId="urn:microsoft.com/office/officeart/2005/8/layout/hProcess4"/>
-    <dgm:cxn modelId="{3BA51A6D-6778-4A76-81C2-F27BF63FFE4F}" type="presOf" srcId="{428AB112-F44A-4DBD-9A72-307227A48835}" destId="{22FAA828-71BC-4F47-855C-19152EC671EC}" srcOrd="1" destOrd="2" presId="urn:microsoft.com/office/officeart/2005/8/layout/hProcess4"/>
-    <dgm:cxn modelId="{05D31F52-AB99-41FE-B518-7A810335A1BA}" type="presOf" srcId="{FB1AC2EB-2A73-487E-BFFC-E85DCC33CF70}" destId="{22FAA828-71BC-4F47-855C-19152EC671EC}" srcOrd="1" destOrd="0" presId="urn:microsoft.com/office/officeart/2005/8/layout/hProcess4"/>
-    <dgm:cxn modelId="{284B5854-B03F-43A1-A980-1E2CA9E3F355}" type="presOf" srcId="{8111E655-AA73-4919-8D88-D2AFAC6203BA}" destId="{DE4AC59B-B8E8-4AE0-82DC-3BD6B4ADF27A}" srcOrd="0" destOrd="0" presId="urn:microsoft.com/office/officeart/2005/8/layout/hProcess4"/>
-    <dgm:cxn modelId="{AF464776-F375-42C1-A960-13E9CEAD8FA3}" type="presOf" srcId="{A5277286-5511-4E9A-9AF8-737B622E3223}" destId="{1C299799-9D54-457B-A3C7-0FB93A410866}" srcOrd="0" destOrd="0" presId="urn:microsoft.com/office/officeart/2005/8/layout/hProcess4"/>
-    <dgm:cxn modelId="{B4C2015A-3E27-4822-AFDD-CB4131CA6FDC}" type="presOf" srcId="{428AB112-F44A-4DBD-9A72-307227A48835}" destId="{686EF4F2-C186-45B2-85A0-F6687D978556}" srcOrd="0" destOrd="2" presId="urn:microsoft.com/office/officeart/2005/8/layout/hProcess4"/>
-    <dgm:cxn modelId="{E402FD5A-86DA-4AA4-BB63-19D2FC1A9CFA}" type="presOf" srcId="{3679B97A-32D2-4172-BEF9-560A1496BE56}" destId="{686EF4F2-C186-45B2-85A0-F6687D978556}" srcOrd="0" destOrd="3" presId="urn:microsoft.com/office/officeart/2005/8/layout/hProcess4"/>
+    <dgm:cxn modelId="{E96F876E-CE3C-4C0C-A22A-CE43289A11C3}" type="presOf" srcId="{FB1AC2EB-2A73-487E-BFFC-E85DCC33CF70}" destId="{686EF4F2-C186-45B2-85A0-F6687D978556}" srcOrd="0" destOrd="0" presId="urn:microsoft.com/office/officeart/2005/8/layout/hProcess4"/>
+    <dgm:cxn modelId="{54DB877C-7458-49B5-A638-5F58ED1F4F97}" type="presOf" srcId="{F945E611-CD2E-4C69-9DAE-2D0D3822A0EA}" destId="{3C445FF9-93F1-4683-A6D2-EC9DB43AA93D}" srcOrd="1" destOrd="1" presId="urn:microsoft.com/office/officeart/2005/8/layout/hProcess4"/>
     <dgm:cxn modelId="{8BC42789-7A8C-4F3C-9F4C-2F71DA98F207}" srcId="{5489487A-AE09-4C57-A8FE-3C88CD528A51}" destId="{18DC73F0-EDC3-4451-98EA-91C847F5E375}" srcOrd="1" destOrd="0" parTransId="{49516162-687F-4DFA-BEBA-7A284363F675}" sibTransId="{60465BCF-9C95-4637-8D4C-5290976EB2A0}"/>
-    <dgm:cxn modelId="{2A4DB68A-A8F5-4013-BA1D-CB9791661462}" type="presOf" srcId="{1BCB95D6-B1A4-439C-9AD1-CE00E32D68AA}" destId="{94FE265A-D377-4872-8AAD-6D9586E0C18A}" srcOrd="0" destOrd="0" presId="urn:microsoft.com/office/officeart/2005/8/layout/hProcess4"/>
+    <dgm:cxn modelId="{CA76AA8A-3F24-47F2-88B3-204762E4744F}" type="presOf" srcId="{5DA50F34-C831-4850-8B63-CE799FF6C0D5}" destId="{C4D9AE61-43FF-44EC-9E2D-7446ED243914}" srcOrd="0" destOrd="0" presId="urn:microsoft.com/office/officeart/2005/8/layout/hProcess4"/>
+    <dgm:cxn modelId="{91C92990-DB73-4150-B506-4A7866514440}" type="presOf" srcId="{FB1AC2EB-2A73-487E-BFFC-E85DCC33CF70}" destId="{22FAA828-71BC-4F47-855C-19152EC671EC}" srcOrd="1" destOrd="0" presId="urn:microsoft.com/office/officeart/2005/8/layout/hProcess4"/>
+    <dgm:cxn modelId="{E16B2192-D5C7-44D8-BF47-E282E92085C8}" type="presOf" srcId="{5489487A-AE09-4C57-A8FE-3C88CD528A51}" destId="{57A9CED2-870E-4BB2-8BB0-97EB3CDBF401}" srcOrd="0" destOrd="0" presId="urn:microsoft.com/office/officeart/2005/8/layout/hProcess4"/>
     <dgm:cxn modelId="{46FA7699-0760-422D-95EC-7D257C462A6A}" srcId="{99D1A08B-05C7-4294-99DD-7BE56AF469A8}" destId="{5C407219-177A-43EE-B67E-B6E75271BA5B}" srcOrd="0" destOrd="0" parTransId="{78EA6105-D13A-4F17-AB97-952ED6E1056F}" sibTransId="{8E1FD376-005E-46DD-AB7C-3AD5F0C68AF6}"/>
     <dgm:cxn modelId="{A778DC99-B49C-4DDC-91A4-BC2F4970DD00}" srcId="{99D1A08B-05C7-4294-99DD-7BE56AF469A8}" destId="{5489487A-AE09-4C57-A8FE-3C88CD528A51}" srcOrd="1" destOrd="0" parTransId="{3491C758-4628-4476-8033-6CEC21F5D7B6}" sibTransId="{A5277286-5511-4E9A-9AF8-737B622E3223}"/>
-    <dgm:cxn modelId="{8589B7AB-6823-4989-8C6C-DD6B72F4F6E1}" type="presOf" srcId="{5489487A-AE09-4C57-A8FE-3C88CD528A51}" destId="{57A9CED2-870E-4BB2-8BB0-97EB3CDBF401}" srcOrd="0" destOrd="0" presId="urn:microsoft.com/office/officeart/2005/8/layout/hProcess4"/>
-    <dgm:cxn modelId="{EE041FAD-318D-41BF-A178-1F05CAEA8438}" type="presOf" srcId="{EB9EEFA8-E354-4F52-BA0E-F1E23DACFF23}" destId="{686EF4F2-C186-45B2-85A0-F6687D978556}" srcOrd="0" destOrd="1" presId="urn:microsoft.com/office/officeart/2005/8/layout/hProcess4"/>
-    <dgm:cxn modelId="{680D46B5-D7AA-4A7A-9B62-35116464C916}" type="presOf" srcId="{5DA50F34-C831-4850-8B63-CE799FF6C0D5}" destId="{C4D9AE61-43FF-44EC-9E2D-7446ED243914}" srcOrd="0" destOrd="0" presId="urn:microsoft.com/office/officeart/2005/8/layout/hProcess4"/>
+    <dgm:cxn modelId="{1570DE9D-57B7-4A63-97B7-2A52B65A8E12}" type="presOf" srcId="{36A43055-FF1E-4000-92DC-E1996435069B}" destId="{3A5BFE43-F020-43A7-BFCC-87B32E6976A9}" srcOrd="1" destOrd="0" presId="urn:microsoft.com/office/officeart/2005/8/layout/hProcess4"/>
+    <dgm:cxn modelId="{01F028B3-4A66-4134-B6C9-9F2E2201375B}" type="presOf" srcId="{8111E655-AA73-4919-8D88-D2AFAC6203BA}" destId="{3C445FF9-93F1-4683-A6D2-EC9DB43AA93D}" srcOrd="1" destOrd="0" presId="urn:microsoft.com/office/officeart/2005/8/layout/hProcess4"/>
+    <dgm:cxn modelId="{285767B9-1933-455B-8C38-53C68F793F3D}" type="presOf" srcId="{DCFD0921-E245-4A02-B3A7-0E9B55127B04}" destId="{30DD4CDA-4812-46C7-BA95-FF21DAD772D9}" srcOrd="0" destOrd="2" presId="urn:microsoft.com/office/officeart/2005/8/layout/hProcess4"/>
     <dgm:cxn modelId="{D4C2C2BA-4EF0-4E8C-8B23-D309E73EFFAB}" srcId="{5DA50F34-C831-4850-8B63-CE799FF6C0D5}" destId="{8111E655-AA73-4919-8D88-D2AFAC6203BA}" srcOrd="0" destOrd="0" parTransId="{1D01C444-95C3-40B7-A96E-5D3C98D5EFB1}" sibTransId="{734582F4-7C5B-4397-B295-2E2F146BB4BE}"/>
     <dgm:cxn modelId="{E0FBC2CB-959A-4226-9ACB-4CB07C4E9F88}" srcId="{5C407219-177A-43EE-B67E-B6E75271BA5B}" destId="{97225384-B3A3-4246-BB0C-554A34D4B7EE}" srcOrd="0" destOrd="0" parTransId="{2032F91E-C142-4D3C-947C-7455714058C6}" sibTransId="{6E3C3B18-981D-4F6C-AB72-2F298617B885}"/>
-    <dgm:cxn modelId="{2FD1C1D0-5F39-44A4-B0CC-E3EB141EBCCB}" type="presOf" srcId="{97225384-B3A3-4246-BB0C-554A34D4B7EE}" destId="{30DD4CDA-4812-46C7-BA95-FF21DAD772D9}" srcOrd="0" destOrd="0" presId="urn:microsoft.com/office/officeart/2005/8/layout/hProcess4"/>
+    <dgm:cxn modelId="{5B97F5CF-45BD-4062-B8B5-695D81AFA186}" type="presOf" srcId="{97225384-B3A3-4246-BB0C-554A34D4B7EE}" destId="{21C25EF7-5122-4CB4-922C-C536D59390E7}" srcOrd="1" destOrd="0" presId="urn:microsoft.com/office/officeart/2005/8/layout/hProcess4"/>
+    <dgm:cxn modelId="{741FD1D5-8134-400B-B927-38E195CEFBC9}" type="presOf" srcId="{EB9EEFA8-E354-4F52-BA0E-F1E23DACFF23}" destId="{22FAA828-71BC-4F47-855C-19152EC671EC}" srcOrd="1" destOrd="1" presId="urn:microsoft.com/office/officeart/2005/8/layout/hProcess4"/>
     <dgm:cxn modelId="{8B4A27D9-7DF5-407D-9FE0-9F9C17CD667A}" srcId="{99D1A08B-05C7-4294-99DD-7BE56AF469A8}" destId="{1BCB95D6-B1A4-439C-9AD1-CE00E32D68AA}" srcOrd="2" destOrd="0" parTransId="{565DC6A8-BFE9-4A7B-9AAF-B0195AFAE88E}" sibTransId="{0C420126-164A-4514-A51E-AB2C4502F253}"/>
-    <dgm:cxn modelId="{5B3F16EF-AC5B-440F-8E59-25BAE29FFE54}" type="presOf" srcId="{269C76F2-6A3F-4463-A37D-34DF9557723A}" destId="{30DD4CDA-4812-46C7-BA95-FF21DAD772D9}" srcOrd="0" destOrd="1" presId="urn:microsoft.com/office/officeart/2005/8/layout/hProcess4"/>
-    <dgm:cxn modelId="{F10086F6-2B83-44CF-93ED-1F8A2C82CF12}" type="presOf" srcId="{DCFD0921-E245-4A02-B3A7-0E9B55127B04}" destId="{21C25EF7-5122-4CB4-922C-C536D59390E7}" srcOrd="1" destOrd="2" presId="urn:microsoft.com/office/officeart/2005/8/layout/hProcess4"/>
-    <dgm:cxn modelId="{4B33FAF7-D5A5-4826-B602-E6AE618B2650}" type="presOf" srcId="{18DC73F0-EDC3-4451-98EA-91C847F5E375}" destId="{D9BDC29B-7D63-4495-A3B2-7C07F9B8C330}" srcOrd="0" destOrd="1" presId="urn:microsoft.com/office/officeart/2005/8/layout/hProcess4"/>
-    <dgm:cxn modelId="{A16A5AFB-4236-4673-9CB5-BE389EB3EF8C}" srcId="{EB9EEFA8-E354-4F52-BA0E-F1E23DACFF23}" destId="{3679B97A-32D2-4172-BEF9-560A1496BE56}" srcOrd="1" destOrd="0" parTransId="{B180FB7C-C893-47CE-AC8C-F0A6527F33DC}" sibTransId="{0D2383D4-47E1-4D36-90BF-8D7B53F07E5B}"/>
-    <dgm:cxn modelId="{1E13F9FB-220A-448A-8179-D4B3A4973A41}" type="presOf" srcId="{DCFD0921-E245-4A02-B3A7-0E9B55127B04}" destId="{30DD4CDA-4812-46C7-BA95-FF21DAD772D9}" srcOrd="0" destOrd="2" presId="urn:microsoft.com/office/officeart/2005/8/layout/hProcess4"/>
-    <dgm:cxn modelId="{173BCDFC-1277-40BA-BD6B-344D8C682E92}" type="presOf" srcId="{EB9EEFA8-E354-4F52-BA0E-F1E23DACFF23}" destId="{22FAA828-71BC-4F47-855C-19152EC671EC}" srcOrd="1" destOrd="1" presId="urn:microsoft.com/office/officeart/2005/8/layout/hProcess4"/>
-    <dgm:cxn modelId="{823F82FE-5345-496E-965A-8D2A66E30149}" type="presOf" srcId="{269C76F2-6A3F-4463-A37D-34DF9557723A}" destId="{21C25EF7-5122-4CB4-922C-C536D59390E7}" srcOrd="1" destOrd="1" presId="urn:microsoft.com/office/officeart/2005/8/layout/hProcess4"/>
-    <dgm:cxn modelId="{868EC685-D5D7-444D-89C5-13F64F183C9F}" type="presParOf" srcId="{1641139E-5806-4ED1-AA40-CDBBD9ABB873}" destId="{A69DC343-962C-4193-B759-C426D90ADEBE}" srcOrd="0" destOrd="0" presId="urn:microsoft.com/office/officeart/2005/8/layout/hProcess4"/>
-    <dgm:cxn modelId="{1D10B392-4277-486F-AB90-8A3420E1DE74}" type="presParOf" srcId="{1641139E-5806-4ED1-AA40-CDBBD9ABB873}" destId="{D44F98B8-7C0E-44E6-B339-45D9858C4485}" srcOrd="1" destOrd="0" presId="urn:microsoft.com/office/officeart/2005/8/layout/hProcess4"/>
-    <dgm:cxn modelId="{8B76E9A5-6F1E-4C8C-82BF-ECCC8C5C15E0}" type="presParOf" srcId="{1641139E-5806-4ED1-AA40-CDBBD9ABB873}" destId="{D414F4B2-7830-4056-8693-7152B494301A}" srcOrd="2" destOrd="0" presId="urn:microsoft.com/office/officeart/2005/8/layout/hProcess4"/>
-    <dgm:cxn modelId="{6484AFA7-8DC6-495D-8242-9DD0439C76B9}" type="presParOf" srcId="{D414F4B2-7830-4056-8693-7152B494301A}" destId="{31228088-885C-49E3-AE4E-7F1B0118071C}" srcOrd="0" destOrd="0" presId="urn:microsoft.com/office/officeart/2005/8/layout/hProcess4"/>
-    <dgm:cxn modelId="{F2E60E5F-8F6C-4E87-9E82-C801329E65FF}" type="presParOf" srcId="{31228088-885C-49E3-AE4E-7F1B0118071C}" destId="{FCC3BD23-997E-4674-8B26-CC365D097590}" srcOrd="0" destOrd="0" presId="urn:microsoft.com/office/officeart/2005/8/layout/hProcess4"/>
-    <dgm:cxn modelId="{B2680729-65C5-49AA-953C-C2B390DB0607}" type="presParOf" srcId="{31228088-885C-49E3-AE4E-7F1B0118071C}" destId="{30DD4CDA-4812-46C7-BA95-FF21DAD772D9}" srcOrd="1" destOrd="0" presId="urn:microsoft.com/office/officeart/2005/8/layout/hProcess4"/>
-    <dgm:cxn modelId="{C89937A3-E3D0-41E1-B6E0-D64ADEA7C4D4}" type="presParOf" srcId="{31228088-885C-49E3-AE4E-7F1B0118071C}" destId="{21C25EF7-5122-4CB4-922C-C536D59390E7}" srcOrd="2" destOrd="0" presId="urn:microsoft.com/office/officeart/2005/8/layout/hProcess4"/>
-    <dgm:cxn modelId="{C6DE746F-5EA4-4A57-BDA5-3B68A59F2A80}" type="presParOf" srcId="{31228088-885C-49E3-AE4E-7F1B0118071C}" destId="{22CBB4AF-36EB-417C-B703-FAF0662ACF49}" srcOrd="3" destOrd="0" presId="urn:microsoft.com/office/officeart/2005/8/layout/hProcess4"/>
-    <dgm:cxn modelId="{840EF5FC-C947-4712-BDB8-67DCF9F4EFD4}" type="presParOf" srcId="{31228088-885C-49E3-AE4E-7F1B0118071C}" destId="{CD953644-E5C6-4A75-8B8E-A06C97C3F536}" srcOrd="4" destOrd="0" presId="urn:microsoft.com/office/officeart/2005/8/layout/hProcess4"/>
-    <dgm:cxn modelId="{46355112-69E3-4666-89F1-1090E9564E88}" type="presParOf" srcId="{D414F4B2-7830-4056-8693-7152B494301A}" destId="{464DE029-02A1-4763-8666-F53A13C6FAAD}" srcOrd="1" destOrd="0" presId="urn:microsoft.com/office/officeart/2005/8/layout/hProcess4"/>
-    <dgm:cxn modelId="{7764998B-92B0-428C-99FC-2B9BBB6C85B5}" type="presParOf" srcId="{D414F4B2-7830-4056-8693-7152B494301A}" destId="{AFDFC40E-DDD3-4BC8-8BEB-A1A8244FD812}" srcOrd="2" destOrd="0" presId="urn:microsoft.com/office/officeart/2005/8/layout/hProcess4"/>
-    <dgm:cxn modelId="{8071F2CA-3430-428B-A83B-C7333389DC8D}" type="presParOf" srcId="{AFDFC40E-DDD3-4BC8-8BEB-A1A8244FD812}" destId="{3D3FE732-BEE4-4789-B501-EFE8520C98A6}" srcOrd="0" destOrd="0" presId="urn:microsoft.com/office/officeart/2005/8/layout/hProcess4"/>
-    <dgm:cxn modelId="{8DE57368-5989-4A99-B116-BE07676BA4CE}" type="presParOf" srcId="{AFDFC40E-DDD3-4BC8-8BEB-A1A8244FD812}" destId="{D9BDC29B-7D63-4495-A3B2-7C07F9B8C330}" srcOrd="1" destOrd="0" presId="urn:microsoft.com/office/officeart/2005/8/layout/hProcess4"/>
-    <dgm:cxn modelId="{3C7E37CD-5A38-4A43-B6DC-219012EC2D82}" type="presParOf" srcId="{AFDFC40E-DDD3-4BC8-8BEB-A1A8244FD812}" destId="{3A5BFE43-F020-43A7-BFCC-87B32E6976A9}" srcOrd="2" destOrd="0" presId="urn:microsoft.com/office/officeart/2005/8/layout/hProcess4"/>
-    <dgm:cxn modelId="{DCD055DB-A0B8-49B5-8E0B-6F67F1DA1339}" type="presParOf" srcId="{AFDFC40E-DDD3-4BC8-8BEB-A1A8244FD812}" destId="{57A9CED2-870E-4BB2-8BB0-97EB3CDBF401}" srcOrd="3" destOrd="0" presId="urn:microsoft.com/office/officeart/2005/8/layout/hProcess4"/>
-    <dgm:cxn modelId="{C6B7BA88-7E61-4407-BF9F-E01006E93A57}" type="presParOf" srcId="{AFDFC40E-DDD3-4BC8-8BEB-A1A8244FD812}" destId="{9A6587D4-7582-4D83-A90E-1B1B29100CB4}" srcOrd="4" destOrd="0" presId="urn:microsoft.com/office/officeart/2005/8/layout/hProcess4"/>
-    <dgm:cxn modelId="{72695B40-C40F-4D8E-AFA0-2FEBF87B179D}" type="presParOf" srcId="{D414F4B2-7830-4056-8693-7152B494301A}" destId="{1C299799-9D54-457B-A3C7-0FB93A410866}" srcOrd="3" destOrd="0" presId="urn:microsoft.com/office/officeart/2005/8/layout/hProcess4"/>
-    <dgm:cxn modelId="{B07C2893-6AE9-4493-B502-8C87EB7E097F}" type="presParOf" srcId="{D414F4B2-7830-4056-8693-7152B494301A}" destId="{64364D03-C473-454F-AF21-95C000F5F884}" srcOrd="4" destOrd="0" presId="urn:microsoft.com/office/officeart/2005/8/layout/hProcess4"/>
-    <dgm:cxn modelId="{B2B8AF69-7887-4ABC-B586-557C62451496}" type="presParOf" srcId="{64364D03-C473-454F-AF21-95C000F5F884}" destId="{44F76157-1425-47BB-9E5D-B9F240E12A0A}" srcOrd="0" destOrd="0" presId="urn:microsoft.com/office/officeart/2005/8/layout/hProcess4"/>
-    <dgm:cxn modelId="{75013056-5681-4951-8F5F-75A39543F466}" type="presParOf" srcId="{64364D03-C473-454F-AF21-95C000F5F884}" destId="{686EF4F2-C186-45B2-85A0-F6687D978556}" srcOrd="1" destOrd="0" presId="urn:microsoft.com/office/officeart/2005/8/layout/hProcess4"/>
-    <dgm:cxn modelId="{A985696B-6300-40F9-AEDF-0FA5046B4F5D}" type="presParOf" srcId="{64364D03-C473-454F-AF21-95C000F5F884}" destId="{22FAA828-71BC-4F47-855C-19152EC671EC}" srcOrd="2" destOrd="0" presId="urn:microsoft.com/office/officeart/2005/8/layout/hProcess4"/>
-    <dgm:cxn modelId="{AC328C89-0436-4032-A154-250E0CAD91E4}" type="presParOf" srcId="{64364D03-C473-454F-AF21-95C000F5F884}" destId="{94FE265A-D377-4872-8AAD-6D9586E0C18A}" srcOrd="3" destOrd="0" presId="urn:microsoft.com/office/officeart/2005/8/layout/hProcess4"/>
-    <dgm:cxn modelId="{69A2CD07-030E-41AC-AF4B-980188515A39}" type="presParOf" srcId="{64364D03-C473-454F-AF21-95C000F5F884}" destId="{B6B4BA71-2269-473A-9B34-EE3A92EF3F26}" srcOrd="4" destOrd="0" presId="urn:microsoft.com/office/officeart/2005/8/layout/hProcess4"/>
-    <dgm:cxn modelId="{7CCD34AB-813D-4C41-8F6C-AF4294376AA8}" type="presParOf" srcId="{D414F4B2-7830-4056-8693-7152B494301A}" destId="{74F3F80A-8B0F-4F29-B321-AD28639C9105}" srcOrd="5" destOrd="0" presId="urn:microsoft.com/office/officeart/2005/8/layout/hProcess4"/>
-    <dgm:cxn modelId="{5E906BC3-28C0-467D-B483-43C158B8EF07}" type="presParOf" srcId="{D414F4B2-7830-4056-8693-7152B494301A}" destId="{EA78CE16-E317-4FEA-996D-E0EE0A893B5C}" srcOrd="6" destOrd="0" presId="urn:microsoft.com/office/officeart/2005/8/layout/hProcess4"/>
-    <dgm:cxn modelId="{FAEF8719-B83A-428A-886D-0F5DC26E5929}" type="presParOf" srcId="{EA78CE16-E317-4FEA-996D-E0EE0A893B5C}" destId="{60BAA0C7-18DD-413F-B007-B92B7FACDBD8}" srcOrd="0" destOrd="0" presId="urn:microsoft.com/office/officeart/2005/8/layout/hProcess4"/>
-    <dgm:cxn modelId="{0837C6E1-A9B4-496C-9C14-3287438F8F61}" type="presParOf" srcId="{EA78CE16-E317-4FEA-996D-E0EE0A893B5C}" destId="{DE4AC59B-B8E8-4AE0-82DC-3BD6B4ADF27A}" srcOrd="1" destOrd="0" presId="urn:microsoft.com/office/officeart/2005/8/layout/hProcess4"/>
-    <dgm:cxn modelId="{78CCDABC-5B6F-417A-8408-6379AA8A9341}" type="presParOf" srcId="{EA78CE16-E317-4FEA-996D-E0EE0A893B5C}" destId="{3C445FF9-93F1-4683-A6D2-EC9DB43AA93D}" srcOrd="2" destOrd="0" presId="urn:microsoft.com/office/officeart/2005/8/layout/hProcess4"/>
-    <dgm:cxn modelId="{A73D4E6C-3615-4D7E-8C81-9F9C2170771C}" type="presParOf" srcId="{EA78CE16-E317-4FEA-996D-E0EE0A893B5C}" destId="{C4D9AE61-43FF-44EC-9E2D-7446ED243914}" srcOrd="3" destOrd="0" presId="urn:microsoft.com/office/officeart/2005/8/layout/hProcess4"/>
-    <dgm:cxn modelId="{82E58ECF-A263-4E52-981B-7A8BB5397FF7}" type="presParOf" srcId="{EA78CE16-E317-4FEA-996D-E0EE0A893B5C}" destId="{B20B26B3-AC24-4A72-B831-B92A331552E8}" srcOrd="4" destOrd="0" presId="urn:microsoft.com/office/officeart/2005/8/layout/hProcess4"/>
+    <dgm:cxn modelId="{E220B6DE-9DB5-4D4E-9664-FB3339DA7220}" type="presOf" srcId="{DCFD0921-E245-4A02-B3A7-0E9B55127B04}" destId="{21C25EF7-5122-4CB4-922C-C536D59390E7}" srcOrd="1" destOrd="2" presId="urn:microsoft.com/office/officeart/2005/8/layout/hProcess4"/>
+    <dgm:cxn modelId="{A8F984E8-0058-40DA-AC0D-2E007A2056CE}" type="presOf" srcId="{36A43055-FF1E-4000-92DC-E1996435069B}" destId="{D9BDC29B-7D63-4495-A3B2-7C07F9B8C330}" srcOrd="0" destOrd="0" presId="urn:microsoft.com/office/officeart/2005/8/layout/hProcess4"/>
+    <dgm:cxn modelId="{FB0716F9-6BD9-4536-8DCF-134146E022B6}" srcId="{1BCB95D6-B1A4-439C-9AD1-CE00E32D68AA}" destId="{067E8FF9-061C-4CD3-A921-26E66C8903EA}" srcOrd="2" destOrd="0" parTransId="{4BDED4F2-CDF9-49DB-8ABB-3FB5C36045BA}" sibTransId="{94AFE86B-7BC3-489D-8D06-70F5EE494AE4}"/>
+    <dgm:cxn modelId="{9CFC0B7B-7D78-455C-A996-118EB95A90E7}" type="presParOf" srcId="{1641139E-5806-4ED1-AA40-CDBBD9ABB873}" destId="{A69DC343-962C-4193-B759-C426D90ADEBE}" srcOrd="0" destOrd="0" presId="urn:microsoft.com/office/officeart/2005/8/layout/hProcess4"/>
+    <dgm:cxn modelId="{43302216-AE13-4964-8B68-FBF74D3C6213}" type="presParOf" srcId="{1641139E-5806-4ED1-AA40-CDBBD9ABB873}" destId="{D44F98B8-7C0E-44E6-B339-45D9858C4485}" srcOrd="1" destOrd="0" presId="urn:microsoft.com/office/officeart/2005/8/layout/hProcess4"/>
+    <dgm:cxn modelId="{CB5941FC-033B-471F-B72C-596B833A79BA}" type="presParOf" srcId="{1641139E-5806-4ED1-AA40-CDBBD9ABB873}" destId="{D414F4B2-7830-4056-8693-7152B494301A}" srcOrd="2" destOrd="0" presId="urn:microsoft.com/office/officeart/2005/8/layout/hProcess4"/>
+    <dgm:cxn modelId="{828B986C-4A9F-4787-B53E-C0D972A33A52}" type="presParOf" srcId="{D414F4B2-7830-4056-8693-7152B494301A}" destId="{31228088-885C-49E3-AE4E-7F1B0118071C}" srcOrd="0" destOrd="0" presId="urn:microsoft.com/office/officeart/2005/8/layout/hProcess4"/>
+    <dgm:cxn modelId="{39AB3043-8274-45E1-835E-636A4526349C}" type="presParOf" srcId="{31228088-885C-49E3-AE4E-7F1B0118071C}" destId="{FCC3BD23-997E-4674-8B26-CC365D097590}" srcOrd="0" destOrd="0" presId="urn:microsoft.com/office/officeart/2005/8/layout/hProcess4"/>
+    <dgm:cxn modelId="{3CC4F822-2AA6-4CA0-B99B-D70D6DA05244}" type="presParOf" srcId="{31228088-885C-49E3-AE4E-7F1B0118071C}" destId="{30DD4CDA-4812-46C7-BA95-FF21DAD772D9}" srcOrd="1" destOrd="0" presId="urn:microsoft.com/office/officeart/2005/8/layout/hProcess4"/>
+    <dgm:cxn modelId="{94B31F0F-95F6-49AF-A06A-CD8DD96B2FC9}" type="presParOf" srcId="{31228088-885C-49E3-AE4E-7F1B0118071C}" destId="{21C25EF7-5122-4CB4-922C-C536D59390E7}" srcOrd="2" destOrd="0" presId="urn:microsoft.com/office/officeart/2005/8/layout/hProcess4"/>
+    <dgm:cxn modelId="{F5368BE9-7A9F-4BC3-AA6E-58DD5D28E0BC}" type="presParOf" srcId="{31228088-885C-49E3-AE4E-7F1B0118071C}" destId="{22CBB4AF-36EB-417C-B703-FAF0662ACF49}" srcOrd="3" destOrd="0" presId="urn:microsoft.com/office/officeart/2005/8/layout/hProcess4"/>
+    <dgm:cxn modelId="{FD827C74-68B7-4D4F-9674-982C3EE30F8C}" type="presParOf" srcId="{31228088-885C-49E3-AE4E-7F1B0118071C}" destId="{CD953644-E5C6-4A75-8B8E-A06C97C3F536}" srcOrd="4" destOrd="0" presId="urn:microsoft.com/office/officeart/2005/8/layout/hProcess4"/>
+    <dgm:cxn modelId="{BAB0D624-C2D7-4B8D-BAD9-0D7B7DC5C57C}" type="presParOf" srcId="{D414F4B2-7830-4056-8693-7152B494301A}" destId="{464DE029-02A1-4763-8666-F53A13C6FAAD}" srcOrd="1" destOrd="0" presId="urn:microsoft.com/office/officeart/2005/8/layout/hProcess4"/>
+    <dgm:cxn modelId="{7D341361-EF59-4A26-9807-B6CACAA92D12}" type="presParOf" srcId="{D414F4B2-7830-4056-8693-7152B494301A}" destId="{AFDFC40E-DDD3-4BC8-8BEB-A1A8244FD812}" srcOrd="2" destOrd="0" presId="urn:microsoft.com/office/officeart/2005/8/layout/hProcess4"/>
+    <dgm:cxn modelId="{EB156458-42F8-4464-B4F4-7F3A7DC11D8E}" type="presParOf" srcId="{AFDFC40E-DDD3-4BC8-8BEB-A1A8244FD812}" destId="{3D3FE732-BEE4-4789-B501-EFE8520C98A6}" srcOrd="0" destOrd="0" presId="urn:microsoft.com/office/officeart/2005/8/layout/hProcess4"/>
+    <dgm:cxn modelId="{905BBC4B-2980-4D5F-A09D-F9FD79251C30}" type="presParOf" srcId="{AFDFC40E-DDD3-4BC8-8BEB-A1A8244FD812}" destId="{D9BDC29B-7D63-4495-A3B2-7C07F9B8C330}" srcOrd="1" destOrd="0" presId="urn:microsoft.com/office/officeart/2005/8/layout/hProcess4"/>
+    <dgm:cxn modelId="{8F8ED8BA-6718-482D-B5D5-E70C8409182D}" type="presParOf" srcId="{AFDFC40E-DDD3-4BC8-8BEB-A1A8244FD812}" destId="{3A5BFE43-F020-43A7-BFCC-87B32E6976A9}" srcOrd="2" destOrd="0" presId="urn:microsoft.com/office/officeart/2005/8/layout/hProcess4"/>
+    <dgm:cxn modelId="{D0D979DC-FBB4-4B24-83E3-9BC74E6D7D09}" type="presParOf" srcId="{AFDFC40E-DDD3-4BC8-8BEB-A1A8244FD812}" destId="{57A9CED2-870E-4BB2-8BB0-97EB3CDBF401}" srcOrd="3" destOrd="0" presId="urn:microsoft.com/office/officeart/2005/8/layout/hProcess4"/>
+    <dgm:cxn modelId="{18088A21-EEB9-46DD-AF89-DD46C245760E}" type="presParOf" srcId="{AFDFC40E-DDD3-4BC8-8BEB-A1A8244FD812}" destId="{9A6587D4-7582-4D83-A90E-1B1B29100CB4}" srcOrd="4" destOrd="0" presId="urn:microsoft.com/office/officeart/2005/8/layout/hProcess4"/>
+    <dgm:cxn modelId="{77866227-804C-4C91-8158-F9123EDBDCDF}" type="presParOf" srcId="{D414F4B2-7830-4056-8693-7152B494301A}" destId="{1C299799-9D54-457B-A3C7-0FB93A410866}" srcOrd="3" destOrd="0" presId="urn:microsoft.com/office/officeart/2005/8/layout/hProcess4"/>
+    <dgm:cxn modelId="{D0B6553D-7BAC-40BB-97F1-E488FAB9E810}" type="presParOf" srcId="{D414F4B2-7830-4056-8693-7152B494301A}" destId="{64364D03-C473-454F-AF21-95C000F5F884}" srcOrd="4" destOrd="0" presId="urn:microsoft.com/office/officeart/2005/8/layout/hProcess4"/>
+    <dgm:cxn modelId="{B639D78A-C039-4DE8-B4C7-4C2F29670CA0}" type="presParOf" srcId="{64364D03-C473-454F-AF21-95C000F5F884}" destId="{44F76157-1425-47BB-9E5D-B9F240E12A0A}" srcOrd="0" destOrd="0" presId="urn:microsoft.com/office/officeart/2005/8/layout/hProcess4"/>
+    <dgm:cxn modelId="{BC393594-F653-41C7-B530-14B1B08715BF}" type="presParOf" srcId="{64364D03-C473-454F-AF21-95C000F5F884}" destId="{686EF4F2-C186-45B2-85A0-F6687D978556}" srcOrd="1" destOrd="0" presId="urn:microsoft.com/office/officeart/2005/8/layout/hProcess4"/>
+    <dgm:cxn modelId="{4E450598-1989-4098-B25F-5E15D394E5FF}" type="presParOf" srcId="{64364D03-C473-454F-AF21-95C000F5F884}" destId="{22FAA828-71BC-4F47-855C-19152EC671EC}" srcOrd="2" destOrd="0" presId="urn:microsoft.com/office/officeart/2005/8/layout/hProcess4"/>
+    <dgm:cxn modelId="{AE97C12C-D4F3-4BE7-867C-BB3B5ADFEB84}" type="presParOf" srcId="{64364D03-C473-454F-AF21-95C000F5F884}" destId="{94FE265A-D377-4872-8AAD-6D9586E0C18A}" srcOrd="3" destOrd="0" presId="urn:microsoft.com/office/officeart/2005/8/layout/hProcess4"/>
+    <dgm:cxn modelId="{D57697CA-737C-4B66-8B35-97EFE03665B4}" type="presParOf" srcId="{64364D03-C473-454F-AF21-95C000F5F884}" destId="{B6B4BA71-2269-473A-9B34-EE3A92EF3F26}" srcOrd="4" destOrd="0" presId="urn:microsoft.com/office/officeart/2005/8/layout/hProcess4"/>
+    <dgm:cxn modelId="{2683FC65-BD74-4241-BF43-C96840EEA57E}" type="presParOf" srcId="{D414F4B2-7830-4056-8693-7152B494301A}" destId="{74F3F80A-8B0F-4F29-B321-AD28639C9105}" srcOrd="5" destOrd="0" presId="urn:microsoft.com/office/officeart/2005/8/layout/hProcess4"/>
+    <dgm:cxn modelId="{E106140B-2CC6-417A-9E2D-5142C1913C67}" type="presParOf" srcId="{D414F4B2-7830-4056-8693-7152B494301A}" destId="{EA78CE16-E317-4FEA-996D-E0EE0A893B5C}" srcOrd="6" destOrd="0" presId="urn:microsoft.com/office/officeart/2005/8/layout/hProcess4"/>
+    <dgm:cxn modelId="{50296F47-5E60-4E21-8360-7CEEE4E78228}" type="presParOf" srcId="{EA78CE16-E317-4FEA-996D-E0EE0A893B5C}" destId="{60BAA0C7-18DD-413F-B007-B92B7FACDBD8}" srcOrd="0" destOrd="0" presId="urn:microsoft.com/office/officeart/2005/8/layout/hProcess4"/>
+    <dgm:cxn modelId="{F00D6228-91E2-4D41-8532-F1A7B04EF8C9}" type="presParOf" srcId="{EA78CE16-E317-4FEA-996D-E0EE0A893B5C}" destId="{DE4AC59B-B8E8-4AE0-82DC-3BD6B4ADF27A}" srcOrd="1" destOrd="0" presId="urn:microsoft.com/office/officeart/2005/8/layout/hProcess4"/>
+    <dgm:cxn modelId="{4F7202E3-4CF3-40CB-B4CD-A65555869FD4}" type="presParOf" srcId="{EA78CE16-E317-4FEA-996D-E0EE0A893B5C}" destId="{3C445FF9-93F1-4683-A6D2-EC9DB43AA93D}" srcOrd="2" destOrd="0" presId="urn:microsoft.com/office/officeart/2005/8/layout/hProcess4"/>
+    <dgm:cxn modelId="{B4A032B3-58DD-4908-9701-4DA57544D1D8}" type="presParOf" srcId="{EA78CE16-E317-4FEA-996D-E0EE0A893B5C}" destId="{C4D9AE61-43FF-44EC-9E2D-7446ED243914}" srcOrd="3" destOrd="0" presId="urn:microsoft.com/office/officeart/2005/8/layout/hProcess4"/>
+    <dgm:cxn modelId="{AA56AAF2-AA48-4E82-9C17-974B02709EBA}" type="presParOf" srcId="{EA78CE16-E317-4FEA-996D-E0EE0A893B5C}" destId="{B20B26B3-AC24-4A72-B831-B92A331552E8}" srcOrd="4" destOrd="0" presId="urn:microsoft.com/office/officeart/2005/8/layout/hProcess4"/>
   </dgm:cxnLst>
   <dgm:bg/>
   <dgm:whole/>
@@ -4412,12 +4413,9 @@
           </a:avLst>
         </a:prstGeom>
         <a:solidFill>
-          <a:schemeClr val="lt1">
-            <a:alpha val="90000"/>
-            <a:hueOff val="0"/>
-            <a:satOff val="0"/>
-            <a:lumOff val="0"/>
-            <a:alphaOff val="0"/>
+          <a:schemeClr val="accent2">
+            <a:lumMod val="20000"/>
+            <a:lumOff val="80000"/>
           </a:schemeClr>
         </a:solidFill>
         <a:ln w="19050" cap="flat" cmpd="sng" algn="ctr">
@@ -4496,7 +4494,7 @@
           </a:r>
         </a:p>
         <a:p>
-          <a:pPr marL="342900" lvl="2" indent="-171450" algn="l" defTabSz="711200">
+          <a:pPr marL="171450" lvl="1" indent="-171450" algn="l" defTabSz="711200">
             <a:lnSpc>
               <a:spcPct val="90000"/>
             </a:lnSpc>
@@ -4518,7 +4516,7 @@
           </a:r>
         </a:p>
         <a:p>
-          <a:pPr marL="342900" lvl="2" indent="-171450" algn="l" defTabSz="711200">
+          <a:pPr marL="171450" lvl="1" indent="-171450" algn="l" defTabSz="711200">
             <a:lnSpc>
               <a:spcPct val="90000"/>
             </a:lnSpc>
@@ -4536,7 +4534,7 @@
                 <a:srgbClr val="3333FF"/>
               </a:solidFill>
             </a:rPr>
-            <a:t>Negotiate Price</a:t>
+            <a:t>Negotiate Price with the bank</a:t>
           </a:r>
         </a:p>
       </dsp:txBody>
@@ -8032,7 +8030,7 @@
           <a:p>
             <a:fld id="{23F5F05C-4C32-48D7-B5AA-52291E739591}" type="datetimeFigureOut">
               <a:rPr lang="en-US" smtClean="0"/>
-              <a:t>8/24/2026</a:t>
+              <a:t>8/25/2026</a:t>
             </a:fld>
             <a:endParaRPr lang="en-US"/>
           </a:p>
@@ -8674,7 +8672,7 @@
           <a:p>
             <a:fld id="{5518E2ED-ACDD-48AE-BEAE-F9B835E4D922}" type="datetimeFigureOut">
               <a:rPr lang="en-US" smtClean="0"/>
-              <a:t>8/24/2026</a:t>
+              <a:t>8/25/2026</a:t>
             </a:fld>
             <a:endParaRPr lang="en-US"/>
           </a:p>
@@ -8872,7 +8870,7 @@
           <a:p>
             <a:fld id="{5518E2ED-ACDD-48AE-BEAE-F9B835E4D922}" type="datetimeFigureOut">
               <a:rPr lang="en-US" smtClean="0"/>
-              <a:t>8/24/2026</a:t>
+              <a:t>8/25/2026</a:t>
             </a:fld>
             <a:endParaRPr lang="en-US"/>
           </a:p>
@@ -9080,7 +9078,7 @@
           <a:p>
             <a:fld id="{5518E2ED-ACDD-48AE-BEAE-F9B835E4D922}" type="datetimeFigureOut">
               <a:rPr lang="en-US" smtClean="0"/>
-              <a:t>8/24/2026</a:t>
+              <a:t>8/25/2026</a:t>
             </a:fld>
             <a:endParaRPr lang="en-US"/>
           </a:p>
@@ -9278,7 +9276,7 @@
           <a:p>
             <a:fld id="{5518E2ED-ACDD-48AE-BEAE-F9B835E4D922}" type="datetimeFigureOut">
               <a:rPr lang="en-US" smtClean="0"/>
-              <a:t>8/24/2026</a:t>
+              <a:t>8/25/2026</a:t>
             </a:fld>
             <a:endParaRPr lang="en-US"/>
           </a:p>
@@ -9553,7 +9551,7 @@
           <a:p>
             <a:fld id="{5518E2ED-ACDD-48AE-BEAE-F9B835E4D922}" type="datetimeFigureOut">
               <a:rPr lang="en-US" smtClean="0"/>
-              <a:t>8/24/2026</a:t>
+              <a:t>8/25/2026</a:t>
             </a:fld>
             <a:endParaRPr lang="en-US"/>
           </a:p>
@@ -9818,7 +9816,7 @@
           <a:p>
             <a:fld id="{5518E2ED-ACDD-48AE-BEAE-F9B835E4D922}" type="datetimeFigureOut">
               <a:rPr lang="en-US" smtClean="0"/>
-              <a:t>8/24/2026</a:t>
+              <a:t>8/25/2026</a:t>
             </a:fld>
             <a:endParaRPr lang="en-US"/>
           </a:p>
@@ -10230,7 +10228,7 @@
           <a:p>
             <a:fld id="{5518E2ED-ACDD-48AE-BEAE-F9B835E4D922}" type="datetimeFigureOut">
               <a:rPr lang="en-US" smtClean="0"/>
-              <a:t>8/24/2026</a:t>
+              <a:t>8/25/2026</a:t>
             </a:fld>
             <a:endParaRPr lang="en-US"/>
           </a:p>
@@ -10371,7 +10369,7 @@
           <a:p>
             <a:fld id="{5518E2ED-ACDD-48AE-BEAE-F9B835E4D922}" type="datetimeFigureOut">
               <a:rPr lang="en-US" smtClean="0"/>
-              <a:t>8/24/2026</a:t>
+              <a:t>8/25/2026</a:t>
             </a:fld>
             <a:endParaRPr lang="en-US"/>
           </a:p>
@@ -10484,7 +10482,7 @@
           <a:p>
             <a:fld id="{5518E2ED-ACDD-48AE-BEAE-F9B835E4D922}" type="datetimeFigureOut">
               <a:rPr lang="en-US" smtClean="0"/>
-              <a:t>8/24/2026</a:t>
+              <a:t>8/25/2026</a:t>
             </a:fld>
             <a:endParaRPr lang="en-US"/>
           </a:p>
@@ -10795,7 +10793,7 @@
           <a:p>
             <a:fld id="{5518E2ED-ACDD-48AE-BEAE-F9B835E4D922}" type="datetimeFigureOut">
               <a:rPr lang="en-US" smtClean="0"/>
-              <a:t>8/24/2026</a:t>
+              <a:t>8/25/2026</a:t>
             </a:fld>
             <a:endParaRPr lang="en-US"/>
           </a:p>
@@ -11083,7 +11081,7 @@
           <a:p>
             <a:fld id="{5518E2ED-ACDD-48AE-BEAE-F9B835E4D922}" type="datetimeFigureOut">
               <a:rPr lang="en-US" smtClean="0"/>
-              <a:t>8/24/2026</a:t>
+              <a:t>8/25/2026</a:t>
             </a:fld>
             <a:endParaRPr lang="en-US"/>
           </a:p>
@@ -11324,7 +11322,7 @@
           <a:p>
             <a:fld id="{5518E2ED-ACDD-48AE-BEAE-F9B835E4D922}" type="datetimeFigureOut">
               <a:rPr lang="en-US" smtClean="0"/>
-              <a:t>8/24/2026</a:t>
+              <a:t>8/25/2026</a:t>
             </a:fld>
             <a:endParaRPr lang="en-US"/>
           </a:p>
@@ -11843,7 +11841,7 @@
         </p:nvSpPr>
         <p:spPr>
           <a:xfrm>
-            <a:off x="371816" y="779929"/>
+            <a:off x="529792" y="1097792"/>
             <a:ext cx="5566207" cy="1908202"/>
           </a:xfrm>
         </p:spPr>
@@ -11856,7 +11854,7 @@
             <a:pPr algn="l"/>
             <a:r>
               <a:rPr lang="en-US" sz="4400" dirty="0"/>
-              <a:t>Immersive Model for Tri State Water Bank to Get More Water to GSL</a:t>
+              <a:t>Immersive Model for a Tri-State Water Bank to Get More Water to GSL</a:t>
             </a:r>
           </a:p>
         </p:txBody>
@@ -12418,8 +12416,8 @@
         </p:blipFill>
         <p:spPr>
           <a:xfrm>
-            <a:off x="228214" y="44819"/>
-            <a:ext cx="11735567" cy="4267199"/>
+            <a:off x="250615" y="672369"/>
+            <a:ext cx="8341423" cy="3505754"/>
           </a:xfrm>
           <a:prstGeom prst="rect">
             <a:avLst/>
@@ -12440,8 +12438,8 @@
         </p:nvSpPr>
         <p:spPr>
           <a:xfrm>
-            <a:off x="1035422" y="5699320"/>
-            <a:ext cx="10121153" cy="954107"/>
+            <a:off x="2041711" y="4800636"/>
+            <a:ext cx="8108577" cy="1384995"/>
           </a:xfrm>
           <a:prstGeom prst="rect">
             <a:avLst/>
@@ -12493,8 +12491,8 @@
         </p:nvSpPr>
         <p:spPr>
           <a:xfrm>
-            <a:off x="179291" y="4312018"/>
-            <a:ext cx="5916706" cy="523220"/>
+            <a:off x="8546614" y="528918"/>
+            <a:ext cx="3431434" cy="954107"/>
           </a:xfrm>
           <a:prstGeom prst="rect">
             <a:avLst/>
@@ -12507,6 +12505,7 @@
           </a:bodyPr>
           <a:lstStyle/>
           <a:p>
+            <a:pPr algn="ctr"/>
             <a:r>
               <a:rPr lang="en-US" sz="2800" i="0" dirty="0">
                 <a:solidFill>
@@ -12539,8 +12538,8 @@
         </p:nvSpPr>
         <p:spPr>
           <a:xfrm>
-            <a:off x="7328645" y="4312018"/>
-            <a:ext cx="4939556" cy="523220"/>
+            <a:off x="8614750" y="1876466"/>
+            <a:ext cx="3340586" cy="954107"/>
           </a:xfrm>
           <a:prstGeom prst="rect">
             <a:avLst/>
@@ -12553,8 +12552,9 @@
           </a:bodyPr>
           <a:lstStyle/>
           <a:p>
+            <a:pPr algn="ctr"/>
             <a:r>
-              <a:rPr lang="en-US" sz="2800">
+              <a:rPr lang="en-US" sz="2800" dirty="0">
                 <a:solidFill>
                   <a:srgbClr val="FF0000"/>
                 </a:solidFill>
@@ -12562,7 +12562,7 @@
               <a:t>H</a:t>
             </a:r>
             <a:r>
-              <a:rPr lang="en-US" sz="2800" b="0" i="0">
+              <a:rPr lang="en-US" sz="2800" b="0" i="0" dirty="0">
                 <a:solidFill>
                   <a:srgbClr val="FF0000"/>
                 </a:solidFill>
@@ -12593,8 +12593,8 @@
         </p:nvSpPr>
         <p:spPr>
           <a:xfrm>
-            <a:off x="4798358" y="5005669"/>
-            <a:ext cx="3314700" cy="523220"/>
+            <a:off x="8998942" y="3093537"/>
+            <a:ext cx="2572201" cy="954107"/>
           </a:xfrm>
           <a:prstGeom prst="rect">
             <a:avLst/>
@@ -12607,6 +12607,7 @@
           </a:bodyPr>
           <a:lstStyle/>
           <a:p>
+            <a:pPr algn="ctr"/>
             <a:r>
               <a:rPr lang="en-US" sz="2800" b="1" dirty="0"/>
               <a:t>Mid 2026 ~ </a:t>
@@ -12758,7 +12759,7 @@
           <p:nvPr>
             <p:extLst>
               <p:ext uri="{D42A27DB-BD31-4B8C-83A1-F6EECF244321}">
-                <p14:modId xmlns:p14="http://schemas.microsoft.com/office/powerpoint/2010/main" val="3276213830"/>
+                <p14:modId xmlns:p14="http://schemas.microsoft.com/office/powerpoint/2010/main" val="2876486537"/>
               </p:ext>
             </p:extLst>
           </p:nvPr>
@@ -13035,7 +13036,7 @@
         </p:nvSpPr>
         <p:spPr>
           <a:xfrm>
-            <a:off x="4458001" y="1085621"/>
+            <a:off x="2969860" y="1085621"/>
             <a:ext cx="6096000" cy="523220"/>
           </a:xfrm>
           <a:prstGeom prst="rect">

</xml_diff>

<commit_message>
Update Data used to create the model file
</commit_message>
<xml_diff>
--- a/Session Guide/IntroPresentation.pptx
+++ b/Session Guide/IntroPresentation.pptx
@@ -119,21 +119,12 @@
 </p:presentation>
 </file>
 
-<file path=ppt/revisionInfo.xml><?xml version="1.0" encoding="utf-8"?>
-<p1510:revInfo xmlns:a="http://schemas.openxmlformats.org/drawingml/2006/main" xmlns:r="http://schemas.openxmlformats.org/officeDocument/2006/relationships" xmlns:p1510="http://schemas.microsoft.com/office/powerpoint/2015/10/main">
-  <p1510:revLst>
-    <p1510:client id="{0FA96045-9951-4B0B-BD62-76A4AB30A5F9}" v="10" dt="2026-08-24T23:19:05.277"/>
-    <p1510:client id="{BE72FB7B-DAE7-44E6-A59E-4031D98A4453}" v="1" dt="2026-08-25T17:57:17.673"/>
-  </p1510:revLst>
-</p1510:revInfo>
-</file>
-
 <file path=ppt/changesInfos/changesInfo1.xml><?xml version="1.0" encoding="utf-8"?>
 <pc:chgInfo xmlns:a="http://schemas.openxmlformats.org/drawingml/2006/main" xmlns:r="http://schemas.openxmlformats.org/officeDocument/2006/relationships" xmlns:ac="http://schemas.microsoft.com/office/drawing/2013/main/command" xmlns:pc="http://schemas.microsoft.com/office/powerpoint/2013/main/command">
   <pc:docChgLst>
     <pc:chgData name="Hadia Akbar" userId="19362115565_tp_box_2" providerId="OAuth2" clId="{FF77DECD-7ECC-48F4-BF82-9D4D4E0BE774}"/>
     <pc:docChg chg="undo redo custSel addSld delSld modSld sldOrd delMainMaster">
-      <pc:chgData name="Hadia Akbar" userId="19362115565_tp_box_2" providerId="OAuth2" clId="{FF77DECD-7ECC-48F4-BF82-9D4D4E0BE774}" dt="2026-08-25T18:40:44.123" v="2533" actId="1076"/>
+      <pc:chgData name="Hadia Akbar" userId="19362115565_tp_box_2" providerId="OAuth2" clId="{FF77DECD-7ECC-48F4-BF82-9D4D4E0BE774}" dt="2026-08-28T18:07:09.575" v="2536" actId="20577"/>
       <pc:docMkLst>
         <pc:docMk/>
       </pc:docMkLst>
@@ -247,52 +238,6 @@
           </ac:graphicFrameMkLst>
         </pc:graphicFrameChg>
       </pc:sldChg>
-      <pc:sldChg chg="addSp delSp modSp new del mod ord setBg addAnim delAnim delDesignElem">
-        <pc:chgData name="Hadia Akbar" userId="19362115565_tp_box_2" providerId="OAuth2" clId="{FF77DECD-7ECC-48F4-BF82-9D4D4E0BE774}" dt="2026-08-24T23:07:33.993" v="2248" actId="47"/>
-        <pc:sldMkLst>
-          <pc:docMk/>
-          <pc:sldMk cId="1480586688" sldId="260"/>
-        </pc:sldMkLst>
-        <pc:picChg chg="add mod">
-          <ac:chgData name="Hadia Akbar" userId="19362115565_tp_box_2" providerId="OAuth2" clId="{FF77DECD-7ECC-48F4-BF82-9D4D4E0BE774}" dt="2026-08-24T23:06:30.886" v="2222" actId="1076"/>
-          <ac:picMkLst>
-            <pc:docMk/>
-            <pc:sldMk cId="1480586688" sldId="260"/>
-            <ac:picMk id="4" creationId="{24E79CC9-78C3-BC1B-D785-D9BBED37350E}"/>
-          </ac:picMkLst>
-        </pc:picChg>
-        <pc:picChg chg="add del mod">
-          <ac:chgData name="Hadia Akbar" userId="19362115565_tp_box_2" providerId="OAuth2" clId="{FF77DECD-7ECC-48F4-BF82-9D4D4E0BE774}" dt="2026-08-24T23:06:40.223" v="2223" actId="21"/>
-          <ac:picMkLst>
-            <pc:docMk/>
-            <pc:sldMk cId="1480586688" sldId="260"/>
-            <ac:picMk id="18" creationId="{E9E2FD9A-CEC4-149A-7AA0-B9A9435CC662}"/>
-          </ac:picMkLst>
-        </pc:picChg>
-      </pc:sldChg>
-      <pc:sldChg chg="addSp delSp modSp new add del mod ord setBg">
-        <pc:chgData name="Hadia Akbar" userId="19362115565_tp_box_2" providerId="OAuth2" clId="{FF77DECD-7ECC-48F4-BF82-9D4D4E0BE774}" dt="2026-08-24T23:18:46.875" v="2461" actId="47"/>
-        <pc:sldMkLst>
-          <pc:docMk/>
-          <pc:sldMk cId="1860897597" sldId="262"/>
-        </pc:sldMkLst>
-        <pc:spChg chg="add mod">
-          <ac:chgData name="Hadia Akbar" userId="19362115565_tp_box_2" providerId="OAuth2" clId="{FF77DECD-7ECC-48F4-BF82-9D4D4E0BE774}" dt="2026-08-24T23:16:46.312" v="2443" actId="21"/>
-          <ac:spMkLst>
-            <pc:docMk/>
-            <pc:sldMk cId="1860897597" sldId="262"/>
-            <ac:spMk id="4" creationId="{4A9A44C1-D39F-B823-D8E3-FD6C1DF75D70}"/>
-          </ac:spMkLst>
-        </pc:spChg>
-        <pc:graphicFrameChg chg="add del mod modGraphic">
-          <ac:chgData name="Hadia Akbar" userId="19362115565_tp_box_2" providerId="OAuth2" clId="{FF77DECD-7ECC-48F4-BF82-9D4D4E0BE774}" dt="2026-08-24T23:16:46.312" v="2443" actId="21"/>
-          <ac:graphicFrameMkLst>
-            <pc:docMk/>
-            <pc:sldMk cId="1860897597" sldId="262"/>
-            <ac:graphicFrameMk id="5" creationId="{7990CB0E-8803-D419-DBC6-4068A222A4E0}"/>
-          </ac:graphicFrameMkLst>
-        </pc:graphicFrameChg>
-      </pc:sldChg>
       <pc:sldChg chg="addSp delSp modSp new mod">
         <pc:chgData name="Hadia Akbar" userId="19362115565_tp_box_2" providerId="OAuth2" clId="{FF77DECD-7ECC-48F4-BF82-9D4D4E0BE774}" dt="2026-08-24T23:18:45.216" v="2459" actId="1076"/>
         <pc:sldMkLst>
@@ -333,13 +278,13 @@
         </pc:picChg>
       </pc:sldChg>
       <pc:sldChg chg="addSp modSp new mod ord">
-        <pc:chgData name="Hadia Akbar" userId="19362115565_tp_box_2" providerId="OAuth2" clId="{FF77DECD-7ECC-48F4-BF82-9D4D4E0BE774}" dt="2026-08-25T18:40:44.123" v="2533" actId="1076"/>
+        <pc:chgData name="Hadia Akbar" userId="19362115565_tp_box_2" providerId="OAuth2" clId="{FF77DECD-7ECC-48F4-BF82-9D4D4E0BE774}" dt="2026-08-28T18:07:09.575" v="2536" actId="20577"/>
         <pc:sldMkLst>
           <pc:docMk/>
           <pc:sldMk cId="1233494780" sldId="264"/>
         </pc:sldMkLst>
         <pc:spChg chg="add mod">
-          <ac:chgData name="Hadia Akbar" userId="19362115565_tp_box_2" providerId="OAuth2" clId="{FF77DECD-7ECC-48F4-BF82-9D4D4E0BE774}" dt="2026-08-25T18:40:44.123" v="2533" actId="1076"/>
+          <ac:chgData name="Hadia Akbar" userId="19362115565_tp_box_2" providerId="OAuth2" clId="{FF77DECD-7ECC-48F4-BF82-9D4D4E0BE774}" dt="2026-08-28T18:07:09.575" v="2536" actId="20577"/>
           <ac:spMkLst>
             <pc:docMk/>
             <pc:sldMk cId="1233494780" sldId="264"/>
@@ -385,22 +330,6 @@
           <pc:docMk/>
           <pc:sldMk cId="1077105498" sldId="265"/>
         </pc:sldMkLst>
-        <pc:spChg chg="del">
-          <ac:chgData name="Hadia Akbar" userId="19362115565_tp_box_2" providerId="OAuth2" clId="{FF77DECD-7ECC-48F4-BF82-9D4D4E0BE774}" dt="2026-08-24T23:17:09.879" v="2452" actId="478"/>
-          <ac:spMkLst>
-            <pc:docMk/>
-            <pc:sldMk cId="1077105498" sldId="265"/>
-            <ac:spMk id="2" creationId="{6812BC6F-D077-4E05-C130-3F2CC3DDECA7}"/>
-          </ac:spMkLst>
-        </pc:spChg>
-        <pc:spChg chg="del">
-          <ac:chgData name="Hadia Akbar" userId="19362115565_tp_box_2" providerId="OAuth2" clId="{FF77DECD-7ECC-48F4-BF82-9D4D4E0BE774}" dt="2026-08-24T23:17:11.632" v="2453" actId="478"/>
-          <ac:spMkLst>
-            <pc:docMk/>
-            <pc:sldMk cId="1077105498" sldId="265"/>
-            <ac:spMk id="3" creationId="{FF8C3D16-A4DC-80A1-9DB8-7698B9BEFF8A}"/>
-          </ac:spMkLst>
-        </pc:spChg>
         <pc:graphicFrameChg chg="add mod">
           <ac:chgData name="Hadia Akbar" userId="19362115565_tp_box_2" providerId="OAuth2" clId="{FF77DECD-7ECC-48F4-BF82-9D4D4E0BE774}" dt="2026-08-24T23:16:57.800" v="2447" actId="1076"/>
           <ac:graphicFrameMkLst>
@@ -8030,7 +7959,7 @@
           <a:p>
             <a:fld id="{23F5F05C-4C32-48D7-B5AA-52291E739591}" type="datetimeFigureOut">
               <a:rPr lang="en-US" smtClean="0"/>
-              <a:t>8/25/2026</a:t>
+              <a:t>8/28/2026</a:t>
             </a:fld>
             <a:endParaRPr lang="en-US"/>
           </a:p>
@@ -8672,7 +8601,7 @@
           <a:p>
             <a:fld id="{5518E2ED-ACDD-48AE-BEAE-F9B835E4D922}" type="datetimeFigureOut">
               <a:rPr lang="en-US" smtClean="0"/>
-              <a:t>8/25/2026</a:t>
+              <a:t>8/28/2026</a:t>
             </a:fld>
             <a:endParaRPr lang="en-US"/>
           </a:p>
@@ -8870,7 +8799,7 @@
           <a:p>
             <a:fld id="{5518E2ED-ACDD-48AE-BEAE-F9B835E4D922}" type="datetimeFigureOut">
               <a:rPr lang="en-US" smtClean="0"/>
-              <a:t>8/25/2026</a:t>
+              <a:t>8/28/2026</a:t>
             </a:fld>
             <a:endParaRPr lang="en-US"/>
           </a:p>
@@ -9078,7 +9007,7 @@
           <a:p>
             <a:fld id="{5518E2ED-ACDD-48AE-BEAE-F9B835E4D922}" type="datetimeFigureOut">
               <a:rPr lang="en-US" smtClean="0"/>
-              <a:t>8/25/2026</a:t>
+              <a:t>8/28/2026</a:t>
             </a:fld>
             <a:endParaRPr lang="en-US"/>
           </a:p>
@@ -9276,7 +9205,7 @@
           <a:p>
             <a:fld id="{5518E2ED-ACDD-48AE-BEAE-F9B835E4D922}" type="datetimeFigureOut">
               <a:rPr lang="en-US" smtClean="0"/>
-              <a:t>8/25/2026</a:t>
+              <a:t>8/28/2026</a:t>
             </a:fld>
             <a:endParaRPr lang="en-US"/>
           </a:p>
@@ -9551,7 +9480,7 @@
           <a:p>
             <a:fld id="{5518E2ED-ACDD-48AE-BEAE-F9B835E4D922}" type="datetimeFigureOut">
               <a:rPr lang="en-US" smtClean="0"/>
-              <a:t>8/25/2026</a:t>
+              <a:t>8/28/2026</a:t>
             </a:fld>
             <a:endParaRPr lang="en-US"/>
           </a:p>
@@ -9816,7 +9745,7 @@
           <a:p>
             <a:fld id="{5518E2ED-ACDD-48AE-BEAE-F9B835E4D922}" type="datetimeFigureOut">
               <a:rPr lang="en-US" smtClean="0"/>
-              <a:t>8/25/2026</a:t>
+              <a:t>8/28/2026</a:t>
             </a:fld>
             <a:endParaRPr lang="en-US"/>
           </a:p>
@@ -10228,7 +10157,7 @@
           <a:p>
             <a:fld id="{5518E2ED-ACDD-48AE-BEAE-F9B835E4D922}" type="datetimeFigureOut">
               <a:rPr lang="en-US" smtClean="0"/>
-              <a:t>8/25/2026</a:t>
+              <a:t>8/28/2026</a:t>
             </a:fld>
             <a:endParaRPr lang="en-US"/>
           </a:p>
@@ -10369,7 +10298,7 @@
           <a:p>
             <a:fld id="{5518E2ED-ACDD-48AE-BEAE-F9B835E4D922}" type="datetimeFigureOut">
               <a:rPr lang="en-US" smtClean="0"/>
-              <a:t>8/25/2026</a:t>
+              <a:t>8/28/2026</a:t>
             </a:fld>
             <a:endParaRPr lang="en-US"/>
           </a:p>
@@ -10482,7 +10411,7 @@
           <a:p>
             <a:fld id="{5518E2ED-ACDD-48AE-BEAE-F9B835E4D922}" type="datetimeFigureOut">
               <a:rPr lang="en-US" smtClean="0"/>
-              <a:t>8/25/2026</a:t>
+              <a:t>8/28/2026</a:t>
             </a:fld>
             <a:endParaRPr lang="en-US"/>
           </a:p>
@@ -10793,7 +10722,7 @@
           <a:p>
             <a:fld id="{5518E2ED-ACDD-48AE-BEAE-F9B835E4D922}" type="datetimeFigureOut">
               <a:rPr lang="en-US" smtClean="0"/>
-              <a:t>8/25/2026</a:t>
+              <a:t>8/28/2026</a:t>
             </a:fld>
             <a:endParaRPr lang="en-US"/>
           </a:p>
@@ -11081,7 +11010,7 @@
           <a:p>
             <a:fld id="{5518E2ED-ACDD-48AE-BEAE-F9B835E4D922}" type="datetimeFigureOut">
               <a:rPr lang="en-US" smtClean="0"/>
-              <a:t>8/25/2026</a:t>
+              <a:t>8/28/2026</a:t>
             </a:fld>
             <a:endParaRPr lang="en-US"/>
           </a:p>
@@ -11322,7 +11251,7 @@
           <a:p>
             <a:fld id="{5518E2ED-ACDD-48AE-BEAE-F9B835E4D922}" type="datetimeFigureOut">
               <a:rPr lang="en-US" smtClean="0"/>
-              <a:t>8/25/2026</a:t>
+              <a:t>8/28/2026</a:t>
             </a:fld>
             <a:endParaRPr lang="en-US"/>
           </a:p>
@@ -12471,7 +12400,21 @@
                 <a:effectLst/>
                 <a:latin typeface="+mn-lt"/>
               </a:rPr>
-              <a:t> of sustained additional inflow per year needed to return the lake to healthy levels (4,198 feet) by 2025</a:t>
+              <a:t> of sustained additional inflow per year needed to return the lake to healthy levels (</a:t>
+            </a:r>
+            <a:r>
+              <a:rPr lang="en-US" sz="2800" b="0" i="0">
+                <a:solidFill>
+                  <a:schemeClr val="tx1"/>
+                </a:solidFill>
+                <a:effectLst/>
+                <a:latin typeface="+mn-lt"/>
+              </a:rPr>
+              <a:t>4,198 feet</a:t>
+            </a:r>
+            <a:r>
+              <a:rPr lang="en-US" sz="2800"/>
+              <a:t>)</a:t>
             </a:r>
             <a:endParaRPr lang="en-US" sz="2800" dirty="0"/>
           </a:p>

</xml_diff>